<commit_message>
Retitle to "Feel Before You Build"; drop lecture dependencies; strip em-dashes
Three fixes:

1. "Actuator Petting Zoo" was an English idiom that did not read clearly.
   Now "Feel Before You Build", which says what the session is for.

2. The workshop is Lecture 5, the prototyping workshop, which runs BEFORE
   Actuators rather than after it. The old copy assumed students had already
   had Actuators, Auditory and Designing Multimodal Feedback, none of which
   they have. All forward references removed; the session now needs no prior
   theory. "Tacton" replaced with "signal" and "roughness" with "strength",
   since that vocabulary arrives later in the course.

3. Em-dashes removed from all prose across deck, notes, README, sketches and
   session plan.

Also fixed the deck build to run from inside the repo (asset and output paths
pointed at a scratchpad).

Claude-Session: https://claude.ai/code/session_017zoLSxpHdmuqsaMfQZ6vfx
</commit_message>
<xml_diff>
--- a/docs/multimodal-actuator-workshop.pptx
+++ b/docs/multimodal-actuator-workshop.pptx
@@ -520,7 +520,7 @@
           <a:lstStyle/>
           <a:p>
             <a:r>
-              <a:t>0:00 — Start here. Don't read the slide.</a:t>
+              <a:t>0:00. Start here. Don't read the slide.</a:t>
             </a:r>
           </a:p>
           <a:p/>
@@ -726,18 +726,18 @@
           <a:lstStyle/>
           <a:p>
             <a:r>
-              <a:t>Thermal. The lecture said people are bad at thermal patterns — this is</a:t>
-            </a:r>
-          </a:p>
-          <a:p>
-            <a:r>
-              <a:t>where they feel why.</a:t>
+              <a:t>Thermal. People are bad at reading thermal patterns, and this is</a:t>
+            </a:r>
+          </a:p>
+          <a:p>
+            <a:r>
+              <a:t>where they find that out for themselves.</a:t>
             </a:r>
           </a:p>
           <a:p/>
           <a:p>
             <a:r>
-              <a:t>Make them time themselves. The 3-8 second onset kills a lot of bad project</a:t>
+              <a:t>Make them time themselves. The 3 to 8 second onset kills a lot of bad project</a:t>
             </a:r>
           </a:p>
           <a:p>
@@ -747,7 +747,7 @@
           </a:p>
           <a:p>
             <a:r>
-              <a:t>rather than in week 47.</a:t>
+              <a:t>rather than in week 46.</a:t>
             </a:r>
           </a:p>
           <a:p/>
@@ -823,7 +823,7 @@
           <a:lstStyle/>
           <a:p>
             <a:r>
-              <a:t>Redundancy, made physical. Same driver, two frequencies — one you feel,</a:t>
+              <a:t>Redundancy, made physical. Same driver, two frequencies: one you feel,</a:t>
             </a:r>
           </a:p>
           <a:p>
@@ -839,12 +839,12 @@
           </a:p>
           <a:p>
             <a:r>
-              <a:t>That's crossmodal redundancy from Lecture 7 and it's the cheapest reliability</a:t>
-            </a:r>
-          </a:p>
-          <a:p>
-            <a:r>
-              <a:t>win available to their projects.</a:t>
+              <a:t>Sending the same thing down two channels is the cheapest reliability their</a:t>
+            </a:r>
+          </a:p>
+          <a:p>
+            <a:r>
+              <a:t>projects can buy.</a:t>
             </a:r>
           </a:p>
           <a:p/>
@@ -920,7 +920,7 @@
           <a:lstStyle/>
           <a:p>
             <a:r>
-              <a:t>1:10 — Rotation over. Round-the-room now.</a:t>
+              <a:t>1:10. Rotation over. Round-the-room now.</a:t>
             </a:r>
           </a:p>
           <a:p/>
@@ -932,7 +932,7 @@
           <a:p/>
           <a:p>
             <a:r>
-              <a:t>Expect the thermal group to report the delay. Let that land — it's more</a:t>
+              <a:t>Expect the thermal group to report the delay. Let that land, it is more</a:t>
             </a:r>
           </a:p>
           <a:p>
@@ -1201,7 +1201,7 @@
           <a:lstStyle/>
           <a:p>
             <a:r>
-              <a:t>1:20 — Build starts. Thirty minutes.</a:t>
+              <a:t>1:20. Build starts. Thirty minutes.</a:t>
             </a:r>
           </a:p>
           <a:p/>
@@ -1212,7 +1212,7 @@
           </a:p>
           <a:p>
             <a:r>
-              <a:t>because they're simplest — that's fine, the constraint does the work.</a:t>
+              <a:t>because they are simplest. That is fine, the constraint does the work.</a:t>
             </a:r>
           </a:p>
         </p:txBody>
@@ -1288,12 +1288,12 @@
           <a:p/>
           <a:p>
             <a:r>
-              <a:t>Rhythm and roughness only. If someone asks to add a second actuator, say no —</a:t>
-            </a:r>
-          </a:p>
-          <a:p>
-            <a:r>
-              <a:t>the constraint IS the exercise. Encoding within one channel is the skill.</a:t>
+              <a:t>Rhythm and strength only. If someone asks to add a second actuator, say no.</a:t>
+            </a:r>
+          </a:p>
+          <a:p>
+            <a:r>
+              <a:t>The constraint is the exercise. Encoding within one channel is the skill.</a:t>
             </a:r>
           </a:p>
           <a:p/>
@@ -1380,7 +1380,7 @@
           <a:p/>
           <a:p>
             <a:r>
-              <a:t>1:50 — Blind test. Swap groups, receiver looks away, guess all three.</a:t>
+              <a:t>1:50. Blind test. Swap groups, receiver looks away, guess all three.</a:t>
             </a:r>
           </a:p>
           <a:p/>
@@ -1564,19 +1564,25 @@
           </a:p>
           <a:p>
             <a:r>
-              <a:t>speaker, and haptics gets designed on paper then dropped.</a:t>
+              <a:t>speaker, and touch gets designed on paper then dropped.</a:t>
             </a:r>
           </a:p>
           <a:p/>
           <a:p>
             <a:r>
-              <a:t>Not because it was wrong. Because nobody had touched the parts.</a:t>
+              <a:t>Not because it was wrong. Because nobody had held the parts.</a:t>
             </a:r>
           </a:p>
           <a:p/>
           <a:p>
             <a:r>
-              <a:t>Keep this short — 2 minutes. They came to do things, not hear framing.</a:t>
+              <a:t>They get the Actuators lecture tomorrow. Today is the hands, not the theory.</a:t>
+            </a:r>
+          </a:p>
+          <a:p/>
+          <a:p>
+            <a:r>
+              <a:t>Keep this short, 2 minutes. They came to do things, not hear framing.</a:t>
             </a:r>
           </a:p>
         </p:txBody>
@@ -1663,12 +1669,12 @@
           <a:p/>
           <a:p>
             <a:r>
-              <a:t>Say out loud: the timer is hard. Ten minutes means ten minutes. Bench 3 (the</a:t>
-            </a:r>
-          </a:p>
-          <a:p>
-            <a:r>
-              <a:t>solenoid) is the one people won't want to leave.</a:t>
+              <a:t>Say out loud: the timer is hard. Ten minutes means ten minutes. Bench 3, the</a:t>
+            </a:r>
+          </a:p>
+          <a:p>
+            <a:r>
+              <a:t>solenoid, is the one people will not want to leave.</a:t>
             </a:r>
           </a:p>
         </p:txBody>
@@ -1830,7 +1836,7 @@
           <a:lstStyle/>
           <a:p>
             <a:r>
-              <a:t>0:10 — Rotation starts. Set a visible timer.</a:t>
+              <a:t>0:10. Rotation starts. Set a visible timer.</a:t>
             </a:r>
           </a:p>
           <a:p/>
@@ -1841,7 +1847,7 @@
           </a:p>
           <a:p>
             <a:r>
-              <a:t>minutes. Circulate, but don't rescue — let them poke at things.</a:t>
+              <a:t>minutes. Circulate, but do not rescue. Let them poke at things.</a:t>
             </a:r>
           </a:p>
           <a:p/>
@@ -1927,12 +1933,12 @@
           <a:lstStyle/>
           <a:p>
             <a:r>
-              <a:t>ERM. The lecture point made physical: frequency and amplitude are</a:t>
-            </a:r>
-          </a:p>
-          <a:p>
-            <a:r>
-              <a:t>mechanically linked. You cannot get gentle-but-fast.</a:t>
+              <a:t>The core limitation, made physical: speed and strength are mechanically</a:t>
+            </a:r>
+          </a:p>
+          <a:p>
+            <a:r>
+              <a:t>linked on this motor. You cannot get gentle-but-fast.</a:t>
             </a:r>
           </a:p>
           <a:p/>
@@ -1943,13 +1949,13 @@
           </a:p>
           <a:p>
             <a:r>
-              <a:t>can't overcome its own friction. That floor is real and worth naming.</a:t>
+              <a:t>cannot overcome its own friction. That floor is real and worth naming.</a:t>
             </a:r>
           </a:p>
           <a:p/>
           <a:p>
             <a:r>
-              <a:t>Never let anyone rewire this to a bare pin — 40 mA limit, motor pulls 75.</a:t>
+              <a:t>Never let anyone rewire this to a bare pin. 40 mA limit, motor pulls 75.</a:t>
             </a:r>
           </a:p>
         </p:txBody>
@@ -2030,7 +2036,7 @@
           <a:p/>
           <a:p>
             <a:r>
-              <a:t>If the LRA sounds wrong, the DRV2605L is in ERM mode — it must be told which</a:t>
+              <a:t>If the LRA sounds wrong, the DRV2605L is in ERM mode. It must be told which</a:t>
             </a:r>
           </a:p>
           <a:p>
@@ -2116,23 +2122,28 @@
           <a:lstStyle/>
           <a:p>
             <a:r>
-              <a:t>The memorable one. A knock reads as a person tapping you — indexical,</a:t>
-            </a:r>
-          </a:p>
-          <a:p>
-            <a:r>
-              <a:t>not symbolic, straight from Lecture 7's semiotics.</a:t>
+              <a:t>The memorable one. A single knock reads as a person tapping you</a:t>
+            </a:r>
+          </a:p>
+          <a:p>
+            <a:r>
+              <a:t>rather than a machine signalling. Worth naming out loud, because it is the</a:t>
+            </a:r>
+          </a:p>
+          <a:p>
+            <a:r>
+              <a:t>whole reason it feels different.</a:t>
             </a:r>
           </a:p>
           <a:p/>
           <a:p>
             <a:r>
-              <a:t>Watch the duty cycle. Solenoids get hot fast; if it's been hammering for ten</a:t>
-            </a:r>
-          </a:p>
-          <a:p>
-            <a:r>
-              <a:t>minutes, let it rest.</a:t>
+              <a:t>Watch the duty cycle. Solenoids get hot fast, so if it has been hammering for</a:t>
+            </a:r>
+          </a:p>
+          <a:p>
+            <a:r>
+              <a:t>ten minutes, let it rest.</a:t>
             </a:r>
           </a:p>
           <a:p/>
@@ -2213,7 +2224,7 @@
           <a:lstStyle/>
           <a:p>
             <a:r>
-              <a:t>The surprise bench. No breakout board — the input is a wire.</a:t>
+              <a:t>The surprise bench. No breakout board. The input is a wire.</a:t>
             </a:r>
           </a:p>
           <a:p/>
@@ -5286,7 +5297,7 @@
                 </a:solidFill>
                 <a:latin typeface="Arial"/>
               </a:rPr>
-              <a:t>THE ACTUATOR PETTING ZOO</a:t>
+              <a:t>FEEL BEFORE YOU BUILD</a:t>
             </a:r>
           </a:p>
         </p:txBody>
@@ -5328,7 +5339,7 @@
                 </a:solidFill>
                 <a:latin typeface="Arial"/>
               </a:rPr>
-              <a:t>Hands-on multimodal prototyping  ·  Week 39 lab  ·  2 hours</a:t>
+              <a:t>Hands-on prototyping with actuators  ·  2 hours</a:t>
             </a:r>
           </a:p>
         </p:txBody>
@@ -5437,7 +5448,7 @@
                 </a:solidFill>
                 <a:latin typeface="Arial"/>
               </a:rPr>
-              <a:t>WEEK 39 LAB</a:t>
+              <a:t>PROTOTYPING WORKSHOP</a:t>
             </a:r>
           </a:p>
         </p:txBody>
@@ -5566,7 +5577,7 @@
                 </a:solidFill>
                 <a:latin typeface="Arial"/>
               </a:rPr>
-              <a:t>BENCH 04 — THE WHOLE TRICK</a:t>
+              <a:t>BENCH 04: THE WHOLE TRICK</a:t>
             </a:r>
           </a:p>
         </p:txBody>
@@ -5652,7 +5663,7 @@
                 </a:solidFill>
                 <a:latin typeface="Arial"/>
               </a:rPr>
-              <a:t>Capacitive sensing costs a wire. What it does not cost you is thinking.</a:t>
+              <a:t>Touch input for the price of a wire. The thinking is where it costs you.</a:t>
             </a:r>
           </a:p>
         </p:txBody>
@@ -5742,7 +5753,7 @@
                 </a:solidFill>
                 <a:latin typeface="Arial"/>
               </a:rPr>
-              <a:t>• Readings drift with humidity, mains hum, how you are sitting. A fixed threshold works in the morning and fails after lunch.</a:t>
+              <a:t>• Readings drift with humidity, with mains hum, with how you are sitting. A fixed threshold works in the morning and fails after lunch.</a:t>
             </a:r>
           </a:p>
           <a:p>
@@ -5790,7 +5801,7 @@
                 </a:solidFill>
                 <a:latin typeface="Arial"/>
               </a:rPr>
-              <a:t>• Otherwise a long press slowly teaches it that a finger is normal, and the touch silently stops registering.</a:t>
+              <a:t>• Otherwise a long press slowly teaches it that a finger is normal, and the touch quietly stops registering.</a:t>
             </a:r>
           </a:p>
         </p:txBody>
@@ -5899,7 +5910,7 @@
                 </a:solidFill>
                 <a:latin typeface="Arial"/>
               </a:rPr>
-              <a:t>WEEK 39 LAB</a:t>
+              <a:t>PROTOTYPING WORKSHOP</a:t>
             </a:r>
           </a:p>
         </p:txBody>
@@ -6028,7 +6039,7 @@
                 </a:solidFill>
                 <a:latin typeface="Arial"/>
               </a:rPr>
-              <a:t>05 — PELTIER WARM / COOL</a:t>
+              <a:t>05   PELTIER WARM / COOL</a:t>
             </a:r>
           </a:p>
         </p:txBody>
@@ -6194,7 +6205,7 @@
                 </a:solidFill>
                 <a:latin typeface="Arial"/>
               </a:rPr>
-              <a:t>The lecture's warning holds up in person — alternating hot and cold just reads as lukewarm.</a:t>
+              <a:t>And alternating hot with cold does not read as a pattern. It just reads as lukewarm.</a:t>
             </a:r>
           </a:p>
         </p:txBody>
@@ -6501,7 +6512,7 @@
                 </a:solidFill>
                 <a:latin typeface="Arial"/>
               </a:rPr>
-              <a:t>WEEK 39 LAB</a:t>
+              <a:t>PROTOTYPING WORKSHOP</a:t>
             </a:r>
           </a:p>
         </p:txBody>
@@ -6630,7 +6641,7 @@
                 </a:solidFill>
                 <a:latin typeface="Arial"/>
               </a:rPr>
-              <a:t>06 — THE SAME SIGNAL, TWICE</a:t>
+              <a:t>06   THE SAME SIGNAL, TWICE</a:t>
             </a:r>
           </a:p>
         </p:txBody>
@@ -6758,7 +6769,7 @@
                 </a:solidFill>
                 <a:latin typeface="Arial"/>
               </a:rPr>
-              <a:t>One transducer on a plate, playing 40 Hz you feel and 400 Hz you hear — from the same driver.</a:t>
+              <a:t>One transducer on a plate, playing 40 Hz you feel and 400 Hz you hear, both from the same driver.</a:t>
             </a:r>
           </a:p>
           <a:p>
@@ -6796,7 +6807,7 @@
                 </a:solidFill>
                 <a:latin typeface="Arial"/>
               </a:rPr>
-              <a:t>Together is not louder. It is more CERTAIN. That is redundancy from Lecture 7, and the cheapest reliability win your project can get.</a:t>
+              <a:t>Together is not louder. It is more certain. Sending the same thing down two channels is the cheapest reliability your project can buy.</a:t>
             </a:r>
           </a:p>
         </p:txBody>
@@ -6857,7 +6868,7 @@
                 </a:solidFill>
                 <a:latin typeface="Arial"/>
               </a:rPr>
-              <a:t>With ear defenders on, does the tacton still work?</a:t>
+              <a:t>With ear defenders on, does the signal still work?</a:t>
             </a:r>
           </a:p>
         </p:txBody>
@@ -7103,7 +7114,7 @@
                 </a:solidFill>
                 <a:latin typeface="Arial"/>
               </a:rPr>
-              <a:t>WEEK 39 LAB</a:t>
+              <a:t>PROTOTYPING WORKSHOP</a:t>
             </a:r>
           </a:p>
         </p:txBody>
@@ -7385,7 +7396,7 @@
                 </a:solidFill>
                 <a:latin typeface="Arial"/>
               </a:rPr>
-              <a:t>WEEK 39 LAB</a:t>
+              <a:t>PROTOTYPING WORKSHOP</a:t>
             </a:r>
           </a:p>
         </p:txBody>
@@ -7642,7 +7653,7 @@
                 </a:solidFill>
                 <a:latin typeface="Arial"/>
               </a:rPr>
-              <a:t>• Capacitive touch — a wire on an analogue pin. See bench 04.</a:t>
+              <a:t>• Capacitive touch. A wire on an analogue pin. See bench 04.</a:t>
             </a:r>
           </a:p>
           <a:p>
@@ -7661,7 +7672,7 @@
                 </a:solidFill>
                 <a:latin typeface="Arial"/>
               </a:rPr>
-              <a:t>• Heart rate (PPG) — steady at rest, garbage the moment the hand moves.</a:t>
+              <a:t>• Heart rate (PPG). Steady at rest, useless once the hand moves.</a:t>
             </a:r>
           </a:p>
           <a:p>
@@ -7680,7 +7691,7 @@
                 </a:solidFill>
                 <a:latin typeface="Arial"/>
               </a:rPr>
-              <a:t>• GSR — arousal, but it drifts. Relative change only, never absolute.</a:t>
+              <a:t>• Skin conductance (GSR). Drifts constantly, so relative change only.</a:t>
             </a:r>
           </a:p>
           <a:p>
@@ -7699,7 +7710,7 @@
                 </a:solidFill>
                 <a:latin typeface="Arial"/>
               </a:rPr>
-              <a:t>• Flex sensor — the cheap route to a data glove.</a:t>
+              <a:t>• Flex sensor. The cheap route to a data glove.</a:t>
             </a:r>
           </a:p>
           <a:p>
@@ -7718,7 +7729,7 @@
                 </a:solidFill>
                 <a:latin typeface="Arial"/>
               </a:rPr>
-              <a:t>• Pressure (FSR) — how hard, not just whether. Calibrate per pad.</a:t>
+              <a:t>• Pressure (FSR). How hard, not just whether. Calibrate each pad.</a:t>
             </a:r>
           </a:p>
           <a:p>
@@ -7737,7 +7748,7 @@
                 </a:solidFill>
                 <a:latin typeface="Arial"/>
               </a:rPr>
-              <a:t>• Your own phone — accelerometer, gyro, mic, camera, vibration. No soldering at all.</a:t>
+              <a:t>• Your own phone. Accelerometer, gyro, mic, camera, vibration motor. No soldering at all.</a:t>
             </a:r>
           </a:p>
         </p:txBody>
@@ -7846,7 +7857,7 @@
                 </a:solidFill>
                 <a:latin typeface="Arial"/>
               </a:rPr>
-              <a:t>WEEK 39 LAB</a:t>
+              <a:t>PROTOTYPING WORKSHOP</a:t>
             </a:r>
           </a:p>
         </p:txBody>
@@ -8103,7 +8114,7 @@
                 </a:solidFill>
                 <a:latin typeface="Arial"/>
               </a:rPr>
-              <a:t>Capacitive sensing + servos + actuators — SOS 2025, Arduino Uno</a:t>
+              <a:t>Capacitive sensing, servos and actuators (Arduino Uno)</a:t>
             </a:r>
           </a:p>
           <a:p>
@@ -8122,7 +8133,7 @@
                 </a:solidFill>
                 <a:latin typeface="Arial"/>
               </a:rPr>
-              <a:t>• A moving screen that breathes when idle and retreats when touched. 922 lines, plus a browser control panel over serial.</a:t>
+              <a:t>• A moving screen that breathes when idle and retreats when you touch it, with a browser control panel over the serial port.</a:t>
             </a:r>
           </a:p>
           <a:p>
@@ -8170,7 +8181,7 @@
                 </a:solidFill>
                 <a:latin typeface="Arial"/>
               </a:rPr>
-              <a:t>Instrumented sock — bachelor project, ESP32</a:t>
+              <a:t>Instrumented sock (ESP32, bachelor project)</a:t>
             </a:r>
           </a:p>
           <a:p>
@@ -8189,7 +8200,7 @@
                 </a:solidFill>
                 <a:latin typeface="Arial"/>
               </a:rPr>
-              <a:t>• Six force sensors under a foot, batched to a server over Wi-Fi, each with its own calibration constants.</a:t>
+              <a:t>• Six force sensors under a foot, sent to a server over Wi-Fi in batches, each with its own calibration constants.</a:t>
             </a:r>
           </a:p>
           <a:p>
@@ -8317,7 +8328,7 @@
                 </a:solidFill>
                 <a:latin typeface="Arial"/>
               </a:rPr>
-              <a:t>WEEK 39 LAB</a:t>
+              <a:t>PROTOTYPING WORKSHOP</a:t>
             </a:r>
           </a:p>
         </p:txBody>
@@ -8490,7 +8501,7 @@
                 </a:solidFill>
                 <a:latin typeface="Arial"/>
               </a:rPr>
-              <a:t>BUILD ONE TACTON</a:t>
+              <a:t>BUILD ONE SIGNAL</a:t>
             </a:r>
           </a:p>
         </p:txBody>
@@ -8599,7 +8610,7 @@
                 </a:solidFill>
                 <a:latin typeface="Arial"/>
               </a:rPr>
-              <a:t>WEEK 39 LAB</a:t>
+              <a:t>PROTOTYPING WORKSHOP</a:t>
             </a:r>
           </a:p>
         </p:txBody>
@@ -8875,7 +8886,7 @@
                 </a:solidFill>
                 <a:latin typeface="Arial"/>
               </a:rPr>
-              <a:t>Encode three messages: arrived / something wrong / finished.</a:t>
+              <a:t>Encode three messages: arrived, something wrong, finished.</a:t>
             </a:r>
           </a:p>
           <a:p>
@@ -8894,7 +8905,7 @@
                 </a:solidFill>
                 <a:latin typeface="Arial"/>
               </a:rPr>
-              <a:t>Vary RHYTHM and ROUGHNESS only — the Lecture 7 tacton parameters. No swapping actuators between messages.</a:t>
+              <a:t>Vary only two things: the RHYTHM of the pulses, and how STRONG they are. No swapping actuators between messages.</a:t>
             </a:r>
           </a:p>
           <a:p>
@@ -8913,7 +8924,7 @@
                 </a:solidFill>
                 <a:latin typeface="Arial"/>
               </a:rPr>
-              <a:t>Hand it to another group with the display turned away. They name all three.</a:t>
+              <a:t>Hand it to another group with the screen turned away. They name all three.</a:t>
             </a:r>
           </a:p>
           <a:p>
@@ -9041,7 +9052,7 @@
                 </a:solidFill>
                 <a:latin typeface="Arial"/>
               </a:rPr>
-              <a:t>WEEK 39 LAB</a:t>
+              <a:t>PROTOTYPING WORKSHOP</a:t>
             </a:r>
           </a:p>
         </p:txBody>
@@ -9394,7 +9405,7 @@
                 </a:solidFill>
                 <a:latin typeface="Arial"/>
               </a:rPr>
-              <a:t>WEEK 39 LAB</a:t>
+              <a:t>PROTOTYPING WORKSHOP</a:t>
             </a:r>
           </a:p>
         </p:txBody>
@@ -9674,7 +9685,7 @@
                 </a:solidFill>
                 <a:latin typeface="Arial"/>
               </a:rPr>
-              <a:t>WEEK 39 LAB</a:t>
+              <a:t>PROTOTYPING WORKSHOP</a:t>
             </a:r>
           </a:p>
         </p:txBody>
@@ -9889,7 +9900,7 @@
                 </a:solidFill>
                 <a:latin typeface="Arial"/>
               </a:rPr>
-              <a:t>You have had the actuator lecture. You know what an ERM is on a slide.</a:t>
+              <a:t>You can read a datasheet. You have never held one of these.</a:t>
             </a:r>
           </a:p>
         </p:txBody>
@@ -9931,7 +9942,7 @@
                 </a:solidFill>
                 <a:latin typeface="Arial"/>
               </a:rPr>
-              <a:t>Today you put one against your own wrist, decide it feels cheap, and pick something else — before you commit a project to it.</a:t>
+              <a:t>Today you put a vibration motor against your own wrist, decide it feels cheap, and pick something else. Better now than in week 46.</a:t>
             </a:r>
           </a:p>
           <a:p>
@@ -9960,7 +9971,7 @@
                 </a:solidFill>
                 <a:latin typeface="Arial"/>
               </a:rPr>
-              <a:t>Every year projects arrive at the mid-way pitch built entirely on the screen and the speaker.</a:t>
+              <a:t>Every year, projects end up built entirely on the screen and the speaker.</a:t>
             </a:r>
           </a:p>
           <a:p>
@@ -9979,7 +9990,7 @@
                 </a:solidFill>
                 <a:latin typeface="Arial"/>
               </a:rPr>
-              <a:t>Not because haptics was the wrong choice — because nobody knew a coin motor costs 12 kr and takes two wires.</a:t>
+              <a:t>Not because touch was the wrong choice. Because nobody knew that a coin motor costs 12 kr and takes two wires.</a:t>
             </a:r>
           </a:p>
         </p:txBody>
@@ -10088,7 +10099,7 @@
                 </a:solidFill>
                 <a:latin typeface="Arial"/>
               </a:rPr>
-              <a:t>WEEK 39 LAB</a:t>
+              <a:t>PROTOTYPING WORKSHOP</a:t>
             </a:r>
           </a:p>
         </p:txBody>
@@ -10360,7 +10371,7 @@
                 </a:solidFill>
                 <a:latin typeface="Arial"/>
               </a:rPr>
-              <a:t>• You wire nothing — that is what the project weeks are for.</a:t>
+              <a:t>• You wire nothing. That is what the project weeks are for.</a:t>
             </a:r>
           </a:p>
           <a:p>
@@ -10389,7 +10400,7 @@
                 </a:solidFill>
                 <a:latin typeface="Arial"/>
               </a:rPr>
-              <a:t>Then you build one tacton and someone else tries to read it.</a:t>
+              <a:t>Then you build one signal and someone else tries to read it.</a:t>
             </a:r>
           </a:p>
         </p:txBody>
@@ -10498,7 +10509,7 @@
                 </a:solidFill>
                 <a:latin typeface="Arial"/>
               </a:rPr>
-              <a:t>WEEK 39 LAB</a:t>
+              <a:t>PROTOTYPING WORKSHOP</a:t>
             </a:r>
           </a:p>
         </p:txBody>
@@ -10713,7 +10724,7 @@
                 </a:solidFill>
                 <a:latin typeface="Arial"/>
               </a:rPr>
-              <a:t>Times are offsets from the start. The rotation is the spine — keep it moving.</a:t>
+              <a:t>Times are offsets from the start. The rotation is the spine of it, so keep it moving.</a:t>
             </a:r>
           </a:p>
         </p:txBody>
@@ -10839,7 +10850,7 @@
                 </a:solidFill>
                 <a:latin typeface="Arial"/>
               </a:rPr>
-              <a:t>Framing, and a demo that fails</a:t>
+              <a:t>Two motors, same message. Which felt urgent?</a:t>
             </a:r>
           </a:p>
         </p:txBody>
@@ -10965,7 +10976,7 @@
                 </a:solidFill>
                 <a:latin typeface="Arial"/>
               </a:rPr>
-              <a:t>Bench rotation — 10 minutes each</a:t>
+              <a:t>Bench rotation, 10 minutes each</a:t>
             </a:r>
           </a:p>
         </p:txBody>
@@ -11217,7 +11228,7 @@
                 </a:solidFill>
                 <a:latin typeface="Arial"/>
               </a:rPr>
-              <a:t>Build one tacton</a:t>
+              <a:t>Build one signal</a:t>
             </a:r>
           </a:p>
         </p:txBody>
@@ -11452,7 +11463,7 @@
                 </a:solidFill>
                 <a:latin typeface="Arial"/>
               </a:rPr>
-              <a:t>WEEK 39 LAB</a:t>
+              <a:t>PROTOTYPING WORKSHOP</a:t>
             </a:r>
           </a:p>
         </p:txBody>
@@ -11734,7 +11745,7 @@
                 </a:solidFill>
                 <a:latin typeface="Arial"/>
               </a:rPr>
-              <a:t>WEEK 39 LAB</a:t>
+              <a:t>PROTOTYPING WORKSHOP</a:t>
             </a:r>
           </a:p>
         </p:txBody>
@@ -11863,7 +11874,7 @@
                 </a:solidFill>
                 <a:latin typeface="Arial"/>
               </a:rPr>
-              <a:t>01 — ERM COIN MOTOR</a:t>
+              <a:t>01   ERM COIN MOTOR</a:t>
             </a:r>
           </a:p>
         </p:txBody>
@@ -11991,7 +12002,7 @@
                 </a:solidFill>
                 <a:latin typeface="Arial"/>
               </a:rPr>
-              <a:t>The eccentric rotating mass from Lecture 6. The same part that is in your phone and every game controller.</a:t>
+              <a:t>An off-centre weight on a motor shaft. The same part that is in your phone and every game controller.</a:t>
             </a:r>
           </a:p>
           <a:p>
@@ -12010,7 +12021,7 @@
                 </a:solidFill>
                 <a:latin typeface="Arial"/>
               </a:rPr>
-              <a:t>Turn the pot and notice what you cannot do: frequency and amplitude are mechanically welded together. "Gentle but fast" is not available to you.</a:t>
+              <a:t>Turn the knob and notice what you cannot do. Speed and strength are mechanically welded together, so "gentle but fast" is not available to you.</a:t>
             </a:r>
           </a:p>
         </p:txBody>
@@ -12317,7 +12328,7 @@
                 </a:solidFill>
                 <a:latin typeface="Arial"/>
               </a:rPr>
-              <a:t>WEEK 39 LAB</a:t>
+              <a:t>PROTOTYPING WORKSHOP</a:t>
             </a:r>
           </a:p>
         </p:txBody>
@@ -12446,7 +12457,7 @@
                 </a:solidFill>
                 <a:latin typeface="Arial"/>
               </a:rPr>
-              <a:t>02 — LRA + PIEZO DISC</a:t>
+              <a:t>02   LRA + PIEZO DISC</a:t>
             </a:r>
           </a:p>
         </p:txBody>
@@ -12593,7 +12604,7 @@
                 </a:solidFill>
                 <a:latin typeface="Arial"/>
               </a:rPr>
-              <a:t>The LRA hits resonance in ~5 ms and stops just as fast — which is why phone keyboards use it.</a:t>
+              <a:t>The LRA hits resonance in about 5 ms and stops just as fast, which is why phone keyboards use it.</a:t>
             </a:r>
           </a:p>
           <a:p>
@@ -12612,7 +12623,7 @@
                 </a:solidFill>
                 <a:latin typeface="Arial"/>
               </a:rPr>
-              <a:t>The piezo is the crystal from the lecture: near-instant, almost no power, but shallow. A tick, not a thump.</a:t>
+              <a:t>The piezo is a crystal that flexes when you put current across it. Near-instant, almost no power, but shallow. A tick, not a thump.</a:t>
             </a:r>
           </a:p>
         </p:txBody>
@@ -12900,7 +12911,7 @@
                 </a:solidFill>
                 <a:latin typeface="Arial"/>
               </a:rPr>
-              <a:t>WEEK 39 LAB</a:t>
+              <a:t>PROTOTYPING WORKSHOP</a:t>
             </a:r>
           </a:p>
         </p:txBody>
@@ -13029,7 +13040,7 @@
                 </a:solidFill>
                 <a:latin typeface="Arial"/>
               </a:rPr>
-              <a:t>03 — SOLENOID TAP</a:t>
+              <a:t>03   SOLENOID TAP</a:t>
             </a:r>
           </a:p>
         </p:txBody>
@@ -13176,26 +13187,7 @@
                 </a:solidFill>
                 <a:latin typeface="Arial"/>
               </a:rPr>
-              <a:t>This is the bench everyone remembers. A discrete knock carries urgency no amount of buzzing does — it reads as somebody tapping you.</a:t>
-            </a:r>
-          </a:p>
-          <a:p>
-            <a:pPr>
-              <a:lnSpc>
-                <a:spcPct val="130000"/>
-              </a:lnSpc>
-              <a:spcAft>
-                <a:spcPts val="900"/>
-              </a:spcAft>
-            </a:pPr>
-            <a:r>
-              <a:rPr sz="1600" b="0">
-                <a:solidFill>
-                  <a:srgbClr val="000000"/>
-                </a:solidFill>
-                <a:latin typeface="Arial"/>
-              </a:rPr>
-              <a:t>Indexical, not symbolic.</a:t>
+              <a:t>This is the bench everyone remembers. A single knock carries urgency that no amount of buzzing does, because it reads as a person tapping you rather than a machine signalling.</a:t>
             </a:r>
           </a:p>
         </p:txBody>
@@ -13502,7 +13494,7 @@
                 </a:solidFill>
                 <a:latin typeface="Arial"/>
               </a:rPr>
-              <a:t>WEEK 39 LAB</a:t>
+              <a:t>PROTOTYPING WORKSHOP</a:t>
             </a:r>
           </a:p>
         </p:txBody>
@@ -13631,7 +13623,7 @@
                 </a:solidFill>
                 <a:latin typeface="Arial"/>
               </a:rPr>
-              <a:t>04 — CAPACITIVE TOUCH</a:t>
+              <a:t>04   CAPACITIVE TOUCH</a:t>
             </a:r>
           </a:p>
         </p:txBody>
@@ -13778,7 +13770,7 @@
                 </a:solidFill>
                 <a:latin typeface="Arial"/>
               </a:rPr>
-              <a:t>There is no button and no sensor you can point at. The input IS a wire taped to a plate, read on an analogue pin.</a:t>
+              <a:t>There is no button and no sensor you can point at. The input is a wire taped behind a plate, read on an analogue pin.</a:t>
             </a:r>
           </a:p>
           <a:p>
@@ -13797,7 +13789,7 @@
                 </a:solidFill>
                 <a:latin typeface="Arial"/>
               </a:rPr>
-              <a:t>This is the SOS 2025 rig running its real sketch.</a:t>
+              <a:t>Any surface can become an input this way: foil, card, fabric.</a:t>
             </a:r>
           </a:p>
         </p:txBody>
@@ -13995,7 +13987,7 @@
                 </a:solidFill>
                 <a:latin typeface="Consolas"/>
               </a:rPr>
-              <a:t>cost   ~0 kr — a wire</a:t>
+              <a:t>cost   ~0 kr, a wire</a:t>
             </a:r>
           </a:p>
         </p:txBody>
@@ -14104,7 +14096,7 @@
                 </a:solidFill>
                 <a:latin typeface="Arial"/>
               </a:rPr>
-              <a:t>WEEK 39 LAB</a:t>
+              <a:t>PROTOTYPING WORKSHOP</a:t>
             </a:r>
           </a:p>
         </p:txBody>

</xml_diff>

<commit_message>
Cut slide text to fragments, matching the course's house style
Measured against the department's own MultimodalInteraction_2b_Visual deck:
it runs a median of 15 words per slide, mine ran 74. Prose sentences on a
lecture-slide template read as a handout, and compete with the presenter.

Body text is now terse fragments. The full sentences moved into the speaker
notes, where the presenter reads them rather than the room.

Median words per slide 74 -> 55, max 102 -> 70 (under the source deck's 87).
The remaining gap is the bench spec blocks, which are reference data.

Claude-Session: https://claude.ai/code/session_017zoLSxpHdmuqsaMfQZ6vfx
</commit_message>
<xml_diff>
--- a/docs/multimodal-actuator-workshop.pptx
+++ b/docs/multimodal-actuator-workshop.pptx
@@ -823,12 +823,12 @@
           <a:lstStyle/>
           <a:p>
             <a:r>
-              <a:t>Redundancy, made physical. Same driver, two frequencies: one you feel,</a:t>
-            </a:r>
-          </a:p>
-          <a:p>
-            <a:r>
-              <a:t>one you hear.</a:t>
+              <a:t>Redundancy, made physical. One transducer on a plate, two frequencies: 40 Hz</a:t>
+            </a:r>
+          </a:p>
+          <a:p>
+            <a:r>
+              <a:t>you feel, 400 Hz you hear, both from the same driver.</a:t>
             </a:r>
           </a:p>
           <a:p/>
@@ -1007,7 +1007,12 @@
           <a:lstStyle/>
           <a:p>
             <a:r>
-              <a:t>Mention, don't teach. These sit on one table with a sign.</a:t>
+              <a:t>Mention, don't teach. These sit on one table with a sign. The slide is one</a:t>
+            </a:r>
+          </a:p>
+          <a:p>
+            <a:r>
+              <a:t>line each; the caveats below are what actually saves them time.</a:t>
             </a:r>
           </a:p>
           <a:p/>
@@ -1104,7 +1109,23 @@
           <a:lstStyle/>
           <a:p>
             <a:r>
-              <a:t>Five minutes, and show the actual repos on screen if you can.</a:t>
+              <a:t>Five minutes, and show the actual repos on screen if you can. The slide names</a:t>
+            </a:r>
+          </a:p>
+          <a:p>
+            <a:r>
+              <a:t>them; you supply the detail.</a:t>
+            </a:r>
+          </a:p>
+          <a:p/>
+          <a:p>
+            <a:r>
+              <a:t>The moving screen has a browser control panel over the serial port, which is</a:t>
+            </a:r>
+          </a:p>
+          <a:p>
+            <a:r>
+              <a:t>exactly what you want at the project demonstrations.</a:t>
             </a:r>
           </a:p>
           <a:p/>
@@ -1282,7 +1303,28 @@
           <a:lstStyle/>
           <a:p>
             <a:r>
-              <a:t>Read the brief out once, then get out of the way.</a:t>
+              <a:t>Read the brief out once, then get out of the way. Full wording, since the</a:t>
+            </a:r>
+          </a:p>
+          <a:p>
+            <a:r>
+              <a:t>slide is only the bones:</a:t>
+            </a:r>
+          </a:p>
+          <a:p/>
+          <a:p>
+            <a:r>
+              <a:t>"Pick one actuator. Encode three messages: arrived, something wrong, finished.</a:t>
+            </a:r>
+          </a:p>
+          <a:p>
+            <a:r>
+              <a:t>Vary only the rhythm of the pulses and how strong they are. Then hand it to</a:t>
+            </a:r>
+          </a:p>
+          <a:p>
+            <a:r>
+              <a:t>another group with the screen turned away and see if they can name all three."</a:t>
             </a:r>
           </a:p>
           <a:p/>
@@ -1559,12 +1601,34 @@
           <a:lstStyle/>
           <a:p>
             <a:r>
-              <a:t>Say the honest version: every year projects end up on the screen and the</a:t>
-            </a:r>
-          </a:p>
-          <a:p>
-            <a:r>
-              <a:t>speaker, and touch gets designed on paper then dropped.</a:t>
+              <a:t>Say the full version out loud, the slide only carries the skeleton:</a:t>
+            </a:r>
+          </a:p>
+          <a:p/>
+          <a:p>
+            <a:r>
+              <a:t>"You can read a datasheet. You have never held one of these. Today you put a</a:t>
+            </a:r>
+          </a:p>
+          <a:p>
+            <a:r>
+              <a:t>vibration motor against your own wrist, decide it feels cheap, and pick</a:t>
+            </a:r>
+          </a:p>
+          <a:p>
+            <a:r>
+              <a:t>something else. Better now than in week 46 with the demo three days out."</a:t>
+            </a:r>
+          </a:p>
+          <a:p/>
+          <a:p>
+            <a:r>
+              <a:t>Every year projects end up on the screen and the speaker, and touch gets</a:t>
+            </a:r>
+          </a:p>
+          <a:p>
+            <a:r>
+              <a:t>designed on paper then dropped.</a:t>
             </a:r>
           </a:p>
           <a:p/>
@@ -2030,7 +2094,12 @@
           </a:p>
           <a:p>
             <a:r>
-              <a:t>5 ms on, 5 ms off. Piezo is sharp but shallow.</a:t>
+              <a:t>5 ms on, 5 ms off. Piezo is a crystal that flexes when you put current across</a:t>
+            </a:r>
+          </a:p>
+          <a:p>
+            <a:r>
+              <a:t>it, so it is sharp but shallow.</a:t>
             </a:r>
           </a:p>
           <a:p/>
@@ -2132,7 +2201,7 @@
           </a:p>
           <a:p>
             <a:r>
-              <a:t>whole reason it feels different.</a:t>
+              <a:t>whole reason it feels different, and the slide only says the short version.</a:t>
             </a:r>
           </a:p>
           <a:p/>
@@ -5491,7 +5560,7 @@
                 </a:solidFill>
                 <a:latin typeface="Arial"/>
               </a:rPr>
-              <a:t>Touch input for the price of a wire. The thinking is where it costs you.</a:t>
+              <a:t>Touch input for the price of a wire.</a:t>
             </a:r>
           </a:p>
           <a:p>
@@ -5542,7 +5611,7 @@
                 </a:solidFill>
                 <a:latin typeface="Arial"/>
               </a:rPr>
-              <a:t>The threshold is RELATIVE, never absolute.</a:t>
+              <a:t>Threshold is relative, never absolute</a:t>
             </a:r>
           </a:p>
           <a:p>
@@ -5562,7 +5631,27 @@
                 </a:solidFill>
                 <a:latin typeface="Arial"/>
               </a:rPr>
-              <a:t>• Readings drift with humidity, with mains hum, with how you are sitting. A fixed threshold works in the morning and fails after lunch.</a:t>
+              <a:t>• Readings drift with humidity and mains hum</a:t>
+            </a:r>
+          </a:p>
+          <a:p>
+            <a:pPr marL="0" indent="0" algn="l">
+              <a:lnSpc>
+                <a:spcPct val="128000"/>
+              </a:lnSpc>
+              <a:spcAft>
+                <a:spcPts val="700"/>
+              </a:spcAft>
+              <a:buNone/>
+            </a:pPr>
+            <a:r>
+              <a:rPr sz="1500" b="0">
+                <a:solidFill>
+                  <a:srgbClr val="000000"/>
+                </a:solidFill>
+                <a:latin typeface="Arial"/>
+              </a:rPr>
+              <a:t>• Fixed threshold works at 9am, fails at 1pm</a:t>
             </a:r>
           </a:p>
           <a:p>
@@ -5593,7 +5682,7 @@
                 </a:solidFill>
                 <a:latin typeface="Arial"/>
               </a:rPr>
-              <a:t>The baseline only learns while untouched.</a:t>
+              <a:t>Baseline only learns while untouched</a:t>
             </a:r>
           </a:p>
           <a:p>
@@ -5613,7 +5702,7 @@
                 </a:solidFill>
                 <a:latin typeface="Arial"/>
               </a:rPr>
-              <a:t>• Otherwise a long press slowly teaches it that a finger is normal, and the touch quietly stops registering.</a:t>
+              <a:t>• Or a long press teaches it that a finger is normal</a:t>
             </a:r>
           </a:p>
         </p:txBody>
@@ -5734,87 +5823,129 @@
                 <a:spcPct val="128000"/>
               </a:lnSpc>
               <a:spcAft>
+                <a:spcPts val="1200"/>
+              </a:spcAft>
+              <a:buNone/>
+            </a:pPr>
+            <a:r>
+              <a:rPr sz="1000" b="1">
+                <a:solidFill>
+                  <a:srgbClr val="595959"/>
+                </a:solidFill>
+                <a:latin typeface="Arial"/>
+              </a:rPr>
+              <a:t>THERMAL</a:t>
+            </a:r>
+          </a:p>
+          <a:p>
+            <a:pPr marL="0" indent="0" algn="l">
+              <a:lnSpc>
+                <a:spcPct val="128000"/>
+              </a:lnSpc>
+              <a:spcAft>
+                <a:spcPts val="400"/>
+              </a:spcAft>
+              <a:buNone/>
+            </a:pPr>
+            <a:r>
+              <a:rPr sz="1600" b="0">
+                <a:solidFill>
+                  <a:srgbClr val="000000"/>
+                </a:solidFill>
+                <a:latin typeface="Arial"/>
+              </a:rPr>
+              <a:t>Heats one side, cools the other.</a:t>
+            </a:r>
+          </a:p>
+          <a:p>
+            <a:pPr marL="0" indent="0" algn="l">
+              <a:lnSpc>
+                <a:spcPct val="128000"/>
+              </a:lnSpc>
+              <a:spcAft>
+                <a:spcPts val="400"/>
+              </a:spcAft>
+              <a:buNone/>
+            </a:pPr>
+            <a:r>
+              <a:rPr sz="1600" b="0">
+                <a:solidFill>
+                  <a:srgbClr val="000000"/>
+                </a:solidFill>
+                <a:latin typeface="Arial"/>
+              </a:rPr>
+              <a:t>Flip the current, it reverses.</a:t>
+            </a:r>
+          </a:p>
+          <a:p>
+            <a:pPr marL="0" indent="0" algn="l">
+              <a:lnSpc>
+                <a:spcPct val="128000"/>
+              </a:lnSpc>
+              <a:spcAft>
+                <a:spcPts val="0"/>
+              </a:spcAft>
+              <a:buNone/>
+            </a:pPr>
+          </a:p>
+          <a:p>
+            <a:pPr marL="0" indent="0" algn="l">
+              <a:lnSpc>
+                <a:spcPct val="128000"/>
+              </a:lnSpc>
+              <a:spcAft>
+                <a:spcPts val="400"/>
+              </a:spcAft>
+              <a:buNone/>
+            </a:pPr>
+            <a:r>
+              <a:rPr sz="1600" b="0">
+                <a:solidFill>
+                  <a:srgbClr val="000000"/>
+                </a:solidFill>
+                <a:latin typeface="Arial"/>
+              </a:rPr>
+              <a:t>Sit with it. Seconds before you are sure.</a:t>
+            </a:r>
+          </a:p>
+          <a:p>
+            <a:pPr marL="0" indent="0" algn="l">
+              <a:lnSpc>
+                <a:spcPct val="128000"/>
+              </a:lnSpc>
+              <a:spcAft>
+                <a:spcPts val="0"/>
+              </a:spcAft>
+              <a:buNone/>
+            </a:pPr>
+          </a:p>
+          <a:p>
+            <a:pPr marL="0" indent="0" algn="l">
+              <a:lnSpc>
+                <a:spcPct val="128000"/>
+              </a:lnSpc>
+              <a:spcAft>
+                <a:spcPts val="400"/>
+              </a:spcAft>
+              <a:buNone/>
+            </a:pPr>
+            <a:r>
+              <a:rPr sz="1600" b="0">
+                <a:solidFill>
+                  <a:srgbClr val="000000"/>
+                </a:solidFill>
+                <a:latin typeface="Arial"/>
+              </a:rPr>
+              <a:t>Hot alternating with cold reads as lukewarm.</a:t>
+            </a:r>
+          </a:p>
+          <a:p>
+            <a:pPr marL="0" indent="0" algn="l">
+              <a:lnSpc>
+                <a:spcPct val="128000"/>
+              </a:lnSpc>
+              <a:spcAft>
                 <a:spcPts val="1000"/>
-              </a:spcAft>
-              <a:buNone/>
-            </a:pPr>
-            <a:r>
-              <a:rPr sz="1000" b="1">
-                <a:solidFill>
-                  <a:srgbClr val="595959"/>
-                </a:solidFill>
-                <a:latin typeface="Arial"/>
-              </a:rPr>
-              <a:t>THERMAL</a:t>
-            </a:r>
-          </a:p>
-          <a:p>
-            <a:pPr marL="0" indent="0" algn="l">
-              <a:lnSpc>
-                <a:spcPct val="128000"/>
-              </a:lnSpc>
-              <a:spcAft>
-                <a:spcPts val="900"/>
-              </a:spcAft>
-              <a:buNone/>
-            </a:pPr>
-            <a:r>
-              <a:rPr sz="1600" b="0">
-                <a:solidFill>
-                  <a:srgbClr val="000000"/>
-                </a:solidFill>
-                <a:latin typeface="Arial"/>
-              </a:rPr>
-              <a:t>A thermoelectric tile: heats one side, cools the other, reverses when you flip the current.</a:t>
-            </a:r>
-          </a:p>
-          <a:p>
-            <a:pPr marL="0" indent="0" algn="l">
-              <a:lnSpc>
-                <a:spcPct val="128000"/>
-              </a:lnSpc>
-              <a:spcAft>
-                <a:spcPts val="900"/>
-              </a:spcAft>
-              <a:buNone/>
-            </a:pPr>
-            <a:r>
-              <a:rPr sz="1600" b="0">
-                <a:solidFill>
-                  <a:srgbClr val="000000"/>
-                </a:solidFill>
-                <a:latin typeface="Arial"/>
-              </a:rPr>
-              <a:t>Sit with it. It takes several seconds before you are sure which way it went.</a:t>
-            </a:r>
-          </a:p>
-          <a:p>
-            <a:pPr marL="0" indent="0" algn="l">
-              <a:lnSpc>
-                <a:spcPct val="128000"/>
-              </a:lnSpc>
-              <a:spcAft>
-                <a:spcPts val="900"/>
-              </a:spcAft>
-              <a:buNone/>
-            </a:pPr>
-            <a:r>
-              <a:rPr sz="1600" b="0">
-                <a:solidFill>
-                  <a:srgbClr val="000000"/>
-                </a:solidFill>
-                <a:latin typeface="Arial"/>
-              </a:rPr>
-              <a:t>And alternating hot with cold does not read as a pattern. It just reads as lukewarm.</a:t>
-            </a:r>
-          </a:p>
-          <a:p>
-            <a:pPr marL="0" indent="0" algn="l">
-              <a:lnSpc>
-                <a:spcPct val="128000"/>
-              </a:lnSpc>
-              <a:spcAft>
-                <a:spcPts val="400"/>
               </a:spcAft>
               <a:buNone/>
             </a:pPr>
@@ -6113,87 +6244,129 @@
                 <a:spcPct val="128000"/>
               </a:lnSpc>
               <a:spcAft>
+                <a:spcPts val="1200"/>
+              </a:spcAft>
+              <a:buNone/>
+            </a:pPr>
+            <a:r>
+              <a:rPr sz="1000" b="1">
+                <a:solidFill>
+                  <a:srgbClr val="595959"/>
+                </a:solidFill>
+                <a:latin typeface="Arial"/>
+              </a:rPr>
+              <a:t>AUDIO + TOUCH</a:t>
+            </a:r>
+          </a:p>
+          <a:p>
+            <a:pPr marL="0" indent="0" algn="l">
+              <a:lnSpc>
+                <a:spcPct val="128000"/>
+              </a:lnSpc>
+              <a:spcAft>
+                <a:spcPts val="400"/>
+              </a:spcAft>
+              <a:buNone/>
+            </a:pPr>
+            <a:r>
+              <a:rPr sz="1600" b="0">
+                <a:solidFill>
+                  <a:srgbClr val="000000"/>
+                </a:solidFill>
+                <a:latin typeface="Arial"/>
+              </a:rPr>
+              <a:t>One driver. 40 Hz you feel, 400 Hz you hear.</a:t>
+            </a:r>
+          </a:p>
+          <a:p>
+            <a:pPr marL="0" indent="0" algn="l">
+              <a:lnSpc>
+                <a:spcPct val="128000"/>
+              </a:lnSpc>
+              <a:spcAft>
+                <a:spcPts val="0"/>
+              </a:spcAft>
+              <a:buNone/>
+            </a:pPr>
+          </a:p>
+          <a:p>
+            <a:pPr marL="0" indent="0" algn="l">
+              <a:lnSpc>
+                <a:spcPct val="128000"/>
+              </a:lnSpc>
+              <a:spcAft>
+                <a:spcPts val="400"/>
+              </a:spcAft>
+              <a:buNone/>
+            </a:pPr>
+            <a:r>
+              <a:rPr sz="1600" b="0">
+                <a:solidFill>
+                  <a:srgbClr val="000000"/>
+                </a:solidFill>
+                <a:latin typeface="Arial"/>
+              </a:rPr>
+              <a:t>Toggle them alone, then together.</a:t>
+            </a:r>
+          </a:p>
+          <a:p>
+            <a:pPr marL="0" indent="0" algn="l">
+              <a:lnSpc>
+                <a:spcPct val="128000"/>
+              </a:lnSpc>
+              <a:spcAft>
+                <a:spcPts val="0"/>
+              </a:spcAft>
+              <a:buNone/>
+            </a:pPr>
+          </a:p>
+          <a:p>
+            <a:pPr marL="0" indent="0" algn="l">
+              <a:lnSpc>
+                <a:spcPct val="128000"/>
+              </a:lnSpc>
+              <a:spcAft>
+                <a:spcPts val="400"/>
+              </a:spcAft>
+              <a:buNone/>
+            </a:pPr>
+            <a:r>
+              <a:rPr sz="1600" b="0">
+                <a:solidFill>
+                  <a:srgbClr val="000000"/>
+                </a:solidFill>
+                <a:latin typeface="Arial"/>
+              </a:rPr>
+              <a:t>Together is not louder. It is more certain.</a:t>
+            </a:r>
+          </a:p>
+          <a:p>
+            <a:pPr marL="0" indent="0" algn="l">
+              <a:lnSpc>
+                <a:spcPct val="128000"/>
+              </a:lnSpc>
+              <a:spcAft>
+                <a:spcPts val="400"/>
+              </a:spcAft>
+              <a:buNone/>
+            </a:pPr>
+            <a:r>
+              <a:rPr sz="1600" b="0">
+                <a:solidFill>
+                  <a:srgbClr val="000000"/>
+                </a:solidFill>
+                <a:latin typeface="Arial"/>
+              </a:rPr>
+              <a:t>Two channels, same message. Cheap reliability.</a:t>
+            </a:r>
+          </a:p>
+          <a:p>
+            <a:pPr marL="0" indent="0" algn="l">
+              <a:lnSpc>
+                <a:spcPct val="128000"/>
+              </a:lnSpc>
+              <a:spcAft>
                 <a:spcPts val="1000"/>
-              </a:spcAft>
-              <a:buNone/>
-            </a:pPr>
-            <a:r>
-              <a:rPr sz="1000" b="1">
-                <a:solidFill>
-                  <a:srgbClr val="595959"/>
-                </a:solidFill>
-                <a:latin typeface="Arial"/>
-              </a:rPr>
-              <a:t>AUDIO + TOUCH</a:t>
-            </a:r>
-          </a:p>
-          <a:p>
-            <a:pPr marL="0" indent="0" algn="l">
-              <a:lnSpc>
-                <a:spcPct val="128000"/>
-              </a:lnSpc>
-              <a:spcAft>
-                <a:spcPts val="900"/>
-              </a:spcAft>
-              <a:buNone/>
-            </a:pPr>
-            <a:r>
-              <a:rPr sz="1600" b="0">
-                <a:solidFill>
-                  <a:srgbClr val="000000"/>
-                </a:solidFill>
-                <a:latin typeface="Arial"/>
-              </a:rPr>
-              <a:t>One transducer on a plate, playing 40 Hz you feel and 400 Hz you hear, both from the same driver.</a:t>
-            </a:r>
-          </a:p>
-          <a:p>
-            <a:pPr marL="0" indent="0" algn="l">
-              <a:lnSpc>
-                <a:spcPct val="128000"/>
-              </a:lnSpc>
-              <a:spcAft>
-                <a:spcPts val="900"/>
-              </a:spcAft>
-              <a:buNone/>
-            </a:pPr>
-            <a:r>
-              <a:rPr sz="1600" b="0">
-                <a:solidFill>
-                  <a:srgbClr val="000000"/>
-                </a:solidFill>
-                <a:latin typeface="Arial"/>
-              </a:rPr>
-              <a:t>Toggle between them alone and together.</a:t>
-            </a:r>
-          </a:p>
-          <a:p>
-            <a:pPr marL="0" indent="0" algn="l">
-              <a:lnSpc>
-                <a:spcPct val="128000"/>
-              </a:lnSpc>
-              <a:spcAft>
-                <a:spcPts val="900"/>
-              </a:spcAft>
-              <a:buNone/>
-            </a:pPr>
-            <a:r>
-              <a:rPr sz="1600" b="0">
-                <a:solidFill>
-                  <a:srgbClr val="000000"/>
-                </a:solidFill>
-                <a:latin typeface="Arial"/>
-              </a:rPr>
-              <a:t>Together is not louder. It is more certain. Sending the same thing down two channels is the cheapest reliability your project can buy.</a:t>
-            </a:r>
-          </a:p>
-          <a:p>
-            <a:pPr marL="0" indent="0" algn="l">
-              <a:lnSpc>
-                <a:spcPct val="128000"/>
-              </a:lnSpc>
-              <a:spcAft>
-                <a:spcPts val="400"/>
               </a:spcAft>
               <a:buNone/>
             </a:pPr>
@@ -6619,7 +6792,7 @@
                 </a:solidFill>
                 <a:latin typeface="Arial"/>
               </a:rPr>
-              <a:t>• Capacitive touch. A wire on an analogue pin. See bench 04.</a:t>
+              <a:t>• Capacitive touch. A wire. See bench 04</a:t>
             </a:r>
           </a:p>
           <a:p>
@@ -6639,7 +6812,7 @@
                 </a:solidFill>
                 <a:latin typeface="Arial"/>
               </a:rPr>
-              <a:t>• Heart rate (PPG). Steady at rest, useless once the hand moves.</a:t>
+              <a:t>• Heart rate (PPG). Useless once the hand moves</a:t>
             </a:r>
           </a:p>
           <a:p>
@@ -6659,7 +6832,7 @@
                 </a:solidFill>
                 <a:latin typeface="Arial"/>
               </a:rPr>
-              <a:t>• Skin conductance (GSR). Drifts constantly, so relative change only.</a:t>
+              <a:t>• Skin conductance (GSR). Relative change only</a:t>
             </a:r>
           </a:p>
           <a:p>
@@ -6679,7 +6852,7 @@
                 </a:solidFill>
                 <a:latin typeface="Arial"/>
               </a:rPr>
-              <a:t>• Flex sensor. The cheap route to a data glove.</a:t>
+              <a:t>• Flex sensor. The cheap data glove</a:t>
             </a:r>
           </a:p>
           <a:p>
@@ -6699,7 +6872,7 @@
                 </a:solidFill>
                 <a:latin typeface="Arial"/>
               </a:rPr>
-              <a:t>• Pressure (FSR). How hard, not just whether. Calibrate each pad.</a:t>
+              <a:t>• Pressure (FSR). Calibrate every pad</a:t>
             </a:r>
           </a:p>
           <a:p>
@@ -6719,7 +6892,7 @@
                 </a:solidFill>
                 <a:latin typeface="Arial"/>
               </a:rPr>
-              <a:t>• Your own phone. Accelerometer, gyro, mic, camera, vibration motor. No soldering at all.</a:t>
+              <a:t>• Your own phone. No soldering at all</a:t>
             </a:r>
           </a:p>
         </p:txBody>
@@ -6871,7 +7044,7 @@
                 </a:solidFill>
                 <a:latin typeface="Arial"/>
               </a:rPr>
-              <a:t>Capacitive sensing, servos and actuators (Arduino Uno)</a:t>
+              <a:t>Moving screen, Arduino Uno</a:t>
             </a:r>
           </a:p>
           <a:p>
@@ -6891,7 +7064,7 @@
                 </a:solidFill>
                 <a:latin typeface="Arial"/>
               </a:rPr>
-              <a:t>• A moving screen that breathes when idle and retreats when you touch it, with a browser control panel over the serial port.</a:t>
+              <a:t>• Breathes when idle. Retreats when touched</a:t>
             </a:r>
           </a:p>
           <a:p>
@@ -6911,7 +7084,7 @@
                 </a:solidFill>
                 <a:latin typeface="Arial"/>
               </a:rPr>
-              <a:t>• Take away: easing and idle motion are what separate "a servo moved" from "it reacted to me". Both are a dozen lines.</a:t>
+              <a:t>• Easing and idle motion do the work. A dozen lines</a:t>
             </a:r>
           </a:p>
           <a:p>
@@ -6942,7 +7115,7 @@
                 </a:solidFill>
                 <a:latin typeface="Arial"/>
               </a:rPr>
-              <a:t>Instrumented sock (ESP32, bachelor project)</a:t>
+              <a:t>Instrumented sock, ESP32</a:t>
             </a:r>
           </a:p>
           <a:p>
@@ -6962,7 +7135,7 @@
                 </a:solidFill>
                 <a:latin typeface="Arial"/>
               </a:rPr>
-              <a:t>• Six force sensors under a foot, sent to a server over Wi-Fi in batches, each with its own calibration constants.</a:t>
+              <a:t>• Six force sensors under a foot, batched over Wi-Fi</a:t>
             </a:r>
           </a:p>
           <a:p>
@@ -6982,7 +7155,7 @@
                 </a:solidFill>
                 <a:latin typeface="Arial"/>
               </a:rPr>
-              <a:t>• Take away: calibrate per sensor, and batch your writes.</a:t>
+              <a:t>• Calibrate per sensor. Batch your writes</a:t>
             </a:r>
           </a:p>
         </p:txBody>
@@ -7210,7 +7383,7 @@
                 </a:solidFill>
                 <a:latin typeface="Arial"/>
               </a:rPr>
-              <a:t>30 minutes. Deliberately not long enough to be precious about it.</a:t>
+              <a:t>30 minutes. Not long enough to be precious about it.</a:t>
             </a:r>
           </a:p>
           <a:p>
@@ -7224,13 +7397,13 @@
               <a:buNone/>
             </a:pPr>
             <a:r>
-              <a:rPr sz="1700" b="0">
-                <a:solidFill>
-                  <a:srgbClr val="000000"/>
-                </a:solidFill>
-                <a:latin typeface="Arial"/>
-              </a:rPr>
-              <a:t>Pick one actuator from the rotation.</a:t>
+              <a:rPr sz="1700" b="1">
+                <a:solidFill>
+                  <a:srgbClr val="000000"/>
+                </a:solidFill>
+                <a:latin typeface="Arial"/>
+              </a:rPr>
+              <a:t>One actuator. Three messages</a:t>
             </a:r>
           </a:p>
           <a:p>
@@ -7244,14 +7417,25 @@
               <a:buNone/>
             </a:pPr>
             <a:r>
-              <a:rPr sz="1700" b="0">
-                <a:solidFill>
-                  <a:srgbClr val="000000"/>
-                </a:solidFill>
-                <a:latin typeface="Arial"/>
-              </a:rPr>
-              <a:t>Encode three messages: arrived, something wrong, finished.</a:t>
-            </a:r>
+              <a:rPr sz="1500" b="0">
+                <a:solidFill>
+                  <a:srgbClr val="000000"/>
+                </a:solidFill>
+                <a:latin typeface="Arial"/>
+              </a:rPr>
+              <a:t>• Arrived. Something wrong. Finished</a:t>
+            </a:r>
+          </a:p>
+          <a:p>
+            <a:pPr marL="0" indent="0" algn="l">
+              <a:lnSpc>
+                <a:spcPct val="128000"/>
+              </a:lnSpc>
+              <a:spcAft>
+                <a:spcPts val="0"/>
+              </a:spcAft>
+              <a:buNone/>
+            </a:pPr>
           </a:p>
           <a:p>
             <a:pPr marL="0" indent="0" algn="l">
@@ -7264,13 +7448,13 @@
               <a:buNone/>
             </a:pPr>
             <a:r>
-              <a:rPr sz="1700" b="0">
-                <a:solidFill>
-                  <a:srgbClr val="000000"/>
-                </a:solidFill>
-                <a:latin typeface="Arial"/>
-              </a:rPr>
-              <a:t>Vary only two things: the RHYTHM of the pulses, and how STRONG they are. No swapping actuators between messages.</a:t>
+              <a:rPr sz="1700" b="1">
+                <a:solidFill>
+                  <a:srgbClr val="000000"/>
+                </a:solidFill>
+                <a:latin typeface="Arial"/>
+              </a:rPr>
+              <a:t>Vary two things only</a:t>
             </a:r>
           </a:p>
           <a:p>
@@ -7284,13 +7468,13 @@
               <a:buNone/>
             </a:pPr>
             <a:r>
-              <a:rPr sz="1700" b="0">
-                <a:solidFill>
-                  <a:srgbClr val="000000"/>
-                </a:solidFill>
-                <a:latin typeface="Arial"/>
-              </a:rPr>
-              <a:t>Hand it to another group with the screen turned away. They name all three.</a:t>
+              <a:rPr sz="1500" b="0">
+                <a:solidFill>
+                  <a:srgbClr val="000000"/>
+                </a:solidFill>
+                <a:latin typeface="Arial"/>
+              </a:rPr>
+              <a:t>• Rhythm of the pulses</a:t>
             </a:r>
           </a:p>
           <a:p>
@@ -7304,13 +7488,64 @@
               <a:buNone/>
             </a:pPr>
             <a:r>
-              <a:rPr sz="1700" b="0">
-                <a:solidFill>
-                  <a:srgbClr val="000000"/>
-                </a:solidFill>
-                <a:latin typeface="Arial"/>
-              </a:rPr>
-              <a:t>Write down which two got confused, and what would have separated them.</a:t>
+              <a:rPr sz="1500" b="0">
+                <a:solidFill>
+                  <a:srgbClr val="000000"/>
+                </a:solidFill>
+                <a:latin typeface="Arial"/>
+              </a:rPr>
+              <a:t>• How strong they are</a:t>
+            </a:r>
+          </a:p>
+          <a:p>
+            <a:pPr marL="0" indent="0" algn="l">
+              <a:lnSpc>
+                <a:spcPct val="128000"/>
+              </a:lnSpc>
+              <a:spcAft>
+                <a:spcPts val="0"/>
+              </a:spcAft>
+              <a:buNone/>
+            </a:pPr>
+          </a:p>
+          <a:p>
+            <a:pPr marL="0" indent="0" algn="l">
+              <a:lnSpc>
+                <a:spcPct val="128000"/>
+              </a:lnSpc>
+              <a:spcAft>
+                <a:spcPts val="700"/>
+              </a:spcAft>
+              <a:buNone/>
+            </a:pPr>
+            <a:r>
+              <a:rPr sz="1700" b="1">
+                <a:solidFill>
+                  <a:srgbClr val="000000"/>
+                </a:solidFill>
+                <a:latin typeface="Arial"/>
+              </a:rPr>
+              <a:t>Blind test: they name all three</a:t>
+            </a:r>
+          </a:p>
+          <a:p>
+            <a:pPr marL="0" indent="0" algn="l">
+              <a:lnSpc>
+                <a:spcPct val="128000"/>
+              </a:lnSpc>
+              <a:spcAft>
+                <a:spcPts val="700"/>
+              </a:spcAft>
+              <a:buNone/>
+            </a:pPr>
+            <a:r>
+              <a:rPr sz="1500" b="0">
+                <a:solidFill>
+                  <a:srgbClr val="000000"/>
+                </a:solidFill>
+                <a:latin typeface="Arial"/>
+              </a:rPr>
+              <a:t>• Note which two got confused, and why</a:t>
             </a:r>
           </a:p>
         </p:txBody>
@@ -7473,7 +7708,27 @@
                 </a:solidFill>
                 <a:latin typeface="Arial"/>
               </a:rPr>
-              <a:t>If your design only works when someone is watching a screen, you built a visual interface with a motor glued to it.</a:t>
+              <a:t>If it only works while someone watches a screen,</a:t>
+            </a:r>
+          </a:p>
+          <a:p>
+            <a:pPr marL="0" indent="0" algn="l">
+              <a:lnSpc>
+                <a:spcPct val="128000"/>
+              </a:lnSpc>
+              <a:spcAft>
+                <a:spcPts val="700"/>
+              </a:spcAft>
+              <a:buNone/>
+            </a:pPr>
+            <a:r>
+              <a:rPr sz="1700" b="0">
+                <a:solidFill>
+                  <a:srgbClr val="000000"/>
+                </a:solidFill>
+                <a:latin typeface="Arial"/>
+              </a:rPr>
+              <a:t>you built a visual interface with a motor glued to it.</a:t>
             </a:r>
           </a:p>
         </p:txBody>
@@ -7751,7 +8006,47 @@
                 </a:solidFill>
                 <a:latin typeface="Arial"/>
               </a:rPr>
-              <a:t>Today you put a vibration motor against your own wrist, decide it feels cheap, and pick something else. Better now than in week 46.</a:t>
+              <a:t>Most projects end up on the screen and the speaker</a:t>
+            </a:r>
+          </a:p>
+          <a:p>
+            <a:pPr marL="0" indent="0" algn="l">
+              <a:lnSpc>
+                <a:spcPct val="128000"/>
+              </a:lnSpc>
+              <a:spcAft>
+                <a:spcPts val="700"/>
+              </a:spcAft>
+              <a:buNone/>
+            </a:pPr>
+            <a:r>
+              <a:rPr sz="1500" b="0">
+                <a:solidFill>
+                  <a:srgbClr val="000000"/>
+                </a:solidFill>
+                <a:latin typeface="Arial"/>
+              </a:rPr>
+              <a:t>• Not because touch was wrong</a:t>
+            </a:r>
+          </a:p>
+          <a:p>
+            <a:pPr marL="0" indent="0" algn="l">
+              <a:lnSpc>
+                <a:spcPct val="128000"/>
+              </a:lnSpc>
+              <a:spcAft>
+                <a:spcPts val="700"/>
+              </a:spcAft>
+              <a:buNone/>
+            </a:pPr>
+            <a:r>
+              <a:rPr sz="1500" b="0">
+                <a:solidFill>
+                  <a:srgbClr val="000000"/>
+                </a:solidFill>
+                <a:latin typeface="Arial"/>
+              </a:rPr>
+              <a:t>• Because nobody knew a coin motor costs 12 kr</a:t>
             </a:r>
           </a:p>
           <a:p>
@@ -7776,13 +8071,13 @@
               <a:buNone/>
             </a:pPr>
             <a:r>
-              <a:rPr sz="1700" b="0">
-                <a:solidFill>
-                  <a:srgbClr val="000000"/>
-                </a:solidFill>
-                <a:latin typeface="Arial"/>
-              </a:rPr>
-              <a:t>Every year, projects end up built entirely on the screen and the speaker.</a:t>
+              <a:rPr sz="1700" b="1">
+                <a:solidFill>
+                  <a:srgbClr val="000000"/>
+                </a:solidFill>
+                <a:latin typeface="Arial"/>
+              </a:rPr>
+              <a:t>Today: decide it feels cheap, pick something else</a:t>
             </a:r>
           </a:p>
           <a:p>
@@ -7796,13 +8091,13 @@
               <a:buNone/>
             </a:pPr>
             <a:r>
-              <a:rPr sz="1700" b="0">
-                <a:solidFill>
-                  <a:srgbClr val="000000"/>
-                </a:solidFill>
-                <a:latin typeface="Arial"/>
-              </a:rPr>
-              <a:t>Not because touch was the wrong choice. Because nobody knew that a coin motor costs 12 kr and takes two wires.</a:t>
+              <a:rPr sz="1500" b="0">
+                <a:solidFill>
+                  <a:srgbClr val="000000"/>
+                </a:solidFill>
+                <a:latin typeface="Arial"/>
+              </a:rPr>
+              <a:t>• Better now than in week 46</a:t>
             </a:r>
           </a:p>
         </p:txBody>
@@ -7934,7 +8229,7 @@
                 </a:solidFill>
                 <a:latin typeface="Arial"/>
               </a:rPr>
-              <a:t>Six benches. Already wired. Already running.</a:t>
+              <a:t>Six benches, already wired and running</a:t>
             </a:r>
           </a:p>
           <a:p>
@@ -7954,7 +8249,7 @@
                 </a:solidFill>
                 <a:latin typeface="Arial"/>
               </a:rPr>
-              <a:t>• Ten minutes each, on a hard timer.</a:t>
+              <a:t>• Ten minutes each. Hard timer</a:t>
             </a:r>
           </a:p>
           <a:p>
@@ -7974,7 +8269,7 @@
                 </a:solidFill>
                 <a:latin typeface="Arial"/>
               </a:rPr>
-              <a:t>• You change one parameter and answer one question.</a:t>
+              <a:t>• Change one parameter, answer one question</a:t>
             </a:r>
           </a:p>
           <a:p>
@@ -7994,7 +8289,7 @@
                 </a:solidFill>
                 <a:latin typeface="Arial"/>
               </a:rPr>
-              <a:t>• You wire nothing. That is what the project weeks are for.</a:t>
+              <a:t>• You wire nothing today</a:t>
             </a:r>
           </a:p>
           <a:p>
@@ -8025,7 +8320,27 @@
                 </a:solidFill>
                 <a:latin typeface="Arial"/>
               </a:rPr>
-              <a:t>Then you build one signal and someone else tries to read it.</a:t>
+              <a:t>Then build one signal</a:t>
+            </a:r>
+          </a:p>
+          <a:p>
+            <a:pPr marL="0" indent="0" algn="l">
+              <a:lnSpc>
+                <a:spcPct val="128000"/>
+              </a:lnSpc>
+              <a:spcAft>
+                <a:spcPts val="700"/>
+              </a:spcAft>
+              <a:buNone/>
+            </a:pPr>
+            <a:r>
+              <a:rPr sz="1500" b="0">
+                <a:solidFill>
+                  <a:srgbClr val="000000"/>
+                </a:solidFill>
+                <a:latin typeface="Arial"/>
+              </a:rPr>
+              <a:t>• Someone else has to read it</a:t>
             </a:r>
           </a:p>
         </p:txBody>
@@ -8474,67 +8789,118 @@
                 <a:spcPct val="128000"/>
               </a:lnSpc>
               <a:spcAft>
+                <a:spcPts val="1200"/>
+              </a:spcAft>
+              <a:buNone/>
+            </a:pPr>
+            <a:r>
+              <a:rPr sz="1000" b="1">
+                <a:solidFill>
+                  <a:srgbClr val="595959"/>
+                </a:solidFill>
+                <a:latin typeface="Arial"/>
+              </a:rPr>
+              <a:t>VIBRATION</a:t>
+            </a:r>
+          </a:p>
+          <a:p>
+            <a:pPr marL="0" indent="0" algn="l">
+              <a:lnSpc>
+                <a:spcPct val="128000"/>
+              </a:lnSpc>
+              <a:spcAft>
+                <a:spcPts val="400"/>
+              </a:spcAft>
+              <a:buNone/>
+            </a:pPr>
+            <a:r>
+              <a:rPr sz="1600" b="0">
+                <a:solidFill>
+                  <a:srgbClr val="000000"/>
+                </a:solidFill>
+                <a:latin typeface="Arial"/>
+              </a:rPr>
+              <a:t>An off-centre weight on a motor shaft.</a:t>
+            </a:r>
+          </a:p>
+          <a:p>
+            <a:pPr marL="0" indent="0" algn="l">
+              <a:lnSpc>
+                <a:spcPct val="128000"/>
+              </a:lnSpc>
+              <a:spcAft>
+                <a:spcPts val="400"/>
+              </a:spcAft>
+              <a:buNone/>
+            </a:pPr>
+            <a:r>
+              <a:rPr sz="1600" b="0">
+                <a:solidFill>
+                  <a:srgbClr val="000000"/>
+                </a:solidFill>
+                <a:latin typeface="Arial"/>
+              </a:rPr>
+              <a:t>The same part as in your phone.</a:t>
+            </a:r>
+          </a:p>
+          <a:p>
+            <a:pPr marL="0" indent="0" algn="l">
+              <a:lnSpc>
+                <a:spcPct val="128000"/>
+              </a:lnSpc>
+              <a:spcAft>
+                <a:spcPts val="0"/>
+              </a:spcAft>
+              <a:buNone/>
+            </a:pPr>
+          </a:p>
+          <a:p>
+            <a:pPr marL="0" indent="0" algn="l">
+              <a:lnSpc>
+                <a:spcPct val="128000"/>
+              </a:lnSpc>
+              <a:spcAft>
+                <a:spcPts val="400"/>
+              </a:spcAft>
+              <a:buNone/>
+            </a:pPr>
+            <a:r>
+              <a:rPr sz="1600" b="0">
+                <a:solidFill>
+                  <a:srgbClr val="000000"/>
+                </a:solidFill>
+                <a:latin typeface="Arial"/>
+              </a:rPr>
+              <a:t>Speed and strength are welded together.</a:t>
+            </a:r>
+          </a:p>
+          <a:p>
+            <a:pPr marL="0" indent="0" algn="l">
+              <a:lnSpc>
+                <a:spcPct val="128000"/>
+              </a:lnSpc>
+              <a:spcAft>
+                <a:spcPts val="400"/>
+              </a:spcAft>
+              <a:buNone/>
+            </a:pPr>
+            <a:r>
+              <a:rPr sz="1600" b="0">
+                <a:solidFill>
+                  <a:srgbClr val="000000"/>
+                </a:solidFill>
+                <a:latin typeface="Arial"/>
+              </a:rPr>
+              <a:t>"Gentle but fast" is not on offer.</a:t>
+            </a:r>
+          </a:p>
+          <a:p>
+            <a:pPr marL="0" indent="0" algn="l">
+              <a:lnSpc>
+                <a:spcPct val="128000"/>
+              </a:lnSpc>
+              <a:spcAft>
                 <a:spcPts val="1000"/>
-              </a:spcAft>
-              <a:buNone/>
-            </a:pPr>
-            <a:r>
-              <a:rPr sz="1000" b="1">
-                <a:solidFill>
-                  <a:srgbClr val="595959"/>
-                </a:solidFill>
-                <a:latin typeface="Arial"/>
-              </a:rPr>
-              <a:t>VIBRATION</a:t>
-            </a:r>
-          </a:p>
-          <a:p>
-            <a:pPr marL="0" indent="0" algn="l">
-              <a:lnSpc>
-                <a:spcPct val="128000"/>
-              </a:lnSpc>
-              <a:spcAft>
-                <a:spcPts val="900"/>
-              </a:spcAft>
-              <a:buNone/>
-            </a:pPr>
-            <a:r>
-              <a:rPr sz="1600" b="0">
-                <a:solidFill>
-                  <a:srgbClr val="000000"/>
-                </a:solidFill>
-                <a:latin typeface="Arial"/>
-              </a:rPr>
-              <a:t>An off-centre weight on a motor shaft. The same part that is in your phone and every game controller.</a:t>
-            </a:r>
-          </a:p>
-          <a:p>
-            <a:pPr marL="0" indent="0" algn="l">
-              <a:lnSpc>
-                <a:spcPct val="128000"/>
-              </a:lnSpc>
-              <a:spcAft>
-                <a:spcPts val="900"/>
-              </a:spcAft>
-              <a:buNone/>
-            </a:pPr>
-            <a:r>
-              <a:rPr sz="1600" b="0">
-                <a:solidFill>
-                  <a:srgbClr val="000000"/>
-                </a:solidFill>
-                <a:latin typeface="Arial"/>
-              </a:rPr>
-              <a:t>Turn the knob and notice what you cannot do. Speed and strength are mechanically welded together, so "gentle but fast" is not available to you.</a:t>
-            </a:r>
-          </a:p>
-          <a:p>
-            <a:pPr marL="0" indent="0" algn="l">
-              <a:lnSpc>
-                <a:spcPct val="128000"/>
-              </a:lnSpc>
-              <a:spcAft>
-                <a:spcPts val="400"/>
               </a:spcAft>
               <a:buNone/>
             </a:pPr>
@@ -8833,87 +9199,149 @@
                 <a:spcPct val="128000"/>
               </a:lnSpc>
               <a:spcAft>
+                <a:spcPts val="1200"/>
+              </a:spcAft>
+              <a:buNone/>
+            </a:pPr>
+            <a:r>
+              <a:rPr sz="1000" b="1">
+                <a:solidFill>
+                  <a:srgbClr val="595959"/>
+                </a:solidFill>
+                <a:latin typeface="Arial"/>
+              </a:rPr>
+              <a:t>VIBRATION</a:t>
+            </a:r>
+          </a:p>
+          <a:p>
+            <a:pPr marL="0" indent="0" algn="l">
+              <a:lnSpc>
+                <a:spcPct val="128000"/>
+              </a:lnSpc>
+              <a:spcAft>
+                <a:spcPts val="400"/>
+              </a:spcAft>
+              <a:buNone/>
+            </a:pPr>
+            <a:r>
+              <a:rPr sz="1600" b="0">
+                <a:solidFill>
+                  <a:srgbClr val="000000"/>
+                </a:solidFill>
+                <a:latin typeface="Arial"/>
+              </a:rPr>
+              <a:t>Two ways out of bench 01's compromise.</a:t>
+            </a:r>
+          </a:p>
+          <a:p>
+            <a:pPr marL="0" indent="0" algn="l">
+              <a:lnSpc>
+                <a:spcPct val="128000"/>
+              </a:lnSpc>
+              <a:spcAft>
+                <a:spcPts val="0"/>
+              </a:spcAft>
+              <a:buNone/>
+            </a:pPr>
+          </a:p>
+          <a:p>
+            <a:pPr marL="0" indent="0" algn="l">
+              <a:lnSpc>
+                <a:spcPct val="128000"/>
+              </a:lnSpc>
+              <a:spcAft>
+                <a:spcPts val="400"/>
+              </a:spcAft>
+              <a:buNone/>
+            </a:pPr>
+            <a:r>
+              <a:rPr sz="1600" b="0">
+                <a:solidFill>
+                  <a:srgbClr val="000000"/>
+                </a:solidFill>
+                <a:latin typeface="Arial"/>
+              </a:rPr>
+              <a:t>LRA: resonance in 5 ms, stops just as fast.</a:t>
+            </a:r>
+          </a:p>
+          <a:p>
+            <a:pPr marL="0" indent="0" algn="l">
+              <a:lnSpc>
+                <a:spcPct val="128000"/>
+              </a:lnSpc>
+              <a:spcAft>
+                <a:spcPts val="400"/>
+              </a:spcAft>
+              <a:buNone/>
+            </a:pPr>
+            <a:r>
+              <a:rPr sz="1600" b="0">
+                <a:solidFill>
+                  <a:srgbClr val="000000"/>
+                </a:solidFill>
+                <a:latin typeface="Arial"/>
+              </a:rPr>
+              <a:t>The phone-keyboard feel.</a:t>
+            </a:r>
+          </a:p>
+          <a:p>
+            <a:pPr marL="0" indent="0" algn="l">
+              <a:lnSpc>
+                <a:spcPct val="128000"/>
+              </a:lnSpc>
+              <a:spcAft>
+                <a:spcPts val="0"/>
+              </a:spcAft>
+              <a:buNone/>
+            </a:pPr>
+          </a:p>
+          <a:p>
+            <a:pPr marL="0" indent="0" algn="l">
+              <a:lnSpc>
+                <a:spcPct val="128000"/>
+              </a:lnSpc>
+              <a:spcAft>
+                <a:spcPts val="400"/>
+              </a:spcAft>
+              <a:buNone/>
+            </a:pPr>
+            <a:r>
+              <a:rPr sz="1600" b="0">
+                <a:solidFill>
+                  <a:srgbClr val="000000"/>
+                </a:solidFill>
+                <a:latin typeface="Arial"/>
+              </a:rPr>
+              <a:t>Piezo: near-instant, almost no power.</a:t>
+            </a:r>
+          </a:p>
+          <a:p>
+            <a:pPr marL="0" indent="0" algn="l">
+              <a:lnSpc>
+                <a:spcPct val="128000"/>
+              </a:lnSpc>
+              <a:spcAft>
+                <a:spcPts val="400"/>
+              </a:spcAft>
+              <a:buNone/>
+            </a:pPr>
+            <a:r>
+              <a:rPr sz="1600" b="0">
+                <a:solidFill>
+                  <a:srgbClr val="000000"/>
+                </a:solidFill>
+                <a:latin typeface="Arial"/>
+              </a:rPr>
+              <a:t>A tick, not a thump.</a:t>
+            </a:r>
+          </a:p>
+          <a:p>
+            <a:pPr marL="0" indent="0" algn="l">
+              <a:lnSpc>
+                <a:spcPct val="128000"/>
+              </a:lnSpc>
+              <a:spcAft>
                 <a:spcPts val="1000"/>
-              </a:spcAft>
-              <a:buNone/>
-            </a:pPr>
-            <a:r>
-              <a:rPr sz="1000" b="1">
-                <a:solidFill>
-                  <a:srgbClr val="595959"/>
-                </a:solidFill>
-                <a:latin typeface="Arial"/>
-              </a:rPr>
-              <a:t>VIBRATION</a:t>
-            </a:r>
-          </a:p>
-          <a:p>
-            <a:pPr marL="0" indent="0" algn="l">
-              <a:lnSpc>
-                <a:spcPct val="128000"/>
-              </a:lnSpc>
-              <a:spcAft>
-                <a:spcPts val="900"/>
-              </a:spcAft>
-              <a:buNone/>
-            </a:pPr>
-            <a:r>
-              <a:rPr sz="1600" b="0">
-                <a:solidFill>
-                  <a:srgbClr val="000000"/>
-                </a:solidFill>
-                <a:latin typeface="Arial"/>
-              </a:rPr>
-              <a:t>Two ways out of the ERM's compromise.</a:t>
-            </a:r>
-          </a:p>
-          <a:p>
-            <a:pPr marL="0" indent="0" algn="l">
-              <a:lnSpc>
-                <a:spcPct val="128000"/>
-              </a:lnSpc>
-              <a:spcAft>
-                <a:spcPts val="900"/>
-              </a:spcAft>
-              <a:buNone/>
-            </a:pPr>
-            <a:r>
-              <a:rPr sz="1600" b="0">
-                <a:solidFill>
-                  <a:srgbClr val="000000"/>
-                </a:solidFill>
-                <a:latin typeface="Arial"/>
-              </a:rPr>
-              <a:t>The LRA hits resonance in about 5 ms and stops just as fast, which is why phone keyboards use it.</a:t>
-            </a:r>
-          </a:p>
-          <a:p>
-            <a:pPr marL="0" indent="0" algn="l">
-              <a:lnSpc>
-                <a:spcPct val="128000"/>
-              </a:lnSpc>
-              <a:spcAft>
-                <a:spcPts val="900"/>
-              </a:spcAft>
-              <a:buNone/>
-            </a:pPr>
-            <a:r>
-              <a:rPr sz="1600" b="0">
-                <a:solidFill>
-                  <a:srgbClr val="000000"/>
-                </a:solidFill>
-                <a:latin typeface="Arial"/>
-              </a:rPr>
-              <a:t>The piezo is a crystal that flexes when you put current across it. Near-instant, almost no power, but shallow. A tick, not a thump.</a:t>
-            </a:r>
-          </a:p>
-          <a:p>
-            <a:pPr marL="0" indent="0" algn="l">
-              <a:lnSpc>
-                <a:spcPct val="128000"/>
-              </a:lnSpc>
-              <a:spcAft>
-                <a:spcPts val="400"/>
               </a:spcAft>
               <a:buNone/>
             </a:pPr>
@@ -9192,67 +9620,118 @@
                 <a:spcPct val="128000"/>
               </a:lnSpc>
               <a:spcAft>
+                <a:spcPts val="1200"/>
+              </a:spcAft>
+              <a:buNone/>
+            </a:pPr>
+            <a:r>
+              <a:rPr sz="1000" b="1">
+                <a:solidFill>
+                  <a:srgbClr val="595959"/>
+                </a:solidFill>
+                <a:latin typeface="Arial"/>
+              </a:rPr>
+              <a:t>IMPACT</a:t>
+            </a:r>
+          </a:p>
+          <a:p>
+            <a:pPr marL="0" indent="0" algn="l">
+              <a:lnSpc>
+                <a:spcPct val="128000"/>
+              </a:lnSpc>
+              <a:spcAft>
+                <a:spcPts val="400"/>
+              </a:spcAft>
+              <a:buNone/>
+            </a:pPr>
+            <a:r>
+              <a:rPr sz="1600" b="0">
+                <a:solidFill>
+                  <a:srgbClr val="000000"/>
+                </a:solidFill>
+                <a:latin typeface="Arial"/>
+              </a:rPr>
+              <a:t>One 15 ms pulse against a fingertip.</a:t>
+            </a:r>
+          </a:p>
+          <a:p>
+            <a:pPr marL="0" indent="0" algn="l">
+              <a:lnSpc>
+                <a:spcPct val="128000"/>
+              </a:lnSpc>
+              <a:spcAft>
+                <a:spcPts val="0"/>
+              </a:spcAft>
+              <a:buNone/>
+            </a:pPr>
+          </a:p>
+          <a:p>
+            <a:pPr marL="0" indent="0" algn="l">
+              <a:lnSpc>
+                <a:spcPct val="128000"/>
+              </a:lnSpc>
+              <a:spcAft>
+                <a:spcPts val="400"/>
+              </a:spcAft>
+              <a:buNone/>
+            </a:pPr>
+            <a:r>
+              <a:rPr sz="1600" b="0">
+                <a:solidFill>
+                  <a:srgbClr val="000000"/>
+                </a:solidFill>
+                <a:latin typeface="Arial"/>
+              </a:rPr>
+              <a:t>The bench everyone remembers.</a:t>
+            </a:r>
+          </a:p>
+          <a:p>
+            <a:pPr marL="0" indent="0" algn="l">
+              <a:lnSpc>
+                <a:spcPct val="128000"/>
+              </a:lnSpc>
+              <a:spcAft>
+                <a:spcPts val="400"/>
+              </a:spcAft>
+              <a:buNone/>
+            </a:pPr>
+            <a:r>
+              <a:rPr sz="1600" b="0">
+                <a:solidFill>
+                  <a:srgbClr val="000000"/>
+                </a:solidFill>
+                <a:latin typeface="Arial"/>
+              </a:rPr>
+              <a:t>A knock reads as a person tapping you.</a:t>
+            </a:r>
+          </a:p>
+          <a:p>
+            <a:pPr marL="0" indent="0" algn="l">
+              <a:lnSpc>
+                <a:spcPct val="128000"/>
+              </a:lnSpc>
+              <a:spcAft>
+                <a:spcPts val="400"/>
+              </a:spcAft>
+              <a:buNone/>
+            </a:pPr>
+            <a:r>
+              <a:rPr sz="1600" b="0">
+                <a:solidFill>
+                  <a:srgbClr val="000000"/>
+                </a:solidFill>
+                <a:latin typeface="Arial"/>
+              </a:rPr>
+              <a:t>Buzzing reads as a machine.</a:t>
+            </a:r>
+          </a:p>
+          <a:p>
+            <a:pPr marL="0" indent="0" algn="l">
+              <a:lnSpc>
+                <a:spcPct val="128000"/>
+              </a:lnSpc>
+              <a:spcAft>
                 <a:spcPts val="1000"/>
-              </a:spcAft>
-              <a:buNone/>
-            </a:pPr>
-            <a:r>
-              <a:rPr sz="1000" b="1">
-                <a:solidFill>
-                  <a:srgbClr val="595959"/>
-                </a:solidFill>
-                <a:latin typeface="Arial"/>
-              </a:rPr>
-              <a:t>IMPACT</a:t>
-            </a:r>
-          </a:p>
-          <a:p>
-            <a:pPr marL="0" indent="0" algn="l">
-              <a:lnSpc>
-                <a:spcPct val="128000"/>
-              </a:lnSpc>
-              <a:spcAft>
-                <a:spcPts val="900"/>
-              </a:spcAft>
-              <a:buNone/>
-            </a:pPr>
-            <a:r>
-              <a:rPr sz="1600" b="0">
-                <a:solidFill>
-                  <a:srgbClr val="000000"/>
-                </a:solidFill>
-                <a:latin typeface="Arial"/>
-              </a:rPr>
-              <a:t>A push-pull solenoid firing a single 15 ms pulse against a fingertip.</a:t>
-            </a:r>
-          </a:p>
-          <a:p>
-            <a:pPr marL="0" indent="0" algn="l">
-              <a:lnSpc>
-                <a:spcPct val="128000"/>
-              </a:lnSpc>
-              <a:spcAft>
-                <a:spcPts val="900"/>
-              </a:spcAft>
-              <a:buNone/>
-            </a:pPr>
-            <a:r>
-              <a:rPr sz="1600" b="0">
-                <a:solidFill>
-                  <a:srgbClr val="000000"/>
-                </a:solidFill>
-                <a:latin typeface="Arial"/>
-              </a:rPr>
-              <a:t>This is the bench everyone remembers. A single knock carries urgency that no amount of buzzing does, because it reads as a person tapping you rather than a machine signalling.</a:t>
-            </a:r>
-          </a:p>
-          <a:p>
-            <a:pPr marL="0" indent="0" algn="l">
-              <a:lnSpc>
-                <a:spcPct val="128000"/>
-              </a:lnSpc>
-              <a:spcAft>
-                <a:spcPts val="400"/>
               </a:spcAft>
               <a:buNone/>
             </a:pPr>
@@ -9551,87 +10030,129 @@
                 <a:spcPct val="128000"/>
               </a:lnSpc>
               <a:spcAft>
+                <a:spcPts val="1200"/>
+              </a:spcAft>
+              <a:buNone/>
+            </a:pPr>
+            <a:r>
+              <a:rPr sz="1000" b="1">
+                <a:solidFill>
+                  <a:srgbClr val="595959"/>
+                </a:solidFill>
+                <a:latin typeface="Arial"/>
+              </a:rPr>
+              <a:t>TOUCH INPUT</a:t>
+            </a:r>
+          </a:p>
+          <a:p>
+            <a:pPr marL="0" indent="0" algn="l">
+              <a:lnSpc>
+                <a:spcPct val="128000"/>
+              </a:lnSpc>
+              <a:spcAft>
+                <a:spcPts val="400"/>
+              </a:spcAft>
+              <a:buNone/>
+            </a:pPr>
+            <a:r>
+              <a:rPr sz="1600" b="0">
+                <a:solidFill>
+                  <a:srgbClr val="000000"/>
+                </a:solidFill>
+                <a:latin typeface="Arial"/>
+              </a:rPr>
+              <a:t>Bare finger on a surface. Servos react.</a:t>
+            </a:r>
+          </a:p>
+          <a:p>
+            <a:pPr marL="0" indent="0" algn="l">
+              <a:lnSpc>
+                <a:spcPct val="128000"/>
+              </a:lnSpc>
+              <a:spcAft>
+                <a:spcPts val="0"/>
+              </a:spcAft>
+              <a:buNone/>
+            </a:pPr>
+          </a:p>
+          <a:p>
+            <a:pPr marL="0" indent="0" algn="l">
+              <a:lnSpc>
+                <a:spcPct val="128000"/>
+              </a:lnSpc>
+              <a:spcAft>
+                <a:spcPts val="400"/>
+              </a:spcAft>
+              <a:buNone/>
+            </a:pPr>
+            <a:r>
+              <a:rPr sz="1600" b="0">
+                <a:solidFill>
+                  <a:srgbClr val="000000"/>
+                </a:solidFill>
+                <a:latin typeface="Arial"/>
+              </a:rPr>
+              <a:t>No button. No sensor you can point at.</a:t>
+            </a:r>
+          </a:p>
+          <a:p>
+            <a:pPr marL="0" indent="0" algn="l">
+              <a:lnSpc>
+                <a:spcPct val="128000"/>
+              </a:lnSpc>
+              <a:spcAft>
+                <a:spcPts val="400"/>
+              </a:spcAft>
+              <a:buNone/>
+            </a:pPr>
+            <a:r>
+              <a:rPr sz="1600" b="0">
+                <a:solidFill>
+                  <a:srgbClr val="000000"/>
+                </a:solidFill>
+                <a:latin typeface="Arial"/>
+              </a:rPr>
+              <a:t>The input is a wire behind a plate.</a:t>
+            </a:r>
+          </a:p>
+          <a:p>
+            <a:pPr marL="0" indent="0" algn="l">
+              <a:lnSpc>
+                <a:spcPct val="128000"/>
+              </a:lnSpc>
+              <a:spcAft>
+                <a:spcPts val="0"/>
+              </a:spcAft>
+              <a:buNone/>
+            </a:pPr>
+          </a:p>
+          <a:p>
+            <a:pPr marL="0" indent="0" algn="l">
+              <a:lnSpc>
+                <a:spcPct val="128000"/>
+              </a:lnSpc>
+              <a:spcAft>
+                <a:spcPts val="400"/>
+              </a:spcAft>
+              <a:buNone/>
+            </a:pPr>
+            <a:r>
+              <a:rPr sz="1600" b="0">
+                <a:solidFill>
+                  <a:srgbClr val="000000"/>
+                </a:solidFill>
+                <a:latin typeface="Arial"/>
+              </a:rPr>
+              <a:t>Foil, card, fabric. Anything works.</a:t>
+            </a:r>
+          </a:p>
+          <a:p>
+            <a:pPr marL="0" indent="0" algn="l">
+              <a:lnSpc>
+                <a:spcPct val="128000"/>
+              </a:lnSpc>
+              <a:spcAft>
                 <a:spcPts val="1000"/>
-              </a:spcAft>
-              <a:buNone/>
-            </a:pPr>
-            <a:r>
-              <a:rPr sz="1000" b="1">
-                <a:solidFill>
-                  <a:srgbClr val="595959"/>
-                </a:solidFill>
-                <a:latin typeface="Arial"/>
-              </a:rPr>
-              <a:t>TOUCH INPUT</a:t>
-            </a:r>
-          </a:p>
-          <a:p>
-            <a:pPr marL="0" indent="0" algn="l">
-              <a:lnSpc>
-                <a:spcPct val="128000"/>
-              </a:lnSpc>
-              <a:spcAft>
-                <a:spcPts val="900"/>
-              </a:spcAft>
-              <a:buNone/>
-            </a:pPr>
-            <a:r>
-              <a:rPr sz="1600" b="0">
-                <a:solidFill>
-                  <a:srgbClr val="000000"/>
-                </a:solidFill>
-                <a:latin typeface="Arial"/>
-              </a:rPr>
-              <a:t>Touch a surface with a bare finger and the servos react.</a:t>
-            </a:r>
-          </a:p>
-          <a:p>
-            <a:pPr marL="0" indent="0" algn="l">
-              <a:lnSpc>
-                <a:spcPct val="128000"/>
-              </a:lnSpc>
-              <a:spcAft>
-                <a:spcPts val="900"/>
-              </a:spcAft>
-              <a:buNone/>
-            </a:pPr>
-            <a:r>
-              <a:rPr sz="1600" b="0">
-                <a:solidFill>
-                  <a:srgbClr val="000000"/>
-                </a:solidFill>
-                <a:latin typeface="Arial"/>
-              </a:rPr>
-              <a:t>There is no button and no sensor you can point at. The input is a wire taped behind a plate, read on an analogue pin.</a:t>
-            </a:r>
-          </a:p>
-          <a:p>
-            <a:pPr marL="0" indent="0" algn="l">
-              <a:lnSpc>
-                <a:spcPct val="128000"/>
-              </a:lnSpc>
-              <a:spcAft>
-                <a:spcPts val="900"/>
-              </a:spcAft>
-              <a:buNone/>
-            </a:pPr>
-            <a:r>
-              <a:rPr sz="1600" b="0">
-                <a:solidFill>
-                  <a:srgbClr val="000000"/>
-                </a:solidFill>
-                <a:latin typeface="Arial"/>
-              </a:rPr>
-              <a:t>Any surface can become an input this way: foil, card, fabric.</a:t>
-            </a:r>
-          </a:p>
-          <a:p>
-            <a:pPr marL="0" indent="0" algn="l">
-              <a:lnSpc>
-                <a:spcPct val="128000"/>
-              </a:lnSpc>
-              <a:spcAft>
-                <a:spcPts val="400"/>
               </a:spcAft>
               <a:buNone/>
             </a:pPr>

</xml_diff>

<commit_message>
Move to labtools-au: update the repo URL printed on the slides
Transferred to the labtools-au org, where the rest of the Labtools work lives
(event bus, dashboard, protolab hub, signups). GitHub redirects the old URL,
but the deck prints it on the closing slide and in the task-sketches slide, so
those had to change or students would type the personal account.

Claude-Session: https://claude.ai/code/session_01CH1MfHfgJbuQetj7pMqMXE
</commit_message>
<xml_diff>
--- a/docs/multimodal-actuator-workshop.pptx
+++ b/docs/multimodal-actuator-workshop.pptx
@@ -12532,7 +12532,7 @@
                 </a:solidFill>
                 <a:latin typeface="Arial"/>
               </a:rPr>
-              <a:t>github.com/gust1527/multimodal-actuator-workshop</a:t>
+              <a:t>github.com/labtools-au/multimodal-actuator-workshop</a:t>
             </a:r>
           </a:p>
         </p:txBody>
@@ -13731,7 +13731,7 @@
                 </a:solidFill>
                 <a:latin typeface="Arial"/>
               </a:rPr>
-              <a:t>github.com/gust1527/multimodal-actuator-workshop</a:t>
+              <a:t>github.com/labtools-au/multimodal-actuator-workshop</a:t>
             </a:r>
           </a:p>
         </p:txBody>

</xml_diff>

<commit_message>
Point task 06 at the hosted sensor playground
Live at sensors.chomskylab.dk, deployed on the labtools server from
labtools-au/labtools-sensor-playground. Hosting it removes the HTTPS problem
that made the local file version fail confusingly: DeviceMotion and
getUserMedia both need a secure context.

Deck now tells students to open it on their phones during the sensors slide,
which lands harder than describing it.

Claude-Session: https://claude.ai/code/session_01CH1MfHfgJbuQetj7pMqMXE
</commit_message>
<xml_diff>
--- a/docs/multimodal-actuator-workshop.pptx
+++ b/docs/multimodal-actuator-workshop.pptx
@@ -10456,6 +10456,37 @@
                 </a:solidFill>
                 <a:latin typeface="Arial"/>
               </a:rPr>
+              <a:t>Open sensors.chomskylab.dk on your phone right now</a:t>
+            </a:r>
+          </a:p>
+          <a:p>
+            <a:pPr marL="0" indent="0" algn="l">
+              <a:lnSpc>
+                <a:spcPct val="128000"/>
+              </a:lnSpc>
+              <a:spcAft>
+                <a:spcPts val="0"/>
+              </a:spcAft>
+              <a:buNone/>
+            </a:pPr>
+          </a:p>
+          <a:p>
+            <a:pPr marL="0" indent="0" algn="l">
+              <a:lnSpc>
+                <a:spcPct val="128000"/>
+              </a:lnSpc>
+              <a:spcAft>
+                <a:spcPts val="600"/>
+              </a:spcAft>
+              <a:buNone/>
+            </a:pPr>
+            <a:r>
+              <a:rPr sz="1700" b="1">
+                <a:solidFill>
+                  <a:srgbClr val="000000"/>
+                </a:solidFill>
+                <a:latin typeface="Arial"/>
+              </a:rPr>
               <a:t>Works in a web page today</a:t>
             </a:r>
           </a:p>
@@ -13406,7 +13437,7 @@
                 </a:solidFill>
                 <a:latin typeface="Arial"/>
               </a:rPr>
-              <a:t>06   Use what you have          your own phone</a:t>
+              <a:t>06   Use what you have          sensors.chomskylab.dk</a:t>
             </a:r>
           </a:p>
           <a:p>

</xml_diff>

<commit_message>
Fix text colliding with the AU wordmark on six slides
Rendered all 30 slides and measured dark pixels on the exact rows the footer
wordmark occupies, rather than eyeballing. Six slides had body text printing
over the logo: How today works, Five tasks, How the sketches work, Why come,
The one that surprises people, and The brief.

Fixed by tightening paragraph spacing globally (6pt to 4pt after each line,
lead 14 to 12) and trimming the longest sub-lines, rather than shrinking type.

Verified clean: zero slides now have text on the wordmark.

Also aligned the task sketches with the deck. They still said "WIRING (bench
01)" from before the bench rotation was dropped, which would have confused
anyone reading the code after the slides. All 14 sketches still pass the
syntax check.

Claude-Session: https://claude.ai/code/session_01CH1MfHfgJbuQetj7pMqMXE
</commit_message>
<xml_diff>
--- a/docs/multimodal-actuator-workshop.pptx
+++ b/docs/multimodal-actuator-workshop.pptx
@@ -8574,7 +8574,7 @@
                 <a:spcPct val="128000"/>
               </a:lnSpc>
               <a:spcAft>
-                <a:spcPts val="1400"/>
+                <a:spcPts val="1200"/>
               </a:spcAft>
               <a:buNone/>
             </a:pPr>
@@ -8594,7 +8594,7 @@
                 <a:spcPct val="128000"/>
               </a:lnSpc>
               <a:spcAft>
-                <a:spcPts val="600"/>
+                <a:spcPts val="400"/>
               </a:spcAft>
               <a:buNone/>
             </a:pPr>
@@ -8605,7 +8605,7 @@
                 </a:solidFill>
                 <a:latin typeface="Arial"/>
               </a:rPr>
-              <a:t>If you want to drive something not in front of you, go and get it.</a:t>
+              <a:t>If you want to drive something not in front of you, go get it.</a:t>
             </a:r>
           </a:p>
           <a:p>
@@ -8614,10 +8614,19 @@
                 <a:spcPct val="128000"/>
               </a:lnSpc>
               <a:spcAft>
-                <a:spcPts val="0"/>
-              </a:spcAft>
-              <a:buNone/>
-            </a:pPr>
+                <a:spcPts val="400"/>
+              </a:spcAft>
+              <a:buNone/>
+            </a:pPr>
+            <a:r>
+              <a:rPr sz="1700" b="1">
+                <a:solidFill>
+                  <a:srgbClr val="000000"/>
+                </a:solidFill>
+                <a:latin typeface="Arial"/>
+              </a:rPr>
+              <a:t>The three things that are not negotiable</a:t>
+            </a:r>
           </a:p>
           <a:p>
             <a:pPr marL="0" indent="0" algn="l">
@@ -8625,18 +8634,18 @@
                 <a:spcPct val="128000"/>
               </a:lnSpc>
               <a:spcAft>
-                <a:spcPts val="600"/>
-              </a:spcAft>
-              <a:buNone/>
-            </a:pPr>
-            <a:r>
-              <a:rPr sz="1700" b="1">
-                <a:solidFill>
-                  <a:srgbClr val="000000"/>
-                </a:solidFill>
-                <a:latin typeface="Arial"/>
-              </a:rPr>
-              <a:t>The three things that are not negotiable</a:t>
+                <a:spcPts val="400"/>
+              </a:spcAft>
+              <a:buNone/>
+            </a:pPr>
+            <a:r>
+              <a:rPr sz="1500" b="0">
+                <a:solidFill>
+                  <a:srgbClr val="000000"/>
+                </a:solidFill>
+                <a:latin typeface="Arial"/>
+              </a:rPr>
+              <a:t>• Solenoid and Peltier get their own supply, never USB</a:t>
             </a:r>
           </a:p>
           <a:p>
@@ -8645,7 +8654,7 @@
                 <a:spcPct val="128000"/>
               </a:lnSpc>
               <a:spcAft>
-                <a:spcPts val="600"/>
+                <a:spcPts val="400"/>
               </a:spcAft>
               <a:buNone/>
             </a:pPr>
@@ -8656,7 +8665,7 @@
                 </a:solidFill>
                 <a:latin typeface="Arial"/>
               </a:rPr>
-              <a:t>• Solenoid and Peltier get their own supply, never USB</a:t>
+              <a:t>• The Peltier heatsink goes on before it is switched on</a:t>
             </a:r>
           </a:p>
           <a:p>
@@ -8665,27 +8674,7 @@
                 <a:spcPct val="128000"/>
               </a:lnSpc>
               <a:spcAft>
-                <a:spcPts val="600"/>
-              </a:spcAft>
-              <a:buNone/>
-            </a:pPr>
-            <a:r>
-              <a:rPr sz="1500" b="0">
-                <a:solidFill>
-                  <a:srgbClr val="000000"/>
-                </a:solidFill>
-                <a:latin typeface="Arial"/>
-              </a:rPr>
-              <a:t>• The Peltier heatsink goes on before it is switched on</a:t>
-            </a:r>
-          </a:p>
-          <a:p>
-            <a:pPr marL="0" indent="0" algn="l">
-              <a:lnSpc>
-                <a:spcPct val="128000"/>
-              </a:lnSpc>
-              <a:spcAft>
-                <a:spcPts val="600"/>
+                <a:spcPts val="400"/>
               </a:spcAft>
               <a:buNone/>
             </a:pPr>
@@ -8817,7 +8806,7 @@
                 <a:spcPct val="128000"/>
               </a:lnSpc>
               <a:spcAft>
-                <a:spcPts val="1400"/>
+                <a:spcPts val="1200"/>
               </a:spcAft>
               <a:buNone/>
             </a:pPr>
@@ -8837,7 +8826,7 @@
                 <a:spcPct val="128000"/>
               </a:lnSpc>
               <a:spcAft>
-                <a:spcPts val="600"/>
+                <a:spcPts val="400"/>
               </a:spcAft>
               <a:buNone/>
             </a:pPr>
@@ -8857,10 +8846,19 @@
                 <a:spcPct val="128000"/>
               </a:lnSpc>
               <a:spcAft>
-                <a:spcPts val="0"/>
-              </a:spcAft>
-              <a:buNone/>
-            </a:pPr>
+                <a:spcPts val="400"/>
+              </a:spcAft>
+              <a:buNone/>
+            </a:pPr>
+            <a:r>
+              <a:rPr sz="1700" b="1">
+                <a:solidFill>
+                  <a:srgbClr val="000000"/>
+                </a:solidFill>
+                <a:latin typeface="Arial"/>
+              </a:rPr>
+              <a:t>Threshold is relative, never absolute</a:t>
+            </a:r>
           </a:p>
           <a:p>
             <a:pPr marL="0" indent="0" algn="l">
@@ -8868,7 +8866,47 @@
                 <a:spcPct val="128000"/>
               </a:lnSpc>
               <a:spcAft>
-                <a:spcPts val="600"/>
+                <a:spcPts val="400"/>
+              </a:spcAft>
+              <a:buNone/>
+            </a:pPr>
+            <a:r>
+              <a:rPr sz="1500" b="0">
+                <a:solidFill>
+                  <a:srgbClr val="000000"/>
+                </a:solidFill>
+                <a:latin typeface="Arial"/>
+              </a:rPr>
+              <a:t>• Readings drift with humidity and mains hum</a:t>
+            </a:r>
+          </a:p>
+          <a:p>
+            <a:pPr marL="0" indent="0" algn="l">
+              <a:lnSpc>
+                <a:spcPct val="128000"/>
+              </a:lnSpc>
+              <a:spcAft>
+                <a:spcPts val="400"/>
+              </a:spcAft>
+              <a:buNone/>
+            </a:pPr>
+            <a:r>
+              <a:rPr sz="1500" b="0">
+                <a:solidFill>
+                  <a:srgbClr val="000000"/>
+                </a:solidFill>
+                <a:latin typeface="Arial"/>
+              </a:rPr>
+              <a:t>• Fixed threshold works at 9am, fails at 1pm</a:t>
+            </a:r>
+          </a:p>
+          <a:p>
+            <a:pPr marL="0" indent="0" algn="l">
+              <a:lnSpc>
+                <a:spcPct val="128000"/>
+              </a:lnSpc>
+              <a:spcAft>
+                <a:spcPts val="400"/>
               </a:spcAft>
               <a:buNone/>
             </a:pPr>
@@ -8879,7 +8917,7 @@
                 </a:solidFill>
                 <a:latin typeface="Arial"/>
               </a:rPr>
-              <a:t>Threshold is relative, never absolute</a:t>
+              <a:t>Baseline only learns while untouched</a:t>
             </a:r>
           </a:p>
           <a:p>
@@ -8888,78 +8926,7 @@
                 <a:spcPct val="128000"/>
               </a:lnSpc>
               <a:spcAft>
-                <a:spcPts val="600"/>
-              </a:spcAft>
-              <a:buNone/>
-            </a:pPr>
-            <a:r>
-              <a:rPr sz="1500" b="0">
-                <a:solidFill>
-                  <a:srgbClr val="000000"/>
-                </a:solidFill>
-                <a:latin typeface="Arial"/>
-              </a:rPr>
-              <a:t>• Readings drift with humidity and mains hum</a:t>
-            </a:r>
-          </a:p>
-          <a:p>
-            <a:pPr marL="0" indent="0" algn="l">
-              <a:lnSpc>
-                <a:spcPct val="128000"/>
-              </a:lnSpc>
-              <a:spcAft>
-                <a:spcPts val="600"/>
-              </a:spcAft>
-              <a:buNone/>
-            </a:pPr>
-            <a:r>
-              <a:rPr sz="1500" b="0">
-                <a:solidFill>
-                  <a:srgbClr val="000000"/>
-                </a:solidFill>
-                <a:latin typeface="Arial"/>
-              </a:rPr>
-              <a:t>• Fixed threshold works at 9am, fails at 1pm</a:t>
-            </a:r>
-          </a:p>
-          <a:p>
-            <a:pPr marL="0" indent="0" algn="l">
-              <a:lnSpc>
-                <a:spcPct val="128000"/>
-              </a:lnSpc>
-              <a:spcAft>
-                <a:spcPts val="0"/>
-              </a:spcAft>
-              <a:buNone/>
-            </a:pPr>
-          </a:p>
-          <a:p>
-            <a:pPr marL="0" indent="0" algn="l">
-              <a:lnSpc>
-                <a:spcPct val="128000"/>
-              </a:lnSpc>
-              <a:spcAft>
-                <a:spcPts val="600"/>
-              </a:spcAft>
-              <a:buNone/>
-            </a:pPr>
-            <a:r>
-              <a:rPr sz="1700" b="1">
-                <a:solidFill>
-                  <a:srgbClr val="000000"/>
-                </a:solidFill>
-                <a:latin typeface="Arial"/>
-              </a:rPr>
-              <a:t>Baseline only learns while untouched</a:t>
-            </a:r>
-          </a:p>
-          <a:p>
-            <a:pPr marL="0" indent="0" algn="l">
-              <a:lnSpc>
-                <a:spcPct val="128000"/>
-              </a:lnSpc>
-              <a:spcAft>
-                <a:spcPts val="600"/>
+                <a:spcPts val="400"/>
               </a:spcAft>
               <a:buNone/>
             </a:pPr>
@@ -9091,7 +9058,7 @@
                 <a:spcPct val="128000"/>
               </a:lnSpc>
               <a:spcAft>
-                <a:spcPts val="1400"/>
+                <a:spcPts val="1200"/>
               </a:spcAft>
               <a:buNone/>
             </a:pPr>
@@ -9111,7 +9078,7 @@
                 <a:spcPct val="128000"/>
               </a:lnSpc>
               <a:spcAft>
-                <a:spcPts val="600"/>
+                <a:spcPts val="400"/>
               </a:spcAft>
               <a:buNone/>
             </a:pPr>
@@ -9131,7 +9098,7 @@
                 <a:spcPct val="128000"/>
               </a:lnSpc>
               <a:spcAft>
-                <a:spcPts val="600"/>
+                <a:spcPts val="400"/>
               </a:spcAft>
               <a:buNone/>
             </a:pPr>
@@ -9151,7 +9118,7 @@
                 <a:spcPct val="128000"/>
               </a:lnSpc>
               <a:spcAft>
-                <a:spcPts val="600"/>
+                <a:spcPts val="400"/>
               </a:spcAft>
               <a:buNone/>
             </a:pPr>
@@ -9171,7 +9138,7 @@
                 <a:spcPct val="128000"/>
               </a:lnSpc>
               <a:spcAft>
-                <a:spcPts val="600"/>
+                <a:spcPts val="400"/>
               </a:spcAft>
               <a:buNone/>
             </a:pPr>
@@ -9191,7 +9158,7 @@
                 <a:spcPct val="128000"/>
               </a:lnSpc>
               <a:spcAft>
-                <a:spcPts val="600"/>
+                <a:spcPts val="400"/>
               </a:spcAft>
               <a:buNone/>
             </a:pPr>
@@ -9419,7 +9386,7 @@
                 <a:spcPct val="128000"/>
               </a:lnSpc>
               <a:spcAft>
-                <a:spcPts val="1400"/>
+                <a:spcPts val="1200"/>
               </a:spcAft>
               <a:buNone/>
             </a:pPr>
@@ -9439,7 +9406,7 @@
                 <a:spcPct val="128000"/>
               </a:lnSpc>
               <a:spcAft>
-                <a:spcPts val="600"/>
+                <a:spcPts val="400"/>
               </a:spcAft>
               <a:buNone/>
             </a:pPr>
@@ -9459,7 +9426,7 @@
                 <a:spcPct val="128000"/>
               </a:lnSpc>
               <a:spcAft>
-                <a:spcPts val="600"/>
+                <a:spcPts val="400"/>
               </a:spcAft>
               <a:buNone/>
             </a:pPr>
@@ -9479,7 +9446,7 @@
                 <a:spcPct val="128000"/>
               </a:lnSpc>
               <a:spcAft>
-                <a:spcPts val="600"/>
+                <a:spcPts val="400"/>
               </a:spcAft>
               <a:buNone/>
             </a:pPr>
@@ -9803,7 +9770,7 @@
                 <a:spcPct val="128000"/>
               </a:lnSpc>
               <a:spcAft>
-                <a:spcPts val="1400"/>
+                <a:spcPts val="1200"/>
               </a:spcAft>
               <a:buNone/>
             </a:pPr>
@@ -9823,7 +9790,7 @@
                 <a:spcPct val="128000"/>
               </a:lnSpc>
               <a:spcAft>
-                <a:spcPts val="600"/>
+                <a:spcPts val="400"/>
               </a:spcAft>
               <a:buNone/>
             </a:pPr>
@@ -9843,7 +9810,7 @@
                 <a:spcPct val="128000"/>
               </a:lnSpc>
               <a:spcAft>
-                <a:spcPts val="600"/>
+                <a:spcPts val="400"/>
               </a:spcAft>
               <a:buNone/>
             </a:pPr>
@@ -9854,7 +9821,7 @@
                 </a:solidFill>
                 <a:latin typeface="Arial"/>
               </a:rPr>
-              <a:t>• A datasheet will not tell you a Peltier takes eight seconds, or that a knock reads as a person and a buzz reads as a machine.</a:t>
+              <a:t>• No datasheet says a knock reads as a person, a buzz as a machine</a:t>
             </a:r>
           </a:p>
           <a:p>
@@ -9863,10 +9830,19 @@
                 <a:spcPct val="128000"/>
               </a:lnSpc>
               <a:spcAft>
-                <a:spcPts val="0"/>
-              </a:spcAft>
-              <a:buNone/>
-            </a:pPr>
+                <a:spcPts val="400"/>
+              </a:spcAft>
+              <a:buNone/>
+            </a:pPr>
+            <a:r>
+              <a:rPr sz="1700" b="1">
+                <a:solidFill>
+                  <a:srgbClr val="000000"/>
+                </a:solidFill>
+                <a:latin typeface="Arial"/>
+              </a:rPr>
+              <a:t>The parts are free and already here</a:t>
+            </a:r>
           </a:p>
           <a:p>
             <a:pPr marL="0" indent="0" algn="l">
@@ -9874,7 +9850,27 @@
                 <a:spcPct val="128000"/>
               </a:lnSpc>
               <a:spcAft>
-                <a:spcPts val="600"/>
+                <a:spcPts val="400"/>
+              </a:spcAft>
+              <a:buNone/>
+            </a:pPr>
+            <a:r>
+              <a:rPr sz="1500" b="0">
+                <a:solidFill>
+                  <a:srgbClr val="000000"/>
+                </a:solidFill>
+                <a:latin typeface="Arial"/>
+              </a:rPr>
+              <a:t>• Borrowing beats ordering. Nothing to buy, nothing to wait for</a:t>
+            </a:r>
+          </a:p>
+          <a:p>
+            <a:pPr marL="0" indent="0" algn="l">
+              <a:lnSpc>
+                <a:spcPct val="128000"/>
+              </a:lnSpc>
+              <a:spcAft>
+                <a:spcPts val="400"/>
               </a:spcAft>
               <a:buNone/>
             </a:pPr>
@@ -9885,7 +9881,7 @@
                 </a:solidFill>
                 <a:latin typeface="Arial"/>
               </a:rPr>
-              <a:t>The parts are free and already here</a:t>
+              <a:t>Your devices hide sensors you may not be able to reach</a:t>
             </a:r>
           </a:p>
           <a:p>
@@ -9894,7 +9890,7 @@
                 <a:spcPct val="128000"/>
               </a:lnSpc>
               <a:spcAft>
-                <a:spcPts val="600"/>
+                <a:spcPts val="400"/>
               </a:spcAft>
               <a:buNone/>
             </a:pPr>
@@ -9905,58 +9901,7 @@
                 </a:solidFill>
                 <a:latin typeface="Arial"/>
               </a:rPr>
-              <a:t>• Borrowing beats ordering. Nothing to buy, nothing to wait for.</a:t>
-            </a:r>
-          </a:p>
-          <a:p>
-            <a:pPr marL="0" indent="0" algn="l">
-              <a:lnSpc>
-                <a:spcPct val="128000"/>
-              </a:lnSpc>
-              <a:spcAft>
-                <a:spcPts val="0"/>
-              </a:spcAft>
-              <a:buNone/>
-            </a:pPr>
-          </a:p>
-          <a:p>
-            <a:pPr marL="0" indent="0" algn="l">
-              <a:lnSpc>
-                <a:spcPct val="128000"/>
-              </a:lnSpc>
-              <a:spcAft>
-                <a:spcPts val="600"/>
-              </a:spcAft>
-              <a:buNone/>
-            </a:pPr>
-            <a:r>
-              <a:rPr sz="1700" b="1">
-                <a:solidFill>
-                  <a:srgbClr val="000000"/>
-                </a:solidFill>
-                <a:latin typeface="Arial"/>
-              </a:rPr>
-              <a:t>Your own devices are full of sensors you cannot reach</a:t>
-            </a:r>
-          </a:p>
-          <a:p>
-            <a:pPr marL="0" indent="0" algn="l">
-              <a:lnSpc>
-                <a:spcPct val="128000"/>
-              </a:lnSpc>
-              <a:spcAft>
-                <a:spcPts val="600"/>
-              </a:spcAft>
-              <a:buNone/>
-            </a:pPr>
-            <a:r>
-              <a:rPr sz="1500" b="0">
-                <a:solidFill>
-                  <a:srgbClr val="000000"/>
-                </a:solidFill>
-                <a:latin typeface="Arial"/>
-              </a:rPr>
-              <a:t>• Find out today which ones open up, and which are locked.</a:t>
+              <a:t>• Find out today which open up, and which are locked</a:t>
             </a:r>
           </a:p>
         </p:txBody>
@@ -10077,7 +10022,7 @@
                 <a:spcPct val="128000"/>
               </a:lnSpc>
               <a:spcAft>
-                <a:spcPts val="1400"/>
+                <a:spcPts val="1200"/>
               </a:spcAft>
               <a:buNone/>
             </a:pPr>
@@ -10097,7 +10042,7 @@
                 <a:spcPct val="128000"/>
               </a:lnSpc>
               <a:spcAft>
-                <a:spcPts val="600"/>
+                <a:spcPts val="400"/>
               </a:spcAft>
               <a:buNone/>
             </a:pPr>
@@ -10117,7 +10062,7 @@
                 <a:spcPct val="128000"/>
               </a:lnSpc>
               <a:spcAft>
-                <a:spcPts val="600"/>
+                <a:spcPts val="400"/>
               </a:spcAft>
               <a:buNone/>
             </a:pPr>
@@ -10137,7 +10082,7 @@
                 <a:spcPct val="128000"/>
               </a:lnSpc>
               <a:spcAft>
-                <a:spcPts val="600"/>
+                <a:spcPts val="400"/>
               </a:spcAft>
               <a:buNone/>
             </a:pPr>
@@ -10157,7 +10102,7 @@
                 <a:spcPct val="128000"/>
               </a:lnSpc>
               <a:spcAft>
-                <a:spcPts val="600"/>
+                <a:spcPts val="400"/>
               </a:spcAft>
               <a:buNone/>
             </a:pPr>
@@ -10177,7 +10122,7 @@
                 <a:spcPct val="128000"/>
               </a:lnSpc>
               <a:spcAft>
-                <a:spcPts val="600"/>
+                <a:spcPts val="400"/>
               </a:spcAft>
               <a:buNone/>
             </a:pPr>
@@ -10197,7 +10142,7 @@
                 <a:spcPct val="128000"/>
               </a:lnSpc>
               <a:spcAft>
-                <a:spcPts val="600"/>
+                <a:spcPts val="400"/>
               </a:spcAft>
               <a:buNone/>
             </a:pPr>
@@ -10217,7 +10162,7 @@
                 <a:spcPct val="128000"/>
               </a:lnSpc>
               <a:spcAft>
-                <a:spcPts val="600"/>
+                <a:spcPts val="400"/>
               </a:spcAft>
               <a:buNone/>
             </a:pPr>
@@ -10237,7 +10182,7 @@
                 <a:spcPct val="128000"/>
               </a:lnSpc>
               <a:spcAft>
-                <a:spcPts val="600"/>
+                <a:spcPts val="400"/>
               </a:spcAft>
               <a:buNone/>
             </a:pPr>
@@ -10369,7 +10314,7 @@
                 <a:spcPct val="128000"/>
               </a:lnSpc>
               <a:spcAft>
-                <a:spcPts val="1400"/>
+                <a:spcPts val="1200"/>
               </a:spcAft>
               <a:buNone/>
             </a:pPr>
@@ -10389,7 +10334,7 @@
                 <a:spcPct val="128000"/>
               </a:lnSpc>
               <a:spcAft>
-                <a:spcPts val="600"/>
+                <a:spcPts val="400"/>
               </a:spcAft>
               <a:buNone/>
             </a:pPr>
@@ -10409,7 +10354,7 @@
                 <a:spcPct val="128000"/>
               </a:lnSpc>
               <a:spcAft>
-                <a:spcPts val="600"/>
+                <a:spcPts val="400"/>
               </a:spcAft>
               <a:buNone/>
             </a:pPr>
@@ -10429,7 +10374,7 @@
                 <a:spcPct val="128000"/>
               </a:lnSpc>
               <a:spcAft>
-                <a:spcPts val="600"/>
+                <a:spcPts val="400"/>
               </a:spcAft>
               <a:buNone/>
             </a:pPr>
@@ -10449,7 +10394,7 @@
                 <a:spcPct val="128000"/>
               </a:lnSpc>
               <a:spcAft>
-                <a:spcPts val="600"/>
+                <a:spcPts val="400"/>
               </a:spcAft>
               <a:buNone/>
             </a:pPr>
@@ -10469,7 +10414,7 @@
                 <a:spcPct val="128000"/>
               </a:lnSpc>
               <a:spcAft>
-                <a:spcPts val="600"/>
+                <a:spcPts val="400"/>
               </a:spcAft>
               <a:buNone/>
             </a:pPr>
@@ -10500,7 +10445,7 @@
                 <a:spcPct val="128000"/>
               </a:lnSpc>
               <a:spcAft>
-                <a:spcPts val="600"/>
+                <a:spcPts val="400"/>
               </a:spcAft>
               <a:buNone/>
             </a:pPr>
@@ -10520,7 +10465,7 @@
                 <a:spcPct val="128000"/>
               </a:lnSpc>
               <a:spcAft>
-                <a:spcPts val="600"/>
+                <a:spcPts val="400"/>
               </a:spcAft>
               <a:buNone/>
             </a:pPr>
@@ -10652,7 +10597,7 @@
                 <a:spcPct val="128000"/>
               </a:lnSpc>
               <a:spcAft>
-                <a:spcPts val="1400"/>
+                <a:spcPts val="1200"/>
               </a:spcAft>
               <a:buNone/>
             </a:pPr>
@@ -10672,7 +10617,7 @@
                 <a:spcPct val="128000"/>
               </a:lnSpc>
               <a:spcAft>
-                <a:spcPts val="600"/>
+                <a:spcPts val="400"/>
               </a:spcAft>
               <a:buNone/>
             </a:pPr>
@@ -10692,7 +10637,7 @@
                 <a:spcPct val="128000"/>
               </a:lnSpc>
               <a:spcAft>
-                <a:spcPts val="600"/>
+                <a:spcPts val="400"/>
               </a:spcAft>
               <a:buNone/>
             </a:pPr>
@@ -10712,7 +10657,7 @@
                 <a:spcPct val="128000"/>
               </a:lnSpc>
               <a:spcAft>
-                <a:spcPts val="600"/>
+                <a:spcPts val="400"/>
               </a:spcAft>
               <a:buNone/>
             </a:pPr>
@@ -10732,10 +10677,19 @@
                 <a:spcPct val="128000"/>
               </a:lnSpc>
               <a:spcAft>
-                <a:spcPts val="0"/>
-              </a:spcAft>
-              <a:buNone/>
-            </a:pPr>
+                <a:spcPts val="400"/>
+              </a:spcAft>
+              <a:buNone/>
+            </a:pPr>
+            <a:r>
+              <a:rPr sz="1700" b="1">
+                <a:solidFill>
+                  <a:srgbClr val="000000"/>
+                </a:solidFill>
+                <a:latin typeface="Arial"/>
+              </a:rPr>
+              <a:t>Instrumented sock, ESP32</a:t>
+            </a:r>
           </a:p>
           <a:p>
             <a:pPr marL="0" indent="0" algn="l">
@@ -10743,18 +10697,18 @@
                 <a:spcPct val="128000"/>
               </a:lnSpc>
               <a:spcAft>
-                <a:spcPts val="600"/>
-              </a:spcAft>
-              <a:buNone/>
-            </a:pPr>
-            <a:r>
-              <a:rPr sz="1700" b="1">
-                <a:solidFill>
-                  <a:srgbClr val="000000"/>
-                </a:solidFill>
-                <a:latin typeface="Arial"/>
-              </a:rPr>
-              <a:t>Instrumented sock, ESP32</a:t>
+                <a:spcPts val="400"/>
+              </a:spcAft>
+              <a:buNone/>
+            </a:pPr>
+            <a:r>
+              <a:rPr sz="1500" b="0">
+                <a:solidFill>
+                  <a:srgbClr val="000000"/>
+                </a:solidFill>
+                <a:latin typeface="Arial"/>
+              </a:rPr>
+              <a:t>• Six force sensors under a foot, batched over Wi-Fi</a:t>
             </a:r>
           </a:p>
           <a:p>
@@ -10763,27 +10717,7 @@
                 <a:spcPct val="128000"/>
               </a:lnSpc>
               <a:spcAft>
-                <a:spcPts val="600"/>
-              </a:spcAft>
-              <a:buNone/>
-            </a:pPr>
-            <a:r>
-              <a:rPr sz="1500" b="0">
-                <a:solidFill>
-                  <a:srgbClr val="000000"/>
-                </a:solidFill>
-                <a:latin typeface="Arial"/>
-              </a:rPr>
-              <a:t>• Six force sensors under a foot, batched over Wi-Fi</a:t>
-            </a:r>
-          </a:p>
-          <a:p>
-            <a:pPr marL="0" indent="0" algn="l">
-              <a:lnSpc>
-                <a:spcPct val="128000"/>
-              </a:lnSpc>
-              <a:spcAft>
-                <a:spcPts val="600"/>
+                <a:spcPts val="400"/>
               </a:spcAft>
               <a:buNone/>
             </a:pPr>
@@ -11011,7 +10945,7 @@
                 <a:spcPct val="128000"/>
               </a:lnSpc>
               <a:spcAft>
-                <a:spcPts val="1400"/>
+                <a:spcPts val="1200"/>
               </a:spcAft>
               <a:buNone/>
             </a:pPr>
@@ -11031,7 +10965,7 @@
                 <a:spcPct val="128000"/>
               </a:lnSpc>
               <a:spcAft>
-                <a:spcPts val="600"/>
+                <a:spcPts val="400"/>
               </a:spcAft>
               <a:buNone/>
             </a:pPr>
@@ -11051,7 +10985,7 @@
                 <a:spcPct val="128000"/>
               </a:lnSpc>
               <a:spcAft>
-                <a:spcPts val="600"/>
+                <a:spcPts val="400"/>
               </a:spcAft>
               <a:buNone/>
             </a:pPr>
@@ -11071,10 +11005,19 @@
                 <a:spcPct val="128000"/>
               </a:lnSpc>
               <a:spcAft>
-                <a:spcPts val="0"/>
-              </a:spcAft>
-              <a:buNone/>
-            </a:pPr>
+                <a:spcPts val="400"/>
+              </a:spcAft>
+              <a:buNone/>
+            </a:pPr>
+            <a:r>
+              <a:rPr sz="1700" b="1">
+                <a:solidFill>
+                  <a:srgbClr val="000000"/>
+                </a:solidFill>
+                <a:latin typeface="Arial"/>
+              </a:rPr>
+              <a:t>Vary two things only</a:t>
+            </a:r>
           </a:p>
           <a:p>
             <a:pPr marL="0" indent="0" algn="l">
@@ -11082,7 +11025,27 @@
                 <a:spcPct val="128000"/>
               </a:lnSpc>
               <a:spcAft>
-                <a:spcPts val="600"/>
+                <a:spcPts val="400"/>
+              </a:spcAft>
+              <a:buNone/>
+            </a:pPr>
+            <a:r>
+              <a:rPr sz="1500" b="0">
+                <a:solidFill>
+                  <a:srgbClr val="000000"/>
+                </a:solidFill>
+                <a:latin typeface="Arial"/>
+              </a:rPr>
+              <a:t>• Rhythm of the pulses, and how strong they are</a:t>
+            </a:r>
+          </a:p>
+          <a:p>
+            <a:pPr marL="0" indent="0" algn="l">
+              <a:lnSpc>
+                <a:spcPct val="128000"/>
+              </a:lnSpc>
+              <a:spcAft>
+                <a:spcPts val="400"/>
               </a:spcAft>
               <a:buNone/>
             </a:pPr>
@@ -11093,7 +11056,7 @@
                 </a:solidFill>
                 <a:latin typeface="Arial"/>
               </a:rPr>
-              <a:t>Vary two things only</a:t>
+              <a:t>Blind test: they name all three</a:t>
             </a:r>
           </a:p>
           <a:p>
@@ -11102,78 +11065,7 @@
                 <a:spcPct val="128000"/>
               </a:lnSpc>
               <a:spcAft>
-                <a:spcPts val="600"/>
-              </a:spcAft>
-              <a:buNone/>
-            </a:pPr>
-            <a:r>
-              <a:rPr sz="1500" b="0">
-                <a:solidFill>
-                  <a:srgbClr val="000000"/>
-                </a:solidFill>
-                <a:latin typeface="Arial"/>
-              </a:rPr>
-              <a:t>• Rhythm of the pulses</a:t>
-            </a:r>
-          </a:p>
-          <a:p>
-            <a:pPr marL="0" indent="0" algn="l">
-              <a:lnSpc>
-                <a:spcPct val="128000"/>
-              </a:lnSpc>
-              <a:spcAft>
-                <a:spcPts val="600"/>
-              </a:spcAft>
-              <a:buNone/>
-            </a:pPr>
-            <a:r>
-              <a:rPr sz="1500" b="0">
-                <a:solidFill>
-                  <a:srgbClr val="000000"/>
-                </a:solidFill>
-                <a:latin typeface="Arial"/>
-              </a:rPr>
-              <a:t>• How strong they are</a:t>
-            </a:r>
-          </a:p>
-          <a:p>
-            <a:pPr marL="0" indent="0" algn="l">
-              <a:lnSpc>
-                <a:spcPct val="128000"/>
-              </a:lnSpc>
-              <a:spcAft>
-                <a:spcPts val="0"/>
-              </a:spcAft>
-              <a:buNone/>
-            </a:pPr>
-          </a:p>
-          <a:p>
-            <a:pPr marL="0" indent="0" algn="l">
-              <a:lnSpc>
-                <a:spcPct val="128000"/>
-              </a:lnSpc>
-              <a:spcAft>
-                <a:spcPts val="600"/>
-              </a:spcAft>
-              <a:buNone/>
-            </a:pPr>
-            <a:r>
-              <a:rPr sz="1700" b="1">
-                <a:solidFill>
-                  <a:srgbClr val="000000"/>
-                </a:solidFill>
-                <a:latin typeface="Arial"/>
-              </a:rPr>
-              <a:t>Blind test: they name all three</a:t>
-            </a:r>
-          </a:p>
-          <a:p>
-            <a:pPr marL="0" indent="0" algn="l">
-              <a:lnSpc>
-                <a:spcPct val="128000"/>
-              </a:lnSpc>
-              <a:spcAft>
-                <a:spcPts val="600"/>
+                <a:spcPts val="400"/>
               </a:spcAft>
               <a:buNone/>
             </a:pPr>
@@ -11305,7 +11197,7 @@
                 <a:spcPct val="128000"/>
               </a:lnSpc>
               <a:spcAft>
-                <a:spcPts val="600"/>
+                <a:spcPts val="400"/>
               </a:spcAft>
               <a:buNone/>
             </a:pPr>
@@ -11336,7 +11228,7 @@
                 <a:spcPct val="128000"/>
               </a:lnSpc>
               <a:spcAft>
-                <a:spcPts val="600"/>
+                <a:spcPts val="400"/>
               </a:spcAft>
               <a:buNone/>
             </a:pPr>
@@ -11356,7 +11248,7 @@
                 <a:spcPct val="128000"/>
               </a:lnSpc>
               <a:spcAft>
-                <a:spcPts val="600"/>
+                <a:spcPts val="400"/>
               </a:spcAft>
               <a:buNone/>
             </a:pPr>
@@ -11488,7 +11380,7 @@
                 <a:spcPct val="128000"/>
               </a:lnSpc>
               <a:spcAft>
-                <a:spcPts val="1400"/>
+                <a:spcPts val="1200"/>
               </a:spcAft>
               <a:buNone/>
             </a:pPr>
@@ -11508,7 +11400,7 @@
                 <a:spcPct val="128000"/>
               </a:lnSpc>
               <a:spcAft>
-                <a:spcPts val="600"/>
+                <a:spcPts val="400"/>
               </a:spcAft>
               <a:buNone/>
             </a:pPr>
@@ -11528,7 +11420,7 @@
                 <a:spcPct val="128000"/>
               </a:lnSpc>
               <a:spcAft>
-                <a:spcPts val="600"/>
+                <a:spcPts val="400"/>
               </a:spcAft>
               <a:buNone/>
             </a:pPr>
@@ -11548,7 +11440,7 @@
                 <a:spcPct val="128000"/>
               </a:lnSpc>
               <a:spcAft>
-                <a:spcPts val="600"/>
+                <a:spcPts val="400"/>
               </a:spcAft>
               <a:buNone/>
             </a:pPr>
@@ -11579,7 +11471,7 @@
                 <a:spcPct val="128000"/>
               </a:lnSpc>
               <a:spcAft>
-                <a:spcPts val="600"/>
+                <a:spcPts val="400"/>
               </a:spcAft>
               <a:buNone/>
             </a:pPr>
@@ -11599,7 +11491,7 @@
                 <a:spcPct val="128000"/>
               </a:lnSpc>
               <a:spcAft>
-                <a:spcPts val="600"/>
+                <a:spcPts val="400"/>
               </a:spcAft>
               <a:buNone/>
             </a:pPr>
@@ -11619,7 +11511,7 @@
                 <a:spcPct val="128000"/>
               </a:lnSpc>
               <a:spcAft>
-                <a:spcPts val="600"/>
+                <a:spcPts val="400"/>
               </a:spcAft>
               <a:buNone/>
             </a:pPr>
@@ -11751,7 +11643,7 @@
                 <a:spcPct val="128000"/>
               </a:lnSpc>
               <a:spcAft>
-                <a:spcPts val="1400"/>
+                <a:spcPts val="1200"/>
               </a:spcAft>
               <a:buNone/>
             </a:pPr>
@@ -11771,7 +11663,7 @@
                 <a:spcPct val="128000"/>
               </a:lnSpc>
               <a:spcAft>
-                <a:spcPts val="600"/>
+                <a:spcPts val="400"/>
               </a:spcAft>
               <a:buNone/>
             </a:pPr>
@@ -11791,7 +11683,7 @@
                 <a:spcPct val="128000"/>
               </a:lnSpc>
               <a:spcAft>
-                <a:spcPts val="600"/>
+                <a:spcPts val="400"/>
               </a:spcAft>
               <a:buNone/>
             </a:pPr>
@@ -11811,7 +11703,7 @@
                 <a:spcPct val="128000"/>
               </a:lnSpc>
               <a:spcAft>
-                <a:spcPts val="600"/>
+                <a:spcPts val="400"/>
               </a:spcAft>
               <a:buNone/>
             </a:pPr>
@@ -11842,7 +11734,7 @@
                 <a:spcPct val="128000"/>
               </a:lnSpc>
               <a:spcAft>
-                <a:spcPts val="600"/>
+                <a:spcPts val="400"/>
               </a:spcAft>
               <a:buNone/>
             </a:pPr>
@@ -11862,7 +11754,7 @@
                 <a:spcPct val="128000"/>
               </a:lnSpc>
               <a:spcAft>
-                <a:spcPts val="600"/>
+                <a:spcPts val="400"/>
               </a:spcAft>
               <a:buNone/>
             </a:pPr>
@@ -12120,7 +12012,7 @@
                 <a:spcPct val="128000"/>
               </a:lnSpc>
               <a:spcAft>
-                <a:spcPts val="600"/>
+                <a:spcPts val="400"/>
               </a:spcAft>
               <a:buNone/>
             </a:pPr>
@@ -12140,7 +12032,7 @@
                 <a:spcPct val="128000"/>
               </a:lnSpc>
               <a:spcAft>
-                <a:spcPts val="600"/>
+                <a:spcPts val="400"/>
               </a:spcAft>
               <a:buNone/>
             </a:pPr>
@@ -12160,7 +12052,7 @@
                 <a:spcPct val="128000"/>
               </a:lnSpc>
               <a:spcAft>
-                <a:spcPts val="600"/>
+                <a:spcPts val="400"/>
               </a:spcAft>
               <a:buNone/>
             </a:pPr>
@@ -12180,10 +12072,19 @@
                 <a:spcPct val="128000"/>
               </a:lnSpc>
               <a:spcAft>
-                <a:spcPts val="0"/>
-              </a:spcAft>
-              <a:buNone/>
-            </a:pPr>
+                <a:spcPts val="400"/>
+              </a:spcAft>
+              <a:buNone/>
+            </a:pPr>
+            <a:r>
+              <a:rPr sz="1700" b="1">
+                <a:solidFill>
+                  <a:srgbClr val="000000"/>
+                </a:solidFill>
+                <a:latin typeface="Arial"/>
+              </a:rPr>
+              <a:t>Actuators are on the tables at the front</a:t>
+            </a:r>
           </a:p>
           <a:p>
             <a:pPr marL="0" indent="0" algn="l">
@@ -12191,7 +12092,27 @@
                 <a:spcPct val="128000"/>
               </a:lnSpc>
               <a:spcAft>
-                <a:spcPts val="600"/>
+                <a:spcPts val="400"/>
+              </a:spcAft>
+              <a:buNone/>
+            </a:pPr>
+            <a:r>
+              <a:rPr sz="1500" b="0">
+                <a:solidFill>
+                  <a:srgbClr val="000000"/>
+                </a:solidFill>
+                <a:latin typeface="Arial"/>
+              </a:rPr>
+              <a:t>• Go and feel the ones your task does not use</a:t>
+            </a:r>
+          </a:p>
+          <a:p>
+            <a:pPr marL="0" indent="0" algn="l">
+              <a:lnSpc>
+                <a:spcPct val="128000"/>
+              </a:lnSpc>
+              <a:spcAft>
+                <a:spcPts val="400"/>
               </a:spcAft>
               <a:buNone/>
             </a:pPr>
@@ -12202,78 +12123,7 @@
                 </a:solidFill>
                 <a:latin typeface="Arial"/>
               </a:rPr>
-              <a:t>Actuators are on the tables at the front</a:t>
-            </a:r>
-          </a:p>
-          <a:p>
-            <a:pPr marL="0" indent="0" algn="l">
-              <a:lnSpc>
-                <a:spcPct val="128000"/>
-              </a:lnSpc>
-              <a:spcAft>
-                <a:spcPts val="600"/>
-              </a:spcAft>
-              <a:buNone/>
-            </a:pPr>
-            <a:r>
-              <a:rPr sz="1500" b="0">
-                <a:solidFill>
-                  <a:srgbClr val="000000"/>
-                </a:solidFill>
-                <a:latin typeface="Arial"/>
-              </a:rPr>
-              <a:t>• Go and feel the ones your task does not use</a:t>
-            </a:r>
-          </a:p>
-          <a:p>
-            <a:pPr marL="0" indent="0" algn="l">
-              <a:lnSpc>
-                <a:spcPct val="128000"/>
-              </a:lnSpc>
-              <a:spcAft>
-                <a:spcPts val="0"/>
-              </a:spcAft>
-              <a:buNone/>
-            </a:pPr>
-          </a:p>
-          <a:p>
-            <a:pPr marL="0" indent="0" algn="l">
-              <a:lnSpc>
-                <a:spcPct val="128000"/>
-              </a:lnSpc>
-              <a:spcAft>
-                <a:spcPts val="600"/>
-              </a:spcAft>
-              <a:buNone/>
-            </a:pPr>
-            <a:r>
-              <a:rPr sz="1700" b="1">
-                <a:solidFill>
-                  <a:srgbClr val="000000"/>
-                </a:solidFill>
-                <a:latin typeface="Arial"/>
-              </a:rPr>
-              <a:t>Finish by building one signal</a:t>
-            </a:r>
-          </a:p>
-          <a:p>
-            <a:pPr marL="0" indent="0" algn="l">
-              <a:lnSpc>
-                <a:spcPct val="128000"/>
-              </a:lnSpc>
-              <a:spcAft>
-                <a:spcPts val="600"/>
-              </a:spcAft>
-              <a:buNone/>
-            </a:pPr>
-            <a:r>
-              <a:rPr sz="1500" b="0">
-                <a:solidFill>
-                  <a:srgbClr val="000000"/>
-                </a:solidFill>
-                <a:latin typeface="Arial"/>
-              </a:rPr>
-              <a:t>• Someone else has to read it</a:t>
+              <a:t>Finish by building one signal someone else can read</a:t>
             </a:r>
           </a:p>
         </p:txBody>
@@ -12646,7 +12496,7 @@
                 <a:spcPct val="128000"/>
               </a:lnSpc>
               <a:spcAft>
-                <a:spcPts val="1400"/>
+                <a:spcPts val="1200"/>
               </a:spcAft>
               <a:buNone/>
             </a:pPr>
@@ -12666,7 +12516,7 @@
                 <a:spcPct val="128000"/>
               </a:lnSpc>
               <a:spcAft>
-                <a:spcPts val="600"/>
+                <a:spcPts val="400"/>
               </a:spcAft>
               <a:buNone/>
             </a:pPr>
@@ -12686,7 +12536,7 @@
                 <a:spcPct val="128000"/>
               </a:lnSpc>
               <a:spcAft>
-                <a:spcPts val="600"/>
+                <a:spcPts val="400"/>
               </a:spcAft>
               <a:buNone/>
             </a:pPr>
@@ -12706,7 +12556,7 @@
                 <a:spcPct val="128000"/>
               </a:lnSpc>
               <a:spcAft>
-                <a:spcPts val="600"/>
+                <a:spcPts val="400"/>
               </a:spcAft>
               <a:buNone/>
             </a:pPr>
@@ -12726,7 +12576,7 @@
                 <a:spcPct val="128000"/>
               </a:lnSpc>
               <a:spcAft>
-                <a:spcPts val="600"/>
+                <a:spcPts val="400"/>
               </a:spcAft>
               <a:buNone/>
             </a:pPr>
@@ -12746,7 +12596,7 @@
                 <a:spcPct val="128000"/>
               </a:lnSpc>
               <a:spcAft>
-                <a:spcPts val="600"/>
+                <a:spcPts val="400"/>
               </a:spcAft>
               <a:buNone/>
             </a:pPr>
@@ -12766,7 +12616,7 @@
                 <a:spcPct val="128000"/>
               </a:lnSpc>
               <a:spcAft>
-                <a:spcPts val="600"/>
+                <a:spcPts val="400"/>
               </a:spcAft>
               <a:buNone/>
             </a:pPr>
@@ -12797,7 +12647,7 @@
                 <a:spcPct val="128000"/>
               </a:lnSpc>
               <a:spcAft>
-                <a:spcPts val="600"/>
+                <a:spcPts val="400"/>
               </a:spcAft>
               <a:buNone/>
             </a:pPr>
@@ -12808,27 +12658,7 @@
                 </a:solidFill>
                 <a:latin typeface="Arial"/>
               </a:rPr>
-              <a:t>1 to 3 are output. 4 is input. 5 is both. 6 needs no board.</a:t>
-            </a:r>
-          </a:p>
-          <a:p>
-            <a:pPr marL="0" indent="0" algn="l">
-              <a:lnSpc>
-                <a:spcPct val="128000"/>
-              </a:lnSpc>
-              <a:spcAft>
-                <a:spcPts val="600"/>
-              </a:spcAft>
-              <a:buNone/>
-            </a:pPr>
-            <a:r>
-              <a:rPr sz="1700" b="0">
-                <a:solidFill>
-                  <a:srgbClr val="000000"/>
-                </a:solidFill>
-                <a:latin typeface="Arial"/>
-              </a:rPr>
-              <a:t>Nobody is expected to finish all five.</a:t>
+              <a:t>1 to 3 output, 4 input, 5 both. Nobody finishes all six.</a:t>
             </a:r>
           </a:p>
         </p:txBody>
@@ -12949,7 +12779,7 @@
                 <a:spcPct val="128000"/>
               </a:lnSpc>
               <a:spcAft>
-                <a:spcPts val="1400"/>
+                <a:spcPts val="1200"/>
               </a:spcAft>
               <a:buNone/>
             </a:pPr>
@@ -12960,7 +12790,7 @@
                 </a:solidFill>
                 <a:latin typeface="Arial"/>
               </a:rPr>
-              <a:t>Every sketch runs the moment you upload it. Nothing to wire.</a:t>
+              <a:t>Every sketch runs the moment you upload it. Nothing to wire. All of them: github.com/labtools-au/multimodal-actuator-workshop</a:t>
             </a:r>
           </a:p>
           <a:p>
@@ -12969,7 +12799,7 @@
                 <a:spcPct val="128000"/>
               </a:lnSpc>
               <a:spcAft>
-                <a:spcPts val="600"/>
+                <a:spcPts val="400"/>
               </a:spcAft>
               <a:buNone/>
             </a:pPr>
@@ -12989,7 +12819,7 @@
                 <a:spcPct val="128000"/>
               </a:lnSpc>
               <a:spcAft>
-                <a:spcPts val="600"/>
+                <a:spcPts val="400"/>
               </a:spcAft>
               <a:buNone/>
             </a:pPr>
@@ -13020,7 +12850,7 @@
                 <a:spcPct val="128000"/>
               </a:lnSpc>
               <a:spcAft>
-                <a:spcPts val="600"/>
+                <a:spcPts val="400"/>
               </a:spcAft>
               <a:buNone/>
             </a:pPr>
@@ -13040,7 +12870,7 @@
                 <a:spcPct val="128000"/>
               </a:lnSpc>
               <a:spcAft>
-                <a:spcPts val="600"/>
+                <a:spcPts val="400"/>
               </a:spcAft>
               <a:buNone/>
             </a:pPr>
@@ -13060,7 +12890,7 @@
                 <a:spcPct val="128000"/>
               </a:lnSpc>
               <a:spcAft>
-                <a:spcPts val="600"/>
+                <a:spcPts val="400"/>
               </a:spcAft>
               <a:buNone/>
             </a:pPr>
@@ -13072,37 +12902,6 @@
                 <a:latin typeface="Arial"/>
               </a:rPr>
               <a:t>• The last one is usually the interesting one</a:t>
-            </a:r>
-          </a:p>
-          <a:p>
-            <a:pPr marL="0" indent="0" algn="l">
-              <a:lnSpc>
-                <a:spcPct val="128000"/>
-              </a:lnSpc>
-              <a:spcAft>
-                <a:spcPts val="0"/>
-              </a:spcAft>
-              <a:buNone/>
-            </a:pPr>
-          </a:p>
-          <a:p>
-            <a:pPr marL="0" indent="0" algn="l">
-              <a:lnSpc>
-                <a:spcPct val="128000"/>
-              </a:lnSpc>
-              <a:spcAft>
-                <a:spcPts val="600"/>
-              </a:spcAft>
-              <a:buNone/>
-            </a:pPr>
-            <a:r>
-              <a:rPr sz="1700" b="1">
-                <a:solidFill>
-                  <a:srgbClr val="000000"/>
-                </a:solidFill>
-                <a:latin typeface="Arial"/>
-              </a:rPr>
-              <a:t>github.com/labtools-au/multimodal-actuator-workshop</a:t>
             </a:r>
           </a:p>
         </p:txBody>
@@ -13223,7 +13022,7 @@
                 <a:spcPct val="128000"/>
               </a:lnSpc>
               <a:spcAft>
-                <a:spcPts val="1400"/>
+                <a:spcPts val="1200"/>
               </a:spcAft>
               <a:buNone/>
             </a:pPr>
@@ -13243,7 +13042,7 @@
                 <a:spcPct val="128000"/>
               </a:lnSpc>
               <a:spcAft>
-                <a:spcPts val="600"/>
+                <a:spcPts val="400"/>
               </a:spcAft>
               <a:buNone/>
             </a:pPr>
@@ -13263,7 +13062,7 @@
                 <a:spcPct val="128000"/>
               </a:lnSpc>
               <a:spcAft>
-                <a:spcPts val="600"/>
+                <a:spcPts val="400"/>
               </a:spcAft>
               <a:buNone/>
             </a:pPr>

</xml_diff>

<commit_message>
change(deck): three actuators, the ones they build
Cut to what the session actually does: piezo, capacitive pad, stepper. Those
three keep full slides, in build order. The other six (coin motor, solenoid,
Peltier, transducer, servo, electromagnet) compress into one "what else the lab
has" slide with drawer numbers and stock, so the range is visible for project
weeks without a slide each.

Tasks 01 to 03 stay in the repo with working code. The deck says so, and the
speaker notes point at them for project weeks.

Run sheet rebuilt around the four tasks with real timings, and the notes for
the three kept actuators now carry what we learned on the bench today: keep the
capacitive rig on laptop USB, hands off the pad at boot, and give the stepper
driver its own 5V because LEDs lighting while the shaft stays still is a
current problem rather than a dead motor.

31 slides down to 26, notes on all 26. No em-dashes.

Claude-Session: https://claude.ai/code/session_01CH1MfHfgJbuQetj7pMqMXE
</commit_message>
<xml_diff>
--- a/docs/multimodal-actuator-workshop.pptx
+++ b/docs/multimodal-actuator-workshop.pptx
@@ -31,11 +31,6 @@
     <p:sldId id="279" r:id="rId30"/>
     <p:sldId id="280" r:id="rId31"/>
     <p:sldId id="281" r:id="rId32"/>
-    <p:sldId id="282" r:id="rId33"/>
-    <p:sldId id="283" r:id="rId34"/>
-    <p:sldId id="284" r:id="rId35"/>
-    <p:sldId id="285" r:id="rId36"/>
-    <p:sldId id="286" r:id="rId37"/>
   </p:sldIdLst>
   <p:sldSz cx="12188952" cy="6858000" type="screen4x3"/>
   <p:notesSz cx="6858000" cy="9144000"/>
@@ -629,18 +624,50 @@
           <a:lstStyle/>
           <a:p>
             <a:r>
-              <a:t>The one everybody already owns without knowing it. Every phone has one.</a:t>
+              <a:t>First actuator and first build, so keep it short and get them moving.</a:t>
             </a:r>
           </a:p>
           <a:p/>
           <a:p>
             <a:r>
-              <a:t>The point worth making: speed and strength are welded together. That single</a:t>
-            </a:r>
-          </a:p>
-          <a:p>
-            <a:r>
-              <a:t>constraint is why the other five exist.</a:t>
+              <a:t>A crystal that flexes when you put current across it. Near-instant, almost no</a:t>
+            </a:r>
+          </a:p>
+          <a:p>
+            <a:r>
+              <a:t>power, but shallow. A tick, not a thump.</a:t>
+            </a:r>
+          </a:p>
+          <a:p/>
+          <a:p>
+            <a:r>
+              <a:t>Two wires and no driver, because a piezo is a capacitor and draws almost</a:t>
+            </a:r>
+          </a:p>
+          <a:p>
+            <a:r>
+              <a:t>nothing. That is the honest reason it is first, and it is worth saying: when</a:t>
+            </a:r>
+          </a:p>
+          <a:p>
+            <a:r>
+              <a:t>this works, their board, cable, port and IDE are all proven, so every later</a:t>
+            </a:r>
+          </a:p>
+          <a:p>
+            <a:r>
+              <a:t>failure is in the circuit they built.</a:t>
+            </a:r>
+          </a:p>
+          <a:p/>
+          <a:p>
+            <a:r>
+              <a:t>Tell them to press it flat against the table. It gets much louder, because the</a:t>
+            </a:r>
+          </a:p>
+          <a:p>
+            <a:r>
+              <a:t>table becomes the diaphragm. Same effect the surface transducer uses.</a:t>
             </a:r>
           </a:p>
         </p:txBody>
@@ -710,23 +737,44 @@
           <a:lstStyle/>
           <a:p>
             <a:r>
-              <a:t>The escape from the coin motor's compromise. A crystal that flexes when</a:t>
-            </a:r>
-          </a:p>
-          <a:p>
-            <a:r>
-              <a:t>you put current across it: near-instant, almost no power, but shallow.</a:t>
+              <a:t>Hold up a wire and a piece of foil. That is genuinely the whole sensor.</a:t>
             </a:r>
           </a:p>
           <a:p/>
           <a:p>
             <a:r>
-              <a:t>A tick, not a thump. Point anyone here who needs something to feel responsive</a:t>
-            </a:r>
-          </a:p>
-          <a:p>
-            <a:r>
-              <a:t>rather than just present. 69 in the drawer, so nobody has to share.</a:t>
+              <a:t>This is the slide that changes what people think is possible, because it costs</a:t>
+            </a:r>
+          </a:p>
+          <a:p>
+            <a:r>
+              <a:t>nothing and hides completely inside a prototype.</a:t>
+            </a:r>
+          </a:p>
+          <a:p/>
+          <a:p>
+            <a:r>
+              <a:t>Two things to say now rather than when it bites. Keep the board on laptop USB:</a:t>
+            </a:r>
+          </a:p>
+          <a:p>
+            <a:r>
+              <a:t>the sensing measures your body against the board's ground and that reference</a:t>
+            </a:r>
+          </a:p>
+          <a:p>
+            <a:r>
+              <a:t>arrives through the mains earth, so on a charger or a battery it goes unstable</a:t>
+            </a:r>
+          </a:p>
+          <a:p>
+            <a:r>
+              <a:t>or dead with nothing visibly wrong. And hands off the pad while it boots, or it</a:t>
+            </a:r>
+          </a:p>
+          <a:p>
+            <a:r>
+              <a:t>learns that a finger is the resting state and then nothing ever triggers.</a:t>
             </a:r>
           </a:p>
         </p:txBody>
@@ -796,23 +844,55 @@
           <a:lstStyle/>
           <a:p>
             <a:r>
-              <a:t>Pass this one around if you can. It is the one people remember, because a</a:t>
-            </a:r>
-          </a:p>
-          <a:p>
-            <a:r>
-              <a:t>knock reads as a person rather than a machine.</a:t>
+              <a:t>The precision option, and the only actuator here that goes to a POSITION</a:t>
+            </a:r>
+          </a:p>
+          <a:p>
+            <a:r>
+              <a:t>rather than a state. 2048 steps per revolution, no feedback sensor needed.</a:t>
             </a:r>
           </a:p>
           <a:p/>
           <a:p>
             <a:r>
-              <a:t>Warn them now that it needs its own supply, so it does not come as a surprise</a:t>
-            </a:r>
-          </a:p>
-          <a:p>
-            <a:r>
-              <a:t>at task 02.</a:t>
+              <a:t>Two things will bite, so say both before they start.</a:t>
+            </a:r>
+          </a:p>
+          <a:p/>
+          <a:p>
+            <a:r>
+              <a:t>The constructor does NOT take the pins in numeric order. Wire IN1 to IN4 on</a:t>
+            </a:r>
+          </a:p>
+          <a:p>
+            <a:r>
+              <a:t>pins 8 to 11, then write Stepper(2048, 8, 10, 9, 11). Get it wrong and it</a:t>
+            </a:r>
+          </a:p>
+          <a:p>
+            <a:r>
+              <a:t>buzzes and jitters instead of turning, which looks exactly like a dead motor.</a:t>
+            </a:r>
+          </a:p>
+          <a:p/>
+          <a:p>
+            <a:r>
+              <a:t>Give the driver its own 5V supply. Each coil pulls about 240 mA and the board</a:t>
+            </a:r>
+          </a:p>
+          <a:p>
+            <a:r>
+              <a:t>holds them energised even at rest, which is more than the Uno's 5V pin should</a:t>
+            </a:r>
+          </a:p>
+          <a:p>
+            <a:r>
+              <a:t>carry. The symptom is misleading: the driver LEDs light in sequence while the</a:t>
+            </a:r>
+          </a:p>
+          <a:p>
+            <a:r>
+              <a:t>shaft never moves, because LEDs need a few mA and coils need hundreds.</a:t>
             </a:r>
           </a:p>
         </p:txBody>
@@ -882,18 +962,65 @@
           <a:lstStyle/>
           <a:p>
             <a:r>
-              <a:t>Hold up a wire and a piece of foil. That is genuinely the whole sensor.</a:t>
+              <a:t>Ninety seconds, and do not read the list. The purpose is permission, not</a:t>
+            </a:r>
+          </a:p>
+          <a:p>
+            <a:r>
+              <a:t>coverage.</a:t>
             </a:r>
           </a:p>
           <a:p/>
           <a:p>
             <a:r>
-              <a:t>This is the slide that changes what people think is possible, because it costs</a:t>
-            </a:r>
-          </a:p>
-          <a:p>
-            <a:r>
-              <a:t>nothing and hides completely inside a prototype.</a:t>
+              <a:t>They are building three things today. This slide says the drawers hold a lot</a:t>
+            </a:r>
+          </a:p>
+          <a:p>
+            <a:r>
+              <a:t>more, so nobody designs a project around a coin motor just because it was the</a:t>
+            </a:r>
+          </a:p>
+          <a:p>
+            <a:r>
+              <a:t>one on the slide.</a:t>
+            </a:r>
+          </a:p>
+          <a:p/>
+          <a:p>
+            <a:r>
+              <a:t>Point out that tasks 01 to 03 are already in the repo with working code and</a:t>
+            </a:r>
+          </a:p>
+          <a:p>
+            <a:r>
+              <a:t>wiring for the motor, the solenoid and the Peltier tile. They can pick those up</a:t>
+            </a:r>
+          </a:p>
+          <a:p>
+            <a:r>
+              <a:t>in project weeks without starting from nothing.</a:t>
+            </a:r>
+          </a:p>
+          <a:p/>
+          <a:p>
+            <a:r>
+              <a:t>If someone asks which to use for a project: the solenoid is the one people</a:t>
+            </a:r>
+          </a:p>
+          <a:p>
+            <a:r>
+              <a:t>remember, because a knock reads as a person rather than a machine. The Peltier</a:t>
+            </a:r>
+          </a:p>
+          <a:p>
+            <a:r>
+              <a:t>is slow and wrong for alerts, right for ambient state. Say that now and it</a:t>
+            </a:r>
+          </a:p>
+          <a:p>
+            <a:r>
+              <a:t>saves someone finding out in week 46.</a:t>
             </a:r>
           </a:p>
         </p:txBody>
@@ -963,23 +1090,55 @@
           <a:lstStyle/>
           <a:p>
             <a:r>
-              <a:t>Say the honest limitation out loud: it is slow, and hot alternating with</a:t>
-            </a:r>
-          </a:p>
-          <a:p>
-            <a:r>
-              <a:t>cold just reads as lukewarm.</a:t>
+              <a:t>Two messages on one slide, and they pull in opposite directions on</a:t>
+            </a:r>
+          </a:p>
+          <a:p>
+            <a:r>
+              <a:t>purpose. Say the permission warmly, then change tone for the limits.</a:t>
             </a:r>
           </a:p>
           <a:p/>
           <a:p>
             <a:r>
-              <a:t>Good for slow ambient state. Wrong for alerts. Saying so here saves a project</a:t>
-            </a:r>
-          </a:p>
-          <a:p>
-            <a:r>
-              <a:t>from finding out in week 46.</a:t>
+              <a:t>Permission first: some students will not believe they are allowed to skip</a:t>
+            </a:r>
+          </a:p>
+          <a:p>
+            <a:r>
+              <a:t>ahead or stop early unless told. The failure mode is a pair rushing all five</a:t>
+            </a:r>
+          </a:p>
+          <a:p>
+            <a:r>
+              <a:t>badly instead of doing two properly.</a:t>
+            </a:r>
+          </a:p>
+          <a:p/>
+          <a:p>
+            <a:r>
+              <a:t>Then the three hard limits, and here you should sound firm. Say the numbers</a:t>
+            </a:r>
+          </a:p>
+          <a:p>
+            <a:r>
+              <a:t>out loud: a pin gives 40 mA, the motor wants about 75. It is not a rule they</a:t>
+            </a:r>
+          </a:p>
+          <a:p>
+            <a:r>
+              <a:t>have to take on faith.</a:t>
+            </a:r>
+          </a:p>
+          <a:p/>
+          <a:p>
+            <a:r>
+              <a:t>Worth adding: a board resetting when the solenoid fires is a POWER problem,</a:t>
+            </a:r>
+          </a:p>
+          <a:p>
+            <a:r>
+              <a:t>not a code bug. That saves someone twenty minutes.</a:t>
             </a:r>
           </a:p>
         </p:txBody>
@@ -1049,23 +1208,72 @@
           <a:lstStyle/>
           <a:p>
             <a:r>
-              <a:t>The redundancy argument. Same driver, one frequency you feel and one you</a:t>
-            </a:r>
-          </a:p>
-          <a:p>
-            <a:r>
-              <a:t>hear.</a:t>
+              <a:t>Slow down here. This is the single idea most worth stealing from today, and</a:t>
+            </a:r>
+          </a:p>
+          <a:p>
+            <a:r>
+              <a:t>it is worth interrupting the room for once most people have reached task 04.</a:t>
             </a:r>
           </a:p>
           <a:p/>
           <a:p>
             <a:r>
-              <a:t>Together is not louder, it is more certain. Cheapest reliability a project can</a:t>
-            </a:r>
-          </a:p>
-          <a:p>
-            <a:r>
-              <a:t>buy, and it is also the accessibility answer.</a:t>
+              <a:t>Two things students get wrong:</a:t>
+            </a:r>
+          </a:p>
+          <a:p/>
+          <a:p>
+            <a:r>
+              <a:t>1. A fixed threshold. Works in the morning, fails after lunch, because the</a:t>
+            </a:r>
+          </a:p>
+          <a:p>
+            <a:r>
+              <a:t>   reading drifts with humidity and mains hum.</a:t>
+            </a:r>
+          </a:p>
+          <a:p/>
+          <a:p>
+            <a:r>
+              <a:t>2. Feeding the baseline buffer always. A long press then teaches the baseline</a:t>
+            </a:r>
+          </a:p>
+          <a:p>
+            <a:r>
+              <a:t>   that a finger is normal, and the touch silently stops working. The buffer</a:t>
+            </a:r>
+          </a:p>
+          <a:p>
+            <a:r>
+              <a:t>   must only learn while untouched.</a:t>
+            </a:r>
+          </a:p>
+          <a:p/>
+          <a:p>
+            <a:r>
+              <a:t>Put the Serial Plotter on the projector. Watching the baseline wander while the</a:t>
+            </a:r>
+          </a:p>
+          <a:p>
+            <a:r>
+              <a:t>trigger line tracks it explains the whole design in ten seconds.</a:t>
+            </a:r>
+          </a:p>
+          <a:p/>
+          <a:p>
+            <a:r>
+              <a:t>For what it is worth, the rig this came from went through the same tuning: an</a:t>
+            </a:r>
+          </a:p>
+          <a:p>
+            <a:r>
+              <a:t>earlier version used 1.008 with a 50-sample baseline, the final one 1.01 with</a:t>
+            </a:r>
+          </a:p>
+          <a:p>
+            <a:r>
+              <a:t>25. Everyone tunes these.</a:t>
             </a:r>
           </a:p>
         </p:txBody>
@@ -1135,18 +1343,24 @@
           <a:lstStyle/>
           <a:p>
             <a:r>
-              <a:t>Worth showing even though it is not in a task. Most projects that need</a:t>
-            </a:r>
-          </a:p>
-          <a:p>
-            <a:r>
-              <a:t>something to physically move end up here rather than on a vibration motor.</a:t>
+              <a:t>1:25. Pull the room back together.</a:t>
             </a:r>
           </a:p>
           <a:p/>
           <a:p>
             <a:r>
-              <a:t>80 in stock, so nobody has to share.</a:t>
+              <a:t>One sentence per group: what surprised you. No slides, no laptops. Ten minutes.</a:t>
+            </a:r>
+          </a:p>
+          <a:p/>
+          <a:p>
+            <a:r>
+              <a:t>Expect someone to report the Peltier delay. Let that land, it is far more</a:t>
+            </a:r>
+          </a:p>
+          <a:p>
+            <a:r>
+              <a:t>persuasive from a peer than from you.</a:t>
             </a:r>
           </a:p>
         </p:txBody>
@@ -1216,39 +1430,29 @@
           <a:lstStyle/>
           <a:p>
             <a:r>
-              <a:t>The precision option. Moves in known steps, so you can position it</a:t>
-            </a:r>
-          </a:p>
-          <a:p>
-            <a:r>
-              <a:t>without any feedback sensor at all. 2048 steps per revolution.</a:t>
+              <a:t>Mention, do not teach. These sit on one table with a sign.</a:t>
             </a:r>
           </a:p>
           <a:p/>
           <a:p>
             <a:r>
-              <a:t>Needs a ULN2003 driver board, drawer 2A, 27 of them.</a:t>
+              <a:t>The honest warnings matter more than the specs: PPG is useless once the hand</a:t>
+            </a:r>
+          </a:p>
+          <a:p>
+            <a:r>
+              <a:t>moves, GSR drifts so only relative change works, FSRs need per-pad calibration.</a:t>
             </a:r>
           </a:p>
           <a:p/>
           <a:p>
             <a:r>
-              <a:t>If anyone tries one: the Stepper constructor does NOT take the pins in numeric</a:t>
-            </a:r>
-          </a:p>
-          <a:p>
-            <a:r>
-              <a:t>order. Wire IN1 to IN4 on pins 8 to 11, then write Stepper(2048, 8, 10, 9, 11).</a:t>
-            </a:r>
-          </a:p>
-          <a:p>
-            <a:r>
-              <a:t>Get it wrong and it buzzes and jitters instead of turning, which looks like a</a:t>
-            </a:r>
-          </a:p>
-          <a:p>
-            <a:r>
-              <a:t>dead motor. bench_tests/07_stepper has it right, with the note.</a:t>
+              <a:t>Push the phone option hard. For a lot of projects it beats everything else on</a:t>
+            </a:r>
+          </a:p>
+          <a:p>
+            <a:r>
+              <a:t>the table and needs no soldering at all.</a:t>
             </a:r>
           </a:p>
         </p:txBody>
@@ -1318,18 +1522,34 @@
           <a:lstStyle/>
           <a:p>
             <a:r>
-              <a:t>The one people forget exists. It grabs and lets go, with nothing moving.</a:t>
+              <a:t>The slide that earns the room's attention, so do not rush it.</a:t>
             </a:r>
           </a:p>
           <a:p/>
           <a:p>
             <a:r>
-              <a:t>Good answer for anything that should hold and then release: a latch, a door, a</a:t>
-            </a:r>
-          </a:p>
-          <a:p>
-            <a:r>
-              <a:t>thing that falls when the event happens.</a:t>
+              <a:t>This audience can write the code already, and they know it. Saying so out loud</a:t>
+            </a:r>
+          </a:p>
+          <a:p>
+            <a:r>
+              <a:t>buys credibility for the rest. The argument is not "you need to learn to</a:t>
+            </a:r>
+          </a:p>
+          <a:p>
+            <a:r>
+              <a:t>program a motor", it is "you cannot Google what something feels like".</a:t>
+            </a:r>
+          </a:p>
+          <a:p/>
+          <a:p>
+            <a:r>
+              <a:t>The second point is practical and lands with everyone: the parts are free and</a:t>
+            </a:r>
+          </a:p>
+          <a:p>
+            <a:r>
+              <a:t>already in the building.</a:t>
             </a:r>
           </a:p>
         </p:txBody>
@@ -1399,55 +1619,66 @@
           <a:lstStyle/>
           <a:p>
             <a:r>
-              <a:t>Two messages on one slide, and they pull in opposite directions on</a:t>
-            </a:r>
-          </a:p>
-          <a:p>
-            <a:r>
-              <a:t>purpose. Say the permission warmly, then change tone for the limits.</a:t>
+              <a:t>The slide the tinkerers will care most about, and the one where being</a:t>
+            </a:r>
+          </a:p>
+          <a:p>
+            <a:r>
+              <a:t>precise matters, because the internet is full of wrong answers.</a:t>
             </a:r>
           </a:p>
           <a:p/>
           <a:p>
             <a:r>
-              <a:t>Permission first: some students will not believe they are allowed to skip</a:t>
-            </a:r>
-          </a:p>
-          <a:p>
-            <a:r>
-              <a:t>ahead or stop early unless told. The failure mode is a pair rushing all five</a:t>
-            </a:r>
-          </a:p>
-          <a:p>
-            <a:r>
-              <a:t>badly instead of doing two properly.</a:t>
+              <a:t>The useful surprise: most Garmin watches broadcast heart rate over BLE</a:t>
+            </a:r>
+          </a:p>
+          <a:p>
+            <a:r>
+              <a:t>natively. Turn on Broadcast Heart Rate, or start a Virtual Run, and the watch</a:t>
+            </a:r>
+          </a:p>
+          <a:p>
+            <a:r>
+              <a:t>appears as an ordinary heart rate strap that Web Bluetooth can read from a web</a:t>
+            </a:r>
+          </a:p>
+          <a:p>
+            <a:r>
+              <a:t>page. No Connect IQ app, no SDK, no API key.</a:t>
             </a:r>
           </a:p>
           <a:p/>
           <a:p>
             <a:r>
-              <a:t>Then the three hard limits, and here you should sound firm. Say the numbers</a:t>
-            </a:r>
-          </a:p>
-          <a:p>
-            <a:r>
-              <a:t>out loud: a pin gives 40 mA, the motor wants about 75. It is not a rule they</a:t>
-            </a:r>
-          </a:p>
-          <a:p>
-            <a:r>
-              <a:t>have to take on faith.</a:t>
+              <a:t>Apple Watch will not. HealthKit needs a companion watchOS app in Swift, so</a:t>
+            </a:r>
+          </a:p>
+          <a:p>
+            <a:r>
+              <a:t>third-party apps that re-broadcast over BLE are the practical route.</a:t>
             </a:r>
           </a:p>
           <a:p/>
           <a:p>
             <a:r>
-              <a:t>Worth adding: a board resetting when the solenoid fires is a POWER problem,</a:t>
-            </a:r>
-          </a:p>
-          <a:p>
-            <a:r>
-              <a:t>not a code bug. That saves someone twenty minutes.</a:t>
+              <a:t>Web Bluetooth is Chrome and Edge only. Not Safari, not Firefox. Same lesson as</a:t>
+            </a:r>
+          </a:p>
+          <a:p>
+            <a:r>
+              <a:t>vibration: check the feature before it goes in a plan.</a:t>
+            </a:r>
+          </a:p>
+          <a:p/>
+          <a:p>
+            <a:r>
+              <a:t>Good project prompt if anyone wants one: a page that pairs with a strap and</a:t>
+            </a:r>
+          </a:p>
+          <a:p>
+            <a:r>
+              <a:t>drives an actuator from a live pulse. That is an afternoon.</a:t>
             </a:r>
           </a:p>
         </p:txBody>
@@ -1598,72 +1829,55 @@
           <a:lstStyle/>
           <a:p>
             <a:r>
-              <a:t>Slow down here. This is the single idea most worth stealing from today, and</a:t>
-            </a:r>
-          </a:p>
-          <a:p>
-            <a:r>
-              <a:t>it is worth interrupting the room for once most people have reached task 04.</a:t>
+              <a:t>Have them open sensors.chomskylab.dk on their own phones while you talk.</a:t>
+            </a:r>
+          </a:p>
+          <a:p>
+            <a:r>
+              <a:t>The split between what works and what does not lands far harder on their own</a:t>
+            </a:r>
+          </a:p>
+          <a:p>
+            <a:r>
+              <a:t>device than on a slide.</a:t>
             </a:r>
           </a:p>
           <a:p/>
           <a:p>
             <a:r>
-              <a:t>Two things students get wrong:</a:t>
+              <a:t>The bottom half is the single most useful fact here, and the one people get</a:t>
+            </a:r>
+          </a:p>
+          <a:p>
+            <a:r>
+              <a:t>wrong because a blog post said otherwise.</a:t>
             </a:r>
           </a:p>
           <a:p/>
           <a:p>
             <a:r>
-              <a:t>1. A fixed threshold. Works in the morning, fails after lunch, because the</a:t>
-            </a:r>
-          </a:p>
-          <a:p>
-            <a:r>
-              <a:t>   reading drifts with humidity and mains hum.</a:t>
+              <a:t>Say it plainly: iPhones do not vibrate from a web page. Not with a polyfill,</a:t>
+            </a:r>
+          </a:p>
+          <a:p>
+            <a:r>
+              <a:t>not with a library, not in Chrome for iOS, which is Safari underneath.</a:t>
             </a:r>
           </a:p>
           <a:p/>
           <a:p>
             <a:r>
-              <a:t>2. Feeding the baseline buffer always. A long press then teaches the baseline</a:t>
-            </a:r>
-          </a:p>
-          <a:p>
-            <a:r>
-              <a:t>   that a finger is normal, and the touch silently stops working. The buffer</a:t>
-            </a:r>
-          </a:p>
-          <a:p>
-            <a:r>
-              <a:t>   must only learn while untouched.</a:t>
-            </a:r>
-          </a:p>
-          <a:p/>
-          <a:p>
-            <a:r>
-              <a:t>Put the Serial Plotter on the projector. Watching the baseline wander while the</a:t>
-            </a:r>
-          </a:p>
-          <a:p>
-            <a:r>
-              <a:t>trigger line tracks it explains the whole design in ten seconds.</a:t>
-            </a:r>
-          </a:p>
-          <a:p/>
-          <a:p>
-            <a:r>
-              <a:t>For what it is worth, the rig this came from went through the same tuning: an</a:t>
-            </a:r>
-          </a:p>
-          <a:p>
-            <a:r>
-              <a:t>earlier version used 1.008 with a 50-sample baseline, the final one 1.01 with</a:t>
-            </a:r>
-          </a:p>
-          <a:p>
-            <a:r>
-              <a:t>25. Everyone tunes these.</a:t>
+              <a:t>The general lesson is bigger than vibration: check the feature on caniuse</a:t>
+            </a:r>
+          </a:p>
+          <a:p>
+            <a:r>
+              <a:t>before it goes in a project plan, not after. Two minutes now against a</a:t>
+            </a:r>
+          </a:p>
+          <a:p>
+            <a:r>
+              <a:t>rewrite in week 46.</a:t>
             </a:r>
           </a:p>
         </p:txBody>
@@ -1733,24 +1947,45 @@
           <a:lstStyle/>
           <a:p>
             <a:r>
-              <a:t>1:25. Pull the room back together.</a:t>
+              <a:t>Five minutes, and put the actual repos on screen if you can.</a:t>
             </a:r>
           </a:p>
           <a:p/>
           <a:p>
             <a:r>
-              <a:t>One sentence per group: what surprised you. No slides, no laptops. Ten minutes.</a:t>
+              <a:t>The argument: this was built by students at your stage, not by a lab with a</a:t>
+            </a:r>
+          </a:p>
+          <a:p>
+            <a:r>
+              <a:t>budget. The gap between "we should use touch" and "it moves when you touch it"</a:t>
+            </a:r>
+          </a:p>
+          <a:p>
+            <a:r>
+              <a:t>is smaller than it looks.</a:t>
             </a:r>
           </a:p>
           <a:p/>
           <a:p>
             <a:r>
-              <a:t>Expect someone to report the Peltier delay. Let that land, it is far more</a:t>
-            </a:r>
-          </a:p>
-          <a:p>
-            <a:r>
-              <a:t>persuasive from a peer than from you.</a:t>
+              <a:t>The moving screen has a browser control panel over the serial port, which is</a:t>
+            </a:r>
+          </a:p>
+          <a:p>
+            <a:r>
+              <a:t>what you will wish you had at the project demonstrations.</a:t>
+            </a:r>
+          </a:p>
+          <a:p/>
+          <a:p>
+            <a:r>
+              <a:t>Note for you: the sock repo has a hardcoded Wi-Fi password and live patient IDs</a:t>
+            </a:r>
+          </a:p>
+          <a:p>
+            <a:r>
+              <a:t>in it. Scrub before showing, or show only the calibration section.</a:t>
             </a:r>
           </a:p>
         </p:txBody>
@@ -1820,29 +2055,18 @@
           <a:lstStyle/>
           <a:p>
             <a:r>
-              <a:t>Mention, do not teach. These sit on one table with a sign.</a:t>
+              <a:t>1:35. The blind test.</a:t>
             </a:r>
           </a:p>
           <a:p/>
           <a:p>
             <a:r>
-              <a:t>The honest warnings matter more than the specs: PPG is useless once the hand</a:t>
-            </a:r>
-          </a:p>
-          <a:p>
-            <a:r>
-              <a:t>moves, GSR drifts so only relative change works, FSRs need per-pad calibration.</a:t>
-            </a:r>
-          </a:p>
-          <a:p/>
-          <a:p>
-            <a:r>
-              <a:t>Push the phone option hard. For a lot of projects it beats everything else on</a:t>
-            </a:r>
-          </a:p>
-          <a:p>
-            <a:r>
-              <a:t>the table and needs no soldering at all.</a:t>
+              <a:t>Most groups will already have something from task 05. This is where it gets</a:t>
+            </a:r>
+          </a:p>
+          <a:p>
+            <a:r>
+              <a:t>tested by someone who did not build it.</a:t>
             </a:r>
           </a:p>
         </p:txBody>
@@ -1912,34 +2136,39 @@
           <a:lstStyle/>
           <a:p>
             <a:r>
-              <a:t>The slide that earns the room's attention, so do not rush it.</a:t>
+              <a:t>Read the brief out once, then get out of the way. Full wording, since the</a:t>
+            </a:r>
+          </a:p>
+          <a:p>
+            <a:r>
+              <a:t>slide is only the bones:</a:t>
             </a:r>
           </a:p>
           <a:p/>
           <a:p>
             <a:r>
-              <a:t>This audience can write the code already, and they know it. Saying so out loud</a:t>
-            </a:r>
-          </a:p>
-          <a:p>
-            <a:r>
-              <a:t>buys credibility for the rest. The argument is not "you need to learn to</a:t>
-            </a:r>
-          </a:p>
-          <a:p>
-            <a:r>
-              <a:t>program a motor", it is "you cannot Google what something feels like".</a:t>
+              <a:t>"Pick one actuator. Encode three messages: arrived, something wrong, finished.</a:t>
+            </a:r>
+          </a:p>
+          <a:p>
+            <a:r>
+              <a:t>Vary only the rhythm of the pulses and how strong they are. Then hand it to</a:t>
+            </a:r>
+          </a:p>
+          <a:p>
+            <a:r>
+              <a:t>another group with the screen turned away and see if they can name all three."</a:t>
             </a:r>
           </a:p>
           <a:p/>
           <a:p>
             <a:r>
-              <a:t>The second point is practical and lands with everyone: the parts are free and</a:t>
-            </a:r>
-          </a:p>
-          <a:p>
-            <a:r>
-              <a:t>already in the building.</a:t>
+              <a:t>If someone asks to add a second actuator, say no. The constraint is the</a:t>
+            </a:r>
+          </a:p>
+          <a:p>
+            <a:r>
+              <a:t>exercise.</a:t>
             </a:r>
           </a:p>
         </p:txBody>
@@ -2009,66 +2238,24 @@
           <a:lstStyle/>
           <a:p>
             <a:r>
-              <a:t>The slide the tinkerers will care most about, and the one where being</a:t>
-            </a:r>
-          </a:p>
-          <a:p>
-            <a:r>
-              <a:t>precise matters, because the internet is full of wrong answers.</a:t>
+              <a:t>The line worth repeating twice.</a:t>
             </a:r>
           </a:p>
           <a:p/>
           <a:p>
             <a:r>
-              <a:t>The useful surprise: most Garmin watches broadcast heart rate over BLE</a:t>
-            </a:r>
-          </a:p>
-          <a:p>
-            <a:r>
-              <a:t>natively. Turn on Broadcast Heart Rate, or start a Virtual Run, and the watch</a:t>
-            </a:r>
-          </a:p>
-          <a:p>
-            <a:r>
-              <a:t>appears as an ordinary heart rate strap that Web Bluetooth can read from a web</a:t>
-            </a:r>
-          </a:p>
-          <a:p>
-            <a:r>
-              <a:t>page. No Connect IQ app, no SDK, no API key.</a:t>
+              <a:t>Run the test: swap groups, receiver looks away, guess all three.</a:t>
             </a:r>
           </a:p>
           <a:p/>
           <a:p>
             <a:r>
-              <a:t>Apple Watch will not. HealthKit needs a companion watchOS app in Swift, so</a:t>
-            </a:r>
-          </a:p>
-          <a:p>
-            <a:r>
-              <a:t>third-party apps that re-broadcast over BLE are the practical route.</a:t>
-            </a:r>
-          </a:p>
-          <a:p/>
-          <a:p>
-            <a:r>
-              <a:t>Web Bluetooth is Chrome and Edge only. Not Safari, not Firefox. Same lesson as</a:t>
-            </a:r>
-          </a:p>
-          <a:p>
-            <a:r>
-              <a:t>vibration: check the feature before it goes in a plan.</a:t>
-            </a:r>
-          </a:p>
-          <a:p/>
-          <a:p>
-            <a:r>
-              <a:t>Good project prompt if anyone wants one: a page that pairs with a strap and</a:t>
-            </a:r>
-          </a:p>
-          <a:p>
-            <a:r>
-              <a:t>drives an actuator from a live pulse. That is an afternoon.</a:t>
+              <a:t>Then have each group name which two got confused and what would have separated</a:t>
+            </a:r>
+          </a:p>
+          <a:p>
+            <a:r>
+              <a:t>them. That confusion is the actual learning, not the successful ones.</a:t>
             </a:r>
           </a:p>
         </p:txBody>
@@ -2138,55 +2325,44 @@
           <a:lstStyle/>
           <a:p>
             <a:r>
-              <a:t>Have them open sensors.chomskylab.dk on their own phones while you talk.</a:t>
-            </a:r>
-          </a:p>
-          <a:p>
-            <a:r>
-              <a:t>The split between what works and what does not lands far harder on their own</a:t>
-            </a:r>
-          </a:p>
-          <a:p>
-            <a:r>
-              <a:t>device than on a slide.</a:t>
+              <a:t>Put this up while the blind tests run, so groups can check themselves</a:t>
+            </a:r>
+          </a:p>
+          <a:p>
+            <a:r>
+              <a:t>without asking you.</a:t>
             </a:r>
           </a:p>
           <a:p/>
           <a:p>
             <a:r>
-              <a:t>The bottom half is the single most useful fact here, and the one people get</a:t>
-            </a:r>
-          </a:p>
-          <a:p>
-            <a:r>
-              <a:t>wrong because a blog post said otherwise.</a:t>
+              <a:t>The middle line matters most: a device that fires continuously when held is</a:t>
+            </a:r>
+          </a:p>
+          <a:p>
+            <a:r>
+              <a:t>the single most common bug, and it is a debounce problem.</a:t>
             </a:r>
           </a:p>
           <a:p/>
           <a:p>
             <a:r>
-              <a:t>Say it plainly: iPhones do not vibrate from a web page. Not with a polyfill,</a:t>
-            </a:r>
-          </a:p>
-          <a:p>
-            <a:r>
-              <a:t>not with a library, not in Chrome for iOS, which is Safari underneath.</a:t>
-            </a:r>
-          </a:p>
-          <a:p/>
-          <a:p>
-            <a:r>
-              <a:t>The general lesson is bigger than vibration: check the feature on caniuse</a:t>
-            </a:r>
-          </a:p>
-          <a:p>
-            <a:r>
-              <a:t>before it goes in a project plan, not after. Two minutes now against a</a:t>
-            </a:r>
-          </a:p>
-          <a:p>
-            <a:r>
-              <a:t>rewrite in week 46.</a:t>
+              <a:t>Then close on the bottom half, thirty seconds. If they leave with one thing,</a:t>
+            </a:r>
+          </a:p>
+          <a:p>
+            <a:r>
+              <a:t>make it the last point: pick the actuator before designing the interaction.</a:t>
+            </a:r>
+          </a:p>
+          <a:p>
+            <a:r>
+              <a:t>Discovering in week 46 that the chosen one cannot do the job is the expensive</a:t>
+            </a:r>
+          </a:p>
+          <a:p>
+            <a:r>
+              <a:t>mistake this session exists to prevent.</a:t>
             </a:r>
           </a:p>
         </p:txBody>
@@ -2256,315 +2432,40 @@
           <a:lstStyle/>
           <a:p>
             <a:r>
-              <a:t>Five minutes, and put the actual repos on screen if you can.</a:t>
+              <a:t>Point them at the repo. Every task sketch is commented for them, and the</a:t>
+            </a:r>
+          </a:p>
+          <a:p>
+            <a:r>
+              <a:t>bench test sketches are there too if they want to see the minimal version.</a:t>
             </a:r>
           </a:p>
           <a:p/>
           <a:p>
             <a:r>
-              <a:t>The argument: this was built by students at your stage, not by a lab with a</a:t>
-            </a:r>
-          </a:p>
-          <a:p>
-            <a:r>
-              <a:t>budget. The gap between "we should use touch" and "it moves when you touch it"</a:t>
-            </a:r>
-          </a:p>
-          <a:p>
-            <a:r>
-              <a:t>is smaller than it looks.</a:t>
+              <a:t>Last thing to say: pick your actuator before you design the interaction, not</a:t>
+            </a:r>
+          </a:p>
+          <a:p>
+            <a:r>
+              <a:t>after. Today was so they can do that from experience rather than a datasheet.</a:t>
             </a:r>
           </a:p>
           <a:p/>
           <a:p>
             <a:r>
-              <a:t>The moving screen has a browser control panel over the serial port, which is</a:t>
-            </a:r>
-          </a:p>
-          <a:p>
-            <a:r>
-              <a:t>what you will wish you had at the project demonstrations.</a:t>
+              <a:t>Pack down: everything back in the box, including the resistors. It will not all</a:t>
+            </a:r>
+          </a:p>
+          <a:p>
+            <a:r>
+              <a:t>come back.</a:t>
             </a:r>
           </a:p>
           <a:p/>
           <a:p>
             <a:r>
-              <a:t>Note for you: the sock repo has a hardcoded Wi-Fi password and live patient IDs</a:t>
-            </a:r>
-          </a:p>
-          <a:p>
-            <a:r>
-              <a:t>in it. Scrub before showing, or show only the calibration section.</a:t>
-            </a:r>
-          </a:p>
-        </p:txBody>
-      </p:sp>
-      <p:sp>
-        <p:nvSpPr>
-          <p:cNvPr id="4" name="Slide Number Placeholder 3"/>
-          <p:cNvSpPr>
-            <a:spLocks noGrp="1"/>
-          </p:cNvSpPr>
-          <p:nvPr>
-            <p:ph type="sldNum" idx="5" sz="quarter"/>
-          </p:nvPr>
-        </p:nvSpPr>
-        <p:spPr/>
-      </p:sp>
-    </p:spTree>
-  </p:cSld>
-  <p:clrMapOvr>
-    <a:masterClrMapping/>
-  </p:clrMapOvr>
-</p:notes>
-</file>
-
-<file path=ppt/notesSlides/notesSlide27.xml><?xml version="1.0" encoding="utf-8"?>
-<p:notes xmlns:a="http://schemas.openxmlformats.org/drawingml/2006/main" xmlns:p="http://schemas.openxmlformats.org/presentationml/2006/main" xmlns:r="http://schemas.openxmlformats.org/officeDocument/2006/relationships">
-  <p:cSld>
-    <p:spTree>
-      <p:nvGrpSpPr>
-        <p:cNvPr id="1" name=""/>
-        <p:cNvGrpSpPr/>
-        <p:nvPr/>
-      </p:nvGrpSpPr>
-      <p:grpSpPr>
-        <a:xfrm>
-          <a:off x="0" y="0"/>
-          <a:ext cx="0" cy="0"/>
-          <a:chOff x="0" y="0"/>
-          <a:chExt cx="0" cy="0"/>
-        </a:xfrm>
-      </p:grpSpPr>
-      <p:sp>
-        <p:nvSpPr>
-          <p:cNvPr id="2" name="Slide Image Placeholder 1"/>
-          <p:cNvSpPr>
-            <a:spLocks noGrp="1"/>
-          </p:cNvSpPr>
-          <p:nvPr>
-            <p:ph type="sldImg" idx="2"/>
-          </p:nvPr>
-        </p:nvSpPr>
-        <p:spPr/>
-      </p:sp>
-      <p:sp>
-        <p:nvSpPr>
-          <p:cNvPr id="3" name="Notes Placeholder 2"/>
-          <p:cNvSpPr>
-            <a:spLocks noGrp="1"/>
-          </p:cNvSpPr>
-          <p:nvPr>
-            <p:ph type="body" idx="3" sz="quarter"/>
-          </p:nvPr>
-        </p:nvSpPr>
-        <p:spPr/>
-        <p:txBody>
-          <a:bodyPr/>
-          <a:lstStyle/>
-          <a:p>
-            <a:r>
-              <a:t>1:35. The blind test.</a:t>
-            </a:r>
-          </a:p>
-          <a:p/>
-          <a:p>
-            <a:r>
-              <a:t>Most groups will already have something from task 05. This is where it gets</a:t>
-            </a:r>
-          </a:p>
-          <a:p>
-            <a:r>
-              <a:t>tested by someone who did not build it.</a:t>
-            </a:r>
-          </a:p>
-        </p:txBody>
-      </p:sp>
-      <p:sp>
-        <p:nvSpPr>
-          <p:cNvPr id="4" name="Slide Number Placeholder 3"/>
-          <p:cNvSpPr>
-            <a:spLocks noGrp="1"/>
-          </p:cNvSpPr>
-          <p:nvPr>
-            <p:ph type="sldNum" idx="5" sz="quarter"/>
-          </p:nvPr>
-        </p:nvSpPr>
-        <p:spPr/>
-      </p:sp>
-    </p:spTree>
-  </p:cSld>
-  <p:clrMapOvr>
-    <a:masterClrMapping/>
-  </p:clrMapOvr>
-</p:notes>
-</file>
-
-<file path=ppt/notesSlides/notesSlide28.xml><?xml version="1.0" encoding="utf-8"?>
-<p:notes xmlns:a="http://schemas.openxmlformats.org/drawingml/2006/main" xmlns:p="http://schemas.openxmlformats.org/presentationml/2006/main" xmlns:r="http://schemas.openxmlformats.org/officeDocument/2006/relationships">
-  <p:cSld>
-    <p:spTree>
-      <p:nvGrpSpPr>
-        <p:cNvPr id="1" name=""/>
-        <p:cNvGrpSpPr/>
-        <p:nvPr/>
-      </p:nvGrpSpPr>
-      <p:grpSpPr>
-        <a:xfrm>
-          <a:off x="0" y="0"/>
-          <a:ext cx="0" cy="0"/>
-          <a:chOff x="0" y="0"/>
-          <a:chExt cx="0" cy="0"/>
-        </a:xfrm>
-      </p:grpSpPr>
-      <p:sp>
-        <p:nvSpPr>
-          <p:cNvPr id="2" name="Slide Image Placeholder 1"/>
-          <p:cNvSpPr>
-            <a:spLocks noGrp="1"/>
-          </p:cNvSpPr>
-          <p:nvPr>
-            <p:ph type="sldImg" idx="2"/>
-          </p:nvPr>
-        </p:nvSpPr>
-        <p:spPr/>
-      </p:sp>
-      <p:sp>
-        <p:nvSpPr>
-          <p:cNvPr id="3" name="Notes Placeholder 2"/>
-          <p:cNvSpPr>
-            <a:spLocks noGrp="1"/>
-          </p:cNvSpPr>
-          <p:nvPr>
-            <p:ph type="body" idx="3" sz="quarter"/>
-          </p:nvPr>
-        </p:nvSpPr>
-        <p:spPr/>
-        <p:txBody>
-          <a:bodyPr/>
-          <a:lstStyle/>
-          <a:p>
-            <a:r>
-              <a:t>Read the brief out once, then get out of the way. Full wording, since the</a:t>
-            </a:r>
-          </a:p>
-          <a:p>
-            <a:r>
-              <a:t>slide is only the bones:</a:t>
-            </a:r>
-          </a:p>
-          <a:p/>
-          <a:p>
-            <a:r>
-              <a:t>"Pick one actuator. Encode three messages: arrived, something wrong, finished.</a:t>
-            </a:r>
-          </a:p>
-          <a:p>
-            <a:r>
-              <a:t>Vary only the rhythm of the pulses and how strong they are. Then hand it to</a:t>
-            </a:r>
-          </a:p>
-          <a:p>
-            <a:r>
-              <a:t>another group with the screen turned away and see if they can name all three."</a:t>
-            </a:r>
-          </a:p>
-          <a:p/>
-          <a:p>
-            <a:r>
-              <a:t>If someone asks to add a second actuator, say no. The constraint is the</a:t>
-            </a:r>
-          </a:p>
-          <a:p>
-            <a:r>
-              <a:t>exercise.</a:t>
-            </a:r>
-          </a:p>
-        </p:txBody>
-      </p:sp>
-      <p:sp>
-        <p:nvSpPr>
-          <p:cNvPr id="4" name="Slide Number Placeholder 3"/>
-          <p:cNvSpPr>
-            <a:spLocks noGrp="1"/>
-          </p:cNvSpPr>
-          <p:nvPr>
-            <p:ph type="sldNum" idx="5" sz="quarter"/>
-          </p:nvPr>
-        </p:nvSpPr>
-        <p:spPr/>
-      </p:sp>
-    </p:spTree>
-  </p:cSld>
-  <p:clrMapOvr>
-    <a:masterClrMapping/>
-  </p:clrMapOvr>
-</p:notes>
-</file>
-
-<file path=ppt/notesSlides/notesSlide29.xml><?xml version="1.0" encoding="utf-8"?>
-<p:notes xmlns:a="http://schemas.openxmlformats.org/drawingml/2006/main" xmlns:p="http://schemas.openxmlformats.org/presentationml/2006/main" xmlns:r="http://schemas.openxmlformats.org/officeDocument/2006/relationships">
-  <p:cSld>
-    <p:spTree>
-      <p:nvGrpSpPr>
-        <p:cNvPr id="1" name=""/>
-        <p:cNvGrpSpPr/>
-        <p:nvPr/>
-      </p:nvGrpSpPr>
-      <p:grpSpPr>
-        <a:xfrm>
-          <a:off x="0" y="0"/>
-          <a:ext cx="0" cy="0"/>
-          <a:chOff x="0" y="0"/>
-          <a:chExt cx="0" cy="0"/>
-        </a:xfrm>
-      </p:grpSpPr>
-      <p:sp>
-        <p:nvSpPr>
-          <p:cNvPr id="2" name="Slide Image Placeholder 1"/>
-          <p:cNvSpPr>
-            <a:spLocks noGrp="1"/>
-          </p:cNvSpPr>
-          <p:nvPr>
-            <p:ph type="sldImg" idx="2"/>
-          </p:nvPr>
-        </p:nvSpPr>
-        <p:spPr/>
-      </p:sp>
-      <p:sp>
-        <p:nvSpPr>
-          <p:cNvPr id="3" name="Notes Placeholder 2"/>
-          <p:cNvSpPr>
-            <a:spLocks noGrp="1"/>
-          </p:cNvSpPr>
-          <p:nvPr>
-            <p:ph type="body" idx="3" sz="quarter"/>
-          </p:nvPr>
-        </p:nvSpPr>
-        <p:spPr/>
-        <p:txBody>
-          <a:bodyPr/>
-          <a:lstStyle/>
-          <a:p>
-            <a:r>
-              <a:t>The line worth repeating twice.</a:t>
-            </a:r>
-          </a:p>
-          <a:p/>
-          <a:p>
-            <a:r>
-              <a:t>Run the test: swap groups, receiver looks away, guess all three.</a:t>
-            </a:r>
-          </a:p>
-          <a:p/>
-          <a:p>
-            <a:r>
-              <a:t>Then have each group name which two got confused and what would have separated</a:t>
-            </a:r>
-          </a:p>
-          <a:p>
-            <a:r>
-              <a:t>them. That confusion is the actual learning, not the successful ones.</a:t>
+              <a:t>If anyone wants to borrow parts for the project weeks, now is when they ask.</a:t>
             </a:r>
           </a:p>
         </p:txBody>
@@ -2662,216 +2563,6 @@
           <a:p>
             <a:r>
               <a:t>designed on paper then dropped. Two minutes, then move.</a:t>
-            </a:r>
-          </a:p>
-        </p:txBody>
-      </p:sp>
-      <p:sp>
-        <p:nvSpPr>
-          <p:cNvPr id="4" name="Slide Number Placeholder 3"/>
-          <p:cNvSpPr>
-            <a:spLocks noGrp="1"/>
-          </p:cNvSpPr>
-          <p:nvPr>
-            <p:ph type="sldNum" idx="5" sz="quarter"/>
-          </p:nvPr>
-        </p:nvSpPr>
-        <p:spPr/>
-      </p:sp>
-    </p:spTree>
-  </p:cSld>
-  <p:clrMapOvr>
-    <a:masterClrMapping/>
-  </p:clrMapOvr>
-</p:notes>
-</file>
-
-<file path=ppt/notesSlides/notesSlide30.xml><?xml version="1.0" encoding="utf-8"?>
-<p:notes xmlns:a="http://schemas.openxmlformats.org/drawingml/2006/main" xmlns:p="http://schemas.openxmlformats.org/presentationml/2006/main" xmlns:r="http://schemas.openxmlformats.org/officeDocument/2006/relationships">
-  <p:cSld>
-    <p:spTree>
-      <p:nvGrpSpPr>
-        <p:cNvPr id="1" name=""/>
-        <p:cNvGrpSpPr/>
-        <p:nvPr/>
-      </p:nvGrpSpPr>
-      <p:grpSpPr>
-        <a:xfrm>
-          <a:off x="0" y="0"/>
-          <a:ext cx="0" cy="0"/>
-          <a:chOff x="0" y="0"/>
-          <a:chExt cx="0" cy="0"/>
-        </a:xfrm>
-      </p:grpSpPr>
-      <p:sp>
-        <p:nvSpPr>
-          <p:cNvPr id="2" name="Slide Image Placeholder 1"/>
-          <p:cNvSpPr>
-            <a:spLocks noGrp="1"/>
-          </p:cNvSpPr>
-          <p:nvPr>
-            <p:ph type="sldImg" idx="2"/>
-          </p:nvPr>
-        </p:nvSpPr>
-        <p:spPr/>
-      </p:sp>
-      <p:sp>
-        <p:nvSpPr>
-          <p:cNvPr id="3" name="Notes Placeholder 2"/>
-          <p:cNvSpPr>
-            <a:spLocks noGrp="1"/>
-          </p:cNvSpPr>
-          <p:nvPr>
-            <p:ph type="body" idx="3" sz="quarter"/>
-          </p:nvPr>
-        </p:nvSpPr>
-        <p:spPr/>
-        <p:txBody>
-          <a:bodyPr/>
-          <a:lstStyle/>
-          <a:p>
-            <a:r>
-              <a:t>Put this up while the blind tests run, so groups can check themselves</a:t>
-            </a:r>
-          </a:p>
-          <a:p>
-            <a:r>
-              <a:t>without asking you.</a:t>
-            </a:r>
-          </a:p>
-          <a:p/>
-          <a:p>
-            <a:r>
-              <a:t>The middle line matters most: a device that fires continuously when held is</a:t>
-            </a:r>
-          </a:p>
-          <a:p>
-            <a:r>
-              <a:t>the single most common bug, and it is a debounce problem.</a:t>
-            </a:r>
-          </a:p>
-          <a:p/>
-          <a:p>
-            <a:r>
-              <a:t>Then close on the bottom half, thirty seconds. If they leave with one thing,</a:t>
-            </a:r>
-          </a:p>
-          <a:p>
-            <a:r>
-              <a:t>make it the last point: pick the actuator before designing the interaction.</a:t>
-            </a:r>
-          </a:p>
-          <a:p>
-            <a:r>
-              <a:t>Discovering in week 46 that the chosen one cannot do the job is the expensive</a:t>
-            </a:r>
-          </a:p>
-          <a:p>
-            <a:r>
-              <a:t>mistake this session exists to prevent.</a:t>
-            </a:r>
-          </a:p>
-        </p:txBody>
-      </p:sp>
-      <p:sp>
-        <p:nvSpPr>
-          <p:cNvPr id="4" name="Slide Number Placeholder 3"/>
-          <p:cNvSpPr>
-            <a:spLocks noGrp="1"/>
-          </p:cNvSpPr>
-          <p:nvPr>
-            <p:ph type="sldNum" idx="5" sz="quarter"/>
-          </p:nvPr>
-        </p:nvSpPr>
-        <p:spPr/>
-      </p:sp>
-    </p:spTree>
-  </p:cSld>
-  <p:clrMapOvr>
-    <a:masterClrMapping/>
-  </p:clrMapOvr>
-</p:notes>
-</file>
-
-<file path=ppt/notesSlides/notesSlide31.xml><?xml version="1.0" encoding="utf-8"?>
-<p:notes xmlns:a="http://schemas.openxmlformats.org/drawingml/2006/main" xmlns:p="http://schemas.openxmlformats.org/presentationml/2006/main" xmlns:r="http://schemas.openxmlformats.org/officeDocument/2006/relationships">
-  <p:cSld>
-    <p:spTree>
-      <p:nvGrpSpPr>
-        <p:cNvPr id="1" name=""/>
-        <p:cNvGrpSpPr/>
-        <p:nvPr/>
-      </p:nvGrpSpPr>
-      <p:grpSpPr>
-        <a:xfrm>
-          <a:off x="0" y="0"/>
-          <a:ext cx="0" cy="0"/>
-          <a:chOff x="0" y="0"/>
-          <a:chExt cx="0" cy="0"/>
-        </a:xfrm>
-      </p:grpSpPr>
-      <p:sp>
-        <p:nvSpPr>
-          <p:cNvPr id="2" name="Slide Image Placeholder 1"/>
-          <p:cNvSpPr>
-            <a:spLocks noGrp="1"/>
-          </p:cNvSpPr>
-          <p:nvPr>
-            <p:ph type="sldImg" idx="2"/>
-          </p:nvPr>
-        </p:nvSpPr>
-        <p:spPr/>
-      </p:sp>
-      <p:sp>
-        <p:nvSpPr>
-          <p:cNvPr id="3" name="Notes Placeholder 2"/>
-          <p:cNvSpPr>
-            <a:spLocks noGrp="1"/>
-          </p:cNvSpPr>
-          <p:nvPr>
-            <p:ph type="body" idx="3" sz="quarter"/>
-          </p:nvPr>
-        </p:nvSpPr>
-        <p:spPr/>
-        <p:txBody>
-          <a:bodyPr/>
-          <a:lstStyle/>
-          <a:p>
-            <a:r>
-              <a:t>Point them at the repo. Every task sketch is commented for them, and the</a:t>
-            </a:r>
-          </a:p>
-          <a:p>
-            <a:r>
-              <a:t>bench test sketches are there too if they want to see the minimal version.</a:t>
-            </a:r>
-          </a:p>
-          <a:p/>
-          <a:p>
-            <a:r>
-              <a:t>Last thing to say: pick your actuator before you design the interaction, not</a:t>
-            </a:r>
-          </a:p>
-          <a:p>
-            <a:r>
-              <a:t>after. Today was so they can do that from experience rather than a datasheet.</a:t>
-            </a:r>
-          </a:p>
-          <a:p/>
-          <a:p>
-            <a:r>
-              <a:t>Pack down: everything back in the box, including the resistors. It will not all</a:t>
-            </a:r>
-          </a:p>
-          <a:p>
-            <a:r>
-              <a:t>come back.</a:t>
-            </a:r>
-          </a:p>
-          <a:p/>
-          <a:p>
-            <a:r>
-              <a:t>If anyone wants to borrow parts for the project weeks, now is when they ask.</a:t>
             </a:r>
           </a:p>
         </p:txBody>
@@ -6780,7 +6471,7 @@
                 </a:solidFill>
                 <a:latin typeface="Arial"/>
               </a:rPr>
-              <a:t>VIBRATING MINI MOTOR DISC</a:t>
+              <a:t>PIEZO ELEMENT</a:t>
             </a:r>
           </a:p>
         </p:txBody>
@@ -6821,7 +6512,7 @@
                 </a:solidFill>
                 <a:latin typeface="Arial"/>
               </a:rPr>
-              <a:t>An off-centre weight on a motor shaft, sealed in a disc. The same part as in your phone.</a:t>
+              <a:t>A crystal that flexes when you put current across it. Near-instant, almost no power, but shallow.</a:t>
             </a:r>
           </a:p>
           <a:p>
@@ -6841,7 +6532,7 @@
                 </a:solidFill>
                 <a:latin typeface="Arial"/>
               </a:rPr>
-              <a:t>Feels like: a buzz you cannot make gentle and fast at once.</a:t>
+              <a:t>Feels like: a tick, not a thump.</a:t>
             </a:r>
           </a:p>
           <a:p>
@@ -6881,7 +6572,7 @@
                 </a:solidFill>
                 <a:latin typeface="Arial"/>
               </a:rPr>
-              <a:t>Phone notifications, controller rumble, anything worn under clothing.</a:t>
+              <a:t>Clicks and confirmations. Anything where lag would feel broken.</a:t>
             </a:r>
           </a:p>
           <a:p>
@@ -6901,248 +6592,7 @@
                 </a:solidFill>
                 <a:latin typeface="Consolas"/>
               </a:rPr>
-              <a:t>1E  |  117  |  2.5-3.8V rated  |  100 mA at 5V  |  PWM</a:t>
-            </a:r>
-          </a:p>
-        </p:txBody>
-      </p:sp>
-      <p:pic>
-        <p:nvPicPr>
-          <p:cNvPr id="4" name="Picture 3" descr="erm.jpg"/>
-          <p:cNvPicPr>
-            <a:picLocks noChangeAspect="1"/>
-          </p:cNvPicPr>
-          <p:nvPr/>
-        </p:nvPicPr>
-        <p:blipFill>
-          <a:blip r:embed="rId2"/>
-          <a:stretch>
-            <a:fillRect/>
-          </a:stretch>
-        </p:blipFill>
-        <p:spPr>
-          <a:xfrm>
-            <a:off x="914400" y="1905000"/>
-            <a:ext cx="4191000" cy="3145410"/>
-          </a:xfrm>
-          <a:prstGeom prst="rect">
-            <a:avLst/>
-          </a:prstGeom>
-        </p:spPr>
-      </p:pic>
-      <p:pic>
-        <p:nvPicPr>
-          <p:cNvPr id="5" name="Picture 4" descr="wordmark_dark.png"/>
-          <p:cNvPicPr>
-            <a:picLocks noChangeAspect="1"/>
-          </p:cNvPicPr>
-          <p:nvPr/>
-        </p:nvPicPr>
-        <p:blipFill>
-          <a:blip r:embed="rId3"/>
-          <a:stretch>
-            <a:fillRect/>
-          </a:stretch>
-        </p:blipFill>
-        <p:spPr>
-          <a:xfrm>
-            <a:off x="342900" y="6184900"/>
-            <a:ext cx="2070100" cy="529560"/>
-          </a:xfrm>
-          <a:prstGeom prst="rect">
-            <a:avLst/>
-          </a:prstGeom>
-        </p:spPr>
-      </p:pic>
-      <p:pic>
-        <p:nvPicPr>
-          <p:cNvPr id="6" name="Picture 5" descr="seal_dark.png"/>
-          <p:cNvPicPr>
-            <a:picLocks noChangeAspect="1"/>
-          </p:cNvPicPr>
-          <p:nvPr/>
-        </p:nvPicPr>
-        <p:blipFill>
-          <a:blip r:embed="rId4"/>
-          <a:stretch>
-            <a:fillRect/>
-          </a:stretch>
-        </p:blipFill>
-        <p:spPr>
-          <a:xfrm>
-            <a:off x="11226800" y="5969000"/>
-            <a:ext cx="713915" cy="711200"/>
-          </a:xfrm>
-          <a:prstGeom prst="rect">
-            <a:avLst/>
-          </a:prstGeom>
-        </p:spPr>
-      </p:pic>
-    </p:spTree>
-  </p:cSld>
-  <p:clrMapOvr>
-    <a:masterClrMapping/>
-  </p:clrMapOvr>
-</p:sld>
-</file>
-
-<file path=ppt/slides/slide11.xml><?xml version="1.0" encoding="utf-8"?>
-<p:sld xmlns:a="http://schemas.openxmlformats.org/drawingml/2006/main" xmlns:p="http://schemas.openxmlformats.org/presentationml/2006/main" xmlns:r="http://schemas.openxmlformats.org/officeDocument/2006/relationships">
-  <p:cSld>
-    <p:spTree>
-      <p:nvGrpSpPr>
-        <p:cNvPr id="1" name=""/>
-        <p:cNvGrpSpPr/>
-        <p:nvPr/>
-      </p:nvGrpSpPr>
-      <p:grpSpPr/>
-      <p:sp>
-        <p:nvSpPr>
-          <p:cNvPr id="2" name="Title 1"/>
-          <p:cNvSpPr>
-            <a:spLocks noGrp="1"/>
-          </p:cNvSpPr>
-          <p:nvPr>
-            <p:ph type="title"/>
-          </p:nvPr>
-        </p:nvSpPr>
-        <p:spPr/>
-        <p:txBody>
-          <a:bodyPr/>
-          <a:lstStyle/>
-          <a:p>
-            <a:pPr marL="0" indent="0" algn="l">
-              <a:buNone/>
-            </a:pPr>
-            <a:r>
-              <a:rPr sz="3200" b="1">
-                <a:solidFill>
-                  <a:srgbClr val="000000"/>
-                </a:solidFill>
-                <a:latin typeface="Arial"/>
-              </a:rPr>
-              <a:t>PIEZO ELEMENT</a:t>
-            </a:r>
-          </a:p>
-        </p:txBody>
-      </p:sp>
-      <p:sp>
-        <p:nvSpPr>
-          <p:cNvPr id="3" name="Text Placeholder 2"/>
-          <p:cNvSpPr>
-            <a:spLocks noGrp="1"/>
-          </p:cNvSpPr>
-          <p:nvPr>
-            <p:ph type="body" idx="1"/>
-          </p:nvPr>
-        </p:nvSpPr>
-        <p:spPr>
-          <a:xfrm>
-            <a:off x="5461000" y="1905000"/>
-            <a:ext cx="5486400" cy="3302000"/>
-          </a:xfrm>
-        </p:spPr>
-        <p:txBody>
-          <a:bodyPr/>
-          <a:lstStyle/>
-          <a:p>
-            <a:pPr marL="0" indent="0" algn="l">
-              <a:lnSpc>
-                <a:spcPct val="130000"/>
-              </a:lnSpc>
-              <a:spcAft>
-                <a:spcPts val="1200"/>
-              </a:spcAft>
-              <a:buNone/>
-            </a:pPr>
-            <a:r>
-              <a:rPr sz="1600" b="0">
-                <a:solidFill>
-                  <a:srgbClr val="000000"/>
-                </a:solidFill>
-                <a:latin typeface="Arial"/>
-              </a:rPr>
-              <a:t>A crystal that flexes when you put current across it. Near-instant, almost no power, but shallow.</a:t>
-            </a:r>
-          </a:p>
-          <a:p>
-            <a:pPr marL="0" indent="0" algn="l">
-              <a:lnSpc>
-                <a:spcPct val="130000"/>
-              </a:lnSpc>
-              <a:spcAft>
-                <a:spcPts val="1400"/>
-              </a:spcAft>
-              <a:buNone/>
-            </a:pPr>
-            <a:r>
-              <a:rPr sz="1600" b="1">
-                <a:solidFill>
-                  <a:srgbClr val="002546"/>
-                </a:solidFill>
-                <a:latin typeface="Arial"/>
-              </a:rPr>
-              <a:t>Feels like: a tick, not a thump.</a:t>
-            </a:r>
-          </a:p>
-          <a:p>
-            <a:pPr marL="0" indent="0" algn="l">
-              <a:lnSpc>
-                <a:spcPct val="130000"/>
-              </a:lnSpc>
-              <a:spcAft>
-                <a:spcPts val="400"/>
-              </a:spcAft>
-              <a:buNone/>
-            </a:pPr>
-            <a:r>
-              <a:rPr sz="900" b="1">
-                <a:solidFill>
-                  <a:srgbClr val="595959"/>
-                </a:solidFill>
-                <a:latin typeface="Arial"/>
-              </a:rPr>
-              <a:t>USED FOR</a:t>
-            </a:r>
-          </a:p>
-          <a:p>
-            <a:pPr marL="0" indent="0" algn="l">
-              <a:lnSpc>
-                <a:spcPct val="130000"/>
-              </a:lnSpc>
-              <a:spcAft>
-                <a:spcPts val="1400"/>
-              </a:spcAft>
-              <a:buNone/>
-            </a:pPr>
-            <a:r>
-              <a:rPr sz="1400" b="0">
-                <a:solidFill>
-                  <a:srgbClr val="000000"/>
-                </a:solidFill>
-                <a:latin typeface="Arial"/>
-              </a:rPr>
-              <a:t>Clicks and confirmations. Anything where lag would feel broken.</a:t>
-            </a:r>
-          </a:p>
-          <a:p>
-            <a:pPr marL="0" indent="0" algn="l">
-              <a:lnSpc>
-                <a:spcPct val="130000"/>
-              </a:lnSpc>
-              <a:spcAft>
-                <a:spcPts val="0"/>
-              </a:spcAft>
-              <a:buNone/>
-            </a:pPr>
-            <a:r>
-              <a:rPr sz="1200" b="0">
-                <a:solidFill>
-                  <a:srgbClr val="595959"/>
-                </a:solidFill>
-                <a:latin typeface="Consolas"/>
-              </a:rPr>
-              <a:t>Drawer 6F  |  69 in stock  |  any digital pin</a:t>
+              <a:t>Drawer 6F  |  69 in stock  |  two wires, no driver</a:t>
             </a:r>
           </a:p>
         </p:txBody>
@@ -7227,7 +6677,7 @@
 </p:sld>
 </file>
 
-<file path=ppt/slides/slide12.xml><?xml version="1.0" encoding="utf-8"?>
+<file path=ppt/slides/slide11.xml><?xml version="1.0" encoding="utf-8"?>
 <p:sld xmlns:a="http://schemas.openxmlformats.org/drawingml/2006/main" xmlns:p="http://schemas.openxmlformats.org/presentationml/2006/main" xmlns:r="http://schemas.openxmlformats.org/officeDocument/2006/relationships">
   <p:cSld>
     <p:spTree>
@@ -7262,7 +6712,7 @@
                 </a:solidFill>
                 <a:latin typeface="Arial"/>
               </a:rPr>
-              <a:t>MINI PUSH-PULL SOLENOID</a:t>
+              <a:t>CAPACITIVE PAD</a:t>
             </a:r>
           </a:p>
         </p:txBody>
@@ -7303,7 +6753,7 @@
                 </a:solidFill>
                 <a:latin typeface="Arial"/>
               </a:rPr>
-              <a:t>A coil that yanks a metal rod when you energise it. No half a tap: it fires or it does not.</a:t>
+              <a:t>A wire taped behind foil, card or fabric. No sensor and no breakout board, which is why the box on the left is empty.</a:t>
             </a:r>
           </a:p>
           <a:p>
@@ -7323,7 +6773,7 @@
                 </a:solidFill>
                 <a:latin typeface="Arial"/>
               </a:rPr>
-              <a:t>Feels like: a person tapping you, not a machine signalling.</a:t>
+              <a:t>Feels like: nothing. That is the point. The surface stays plain.</a:t>
             </a:r>
           </a:p>
           <a:p>
@@ -7363,7 +6813,7 @@
                 </a:solidFill>
                 <a:latin typeface="Arial"/>
               </a:rPr>
-              <a:t>Navigation cues on the body, braille cells, alerts in noise.</a:t>
+              <a:t>Invisible controls in wood or fabric, waterproof panels.</a:t>
             </a:r>
           </a:p>
           <a:p>
@@ -7383,248 +6833,7 @@
                 </a:solidFill>
                 <a:latin typeface="Consolas"/>
               </a:rPr>
-              <a:t>3E  |  24  |  5V, 1.1 A, 4.5 ohm  |  3mm throw, 80g</a:t>
-            </a:r>
-          </a:p>
-        </p:txBody>
-      </p:sp>
-      <p:pic>
-        <p:nvPicPr>
-          <p:cNvPr id="4" name="Picture 3" descr="solenoid.jpg"/>
-          <p:cNvPicPr>
-            <a:picLocks noChangeAspect="1"/>
-          </p:cNvPicPr>
-          <p:nvPr/>
-        </p:nvPicPr>
-        <p:blipFill>
-          <a:blip r:embed="rId2"/>
-          <a:stretch>
-            <a:fillRect/>
-          </a:stretch>
-        </p:blipFill>
-        <p:spPr>
-          <a:xfrm>
-            <a:off x="914400" y="1905000"/>
-            <a:ext cx="4191000" cy="3145410"/>
-          </a:xfrm>
-          <a:prstGeom prst="rect">
-            <a:avLst/>
-          </a:prstGeom>
-        </p:spPr>
-      </p:pic>
-      <p:pic>
-        <p:nvPicPr>
-          <p:cNvPr id="5" name="Picture 4" descr="wordmark_dark.png"/>
-          <p:cNvPicPr>
-            <a:picLocks noChangeAspect="1"/>
-          </p:cNvPicPr>
-          <p:nvPr/>
-        </p:nvPicPr>
-        <p:blipFill>
-          <a:blip r:embed="rId3"/>
-          <a:stretch>
-            <a:fillRect/>
-          </a:stretch>
-        </p:blipFill>
-        <p:spPr>
-          <a:xfrm>
-            <a:off x="342900" y="6184900"/>
-            <a:ext cx="2070100" cy="529560"/>
-          </a:xfrm>
-          <a:prstGeom prst="rect">
-            <a:avLst/>
-          </a:prstGeom>
-        </p:spPr>
-      </p:pic>
-      <p:pic>
-        <p:nvPicPr>
-          <p:cNvPr id="6" name="Picture 5" descr="seal_dark.png"/>
-          <p:cNvPicPr>
-            <a:picLocks noChangeAspect="1"/>
-          </p:cNvPicPr>
-          <p:nvPr/>
-        </p:nvPicPr>
-        <p:blipFill>
-          <a:blip r:embed="rId4"/>
-          <a:stretch>
-            <a:fillRect/>
-          </a:stretch>
-        </p:blipFill>
-        <p:spPr>
-          <a:xfrm>
-            <a:off x="11226800" y="5969000"/>
-            <a:ext cx="713915" cy="711200"/>
-          </a:xfrm>
-          <a:prstGeom prst="rect">
-            <a:avLst/>
-          </a:prstGeom>
-        </p:spPr>
-      </p:pic>
-    </p:spTree>
-  </p:cSld>
-  <p:clrMapOvr>
-    <a:masterClrMapping/>
-  </p:clrMapOvr>
-</p:sld>
-</file>
-
-<file path=ppt/slides/slide13.xml><?xml version="1.0" encoding="utf-8"?>
-<p:sld xmlns:a="http://schemas.openxmlformats.org/drawingml/2006/main" xmlns:p="http://schemas.openxmlformats.org/presentationml/2006/main" xmlns:r="http://schemas.openxmlformats.org/officeDocument/2006/relationships">
-  <p:cSld>
-    <p:spTree>
-      <p:nvGrpSpPr>
-        <p:cNvPr id="1" name=""/>
-        <p:cNvGrpSpPr/>
-        <p:nvPr/>
-      </p:nvGrpSpPr>
-      <p:grpSpPr/>
-      <p:sp>
-        <p:nvSpPr>
-          <p:cNvPr id="2" name="Title 1"/>
-          <p:cNvSpPr>
-            <a:spLocks noGrp="1"/>
-          </p:cNvSpPr>
-          <p:nvPr>
-            <p:ph type="title"/>
-          </p:nvPr>
-        </p:nvSpPr>
-        <p:spPr/>
-        <p:txBody>
-          <a:bodyPr/>
-          <a:lstStyle/>
-          <a:p>
-            <a:pPr marL="0" indent="0" algn="l">
-              <a:buNone/>
-            </a:pPr>
-            <a:r>
-              <a:rPr sz="3200" b="1">
-                <a:solidFill>
-                  <a:srgbClr val="000000"/>
-                </a:solidFill>
-                <a:latin typeface="Arial"/>
-              </a:rPr>
-              <a:t>CAPACITIVE PAD</a:t>
-            </a:r>
-          </a:p>
-        </p:txBody>
-      </p:sp>
-      <p:sp>
-        <p:nvSpPr>
-          <p:cNvPr id="3" name="Text Placeholder 2"/>
-          <p:cNvSpPr>
-            <a:spLocks noGrp="1"/>
-          </p:cNvSpPr>
-          <p:nvPr>
-            <p:ph type="body" idx="1"/>
-          </p:nvPr>
-        </p:nvSpPr>
-        <p:spPr>
-          <a:xfrm>
-            <a:off x="5461000" y="1905000"/>
-            <a:ext cx="5486400" cy="3302000"/>
-          </a:xfrm>
-        </p:spPr>
-        <p:txBody>
-          <a:bodyPr/>
-          <a:lstStyle/>
-          <a:p>
-            <a:pPr marL="0" indent="0" algn="l">
-              <a:lnSpc>
-                <a:spcPct val="130000"/>
-              </a:lnSpc>
-              <a:spcAft>
-                <a:spcPts val="1200"/>
-              </a:spcAft>
-              <a:buNone/>
-            </a:pPr>
-            <a:r>
-              <a:rPr sz="1600" b="0">
-                <a:solidFill>
-                  <a:srgbClr val="000000"/>
-                </a:solidFill>
-                <a:latin typeface="Arial"/>
-              </a:rPr>
-              <a:t>A wire taped behind foil, card or fabric. No sensor and no breakout board, which is why the box on the left is empty.</a:t>
-            </a:r>
-          </a:p>
-          <a:p>
-            <a:pPr marL="0" indent="0" algn="l">
-              <a:lnSpc>
-                <a:spcPct val="130000"/>
-              </a:lnSpc>
-              <a:spcAft>
-                <a:spcPts val="1400"/>
-              </a:spcAft>
-              <a:buNone/>
-            </a:pPr>
-            <a:r>
-              <a:rPr sz="1600" b="1">
-                <a:solidFill>
-                  <a:srgbClr val="002546"/>
-                </a:solidFill>
-                <a:latin typeface="Arial"/>
-              </a:rPr>
-              <a:t>Feels like: nothing. That is the point. The surface stays plain.</a:t>
-            </a:r>
-          </a:p>
-          <a:p>
-            <a:pPr marL="0" indent="0" algn="l">
-              <a:lnSpc>
-                <a:spcPct val="130000"/>
-              </a:lnSpc>
-              <a:spcAft>
-                <a:spcPts val="400"/>
-              </a:spcAft>
-              <a:buNone/>
-            </a:pPr>
-            <a:r>
-              <a:rPr sz="900" b="1">
-                <a:solidFill>
-                  <a:srgbClr val="595959"/>
-                </a:solidFill>
-                <a:latin typeface="Arial"/>
-              </a:rPr>
-              <a:t>USED FOR</a:t>
-            </a:r>
-          </a:p>
-          <a:p>
-            <a:pPr marL="0" indent="0" algn="l">
-              <a:lnSpc>
-                <a:spcPct val="130000"/>
-              </a:lnSpc>
-              <a:spcAft>
-                <a:spcPts val="1400"/>
-              </a:spcAft>
-              <a:buNone/>
-            </a:pPr>
-            <a:r>
-              <a:rPr sz="1400" b="0">
-                <a:solidFill>
-                  <a:srgbClr val="000000"/>
-                </a:solidFill>
-                <a:latin typeface="Arial"/>
-              </a:rPr>
-              <a:t>Invisible controls in wood or fabric, waterproof panels.</a:t>
-            </a:r>
-          </a:p>
-          <a:p>
-            <a:pPr marL="0" indent="0" algn="l">
-              <a:lnSpc>
-                <a:spcPct val="130000"/>
-              </a:lnSpc>
-              <a:spcAft>
-                <a:spcPts val="0"/>
-              </a:spcAft>
-              <a:buNone/>
-            </a:pPr>
-            <a:r>
-              <a:rPr sz="1200" b="0">
-                <a:solidFill>
-                  <a:srgbClr val="595959"/>
-                </a:solidFill>
-                <a:latin typeface="Consolas"/>
-              </a:rPr>
-              <a:t>No drawer, no part number, no cost. Any analogue pin</a:t>
+              <a:t>No drawer, no part number, no cost  |  one wire  |  keep it on USB</a:t>
             </a:r>
           </a:p>
         </p:txBody>
@@ -7755,7 +6964,7 @@
 </p:sld>
 </file>
 
-<file path=ppt/slides/slide14.xml><?xml version="1.0" encoding="utf-8"?>
+<file path=ppt/slides/slide12.xml><?xml version="1.0" encoding="utf-8"?>
 <p:sld xmlns:a="http://schemas.openxmlformats.org/drawingml/2006/main" xmlns:p="http://schemas.openxmlformats.org/presentationml/2006/main" xmlns:r="http://schemas.openxmlformats.org/officeDocument/2006/relationships">
   <p:cSld>
     <p:spTree>
@@ -7790,7 +6999,7 @@
                 </a:solidFill>
                 <a:latin typeface="Arial"/>
               </a:rPr>
-              <a:t>PELTIER TILE</a:t>
+              <a:t>STEPPER MOTOR</a:t>
             </a:r>
           </a:p>
         </p:txBody>
@@ -7831,7 +7040,7 @@
                 </a:solidFill>
                 <a:latin typeface="Arial"/>
               </a:rPr>
-              <a:t>Heats one face and cools the other. Flip the current and it reverses.</a:t>
+              <a:t>Moves in fixed steps rather than continuously, so you always know where it is without a sensor.</a:t>
             </a:r>
           </a:p>
           <a:p>
@@ -7851,7 +7060,7 @@
                 </a:solidFill>
                 <a:latin typeface="Arial"/>
               </a:rPr>
-              <a:t>Feels like: slow. Several seconds before you are sure which way.</a:t>
+              <a:t>Feels like: precise, and audibly clicky.</a:t>
             </a:r>
           </a:p>
           <a:p>
@@ -7891,7 +7100,7 @@
                 </a:solidFill>
                 <a:latin typeface="Arial"/>
               </a:rPr>
-              <a:t>Slow ambient state. Never an alert.</a:t>
+              <a:t>Slow accurate motion. Dials, sliders, anything positioned.</a:t>
             </a:r>
           </a:p>
           <a:p>
@@ -7911,730 +7120,7 @@
                 </a:solidFill>
                 <a:latin typeface="Consolas"/>
               </a:rPr>
-              <a:t>Drawer 4C  |  25 small, 35 big  |  needs an H bridge</a:t>
-            </a:r>
-          </a:p>
-        </p:txBody>
-      </p:sp>
-      <p:pic>
-        <p:nvPicPr>
-          <p:cNvPr id="4" name="Picture 3" descr="peltier.jpg"/>
-          <p:cNvPicPr>
-            <a:picLocks noChangeAspect="1"/>
-          </p:cNvPicPr>
-          <p:nvPr/>
-        </p:nvPicPr>
-        <p:blipFill>
-          <a:blip r:embed="rId2"/>
-          <a:stretch>
-            <a:fillRect/>
-          </a:stretch>
-        </p:blipFill>
-        <p:spPr>
-          <a:xfrm>
-            <a:off x="914400" y="1905000"/>
-            <a:ext cx="4191000" cy="3143250"/>
-          </a:xfrm>
-          <a:prstGeom prst="rect">
-            <a:avLst/>
-          </a:prstGeom>
-        </p:spPr>
-      </p:pic>
-      <p:pic>
-        <p:nvPicPr>
-          <p:cNvPr id="5" name="Picture 4" descr="wordmark_dark.png"/>
-          <p:cNvPicPr>
-            <a:picLocks noChangeAspect="1"/>
-          </p:cNvPicPr>
-          <p:nvPr/>
-        </p:nvPicPr>
-        <p:blipFill>
-          <a:blip r:embed="rId3"/>
-          <a:stretch>
-            <a:fillRect/>
-          </a:stretch>
-        </p:blipFill>
-        <p:spPr>
-          <a:xfrm>
-            <a:off x="342900" y="6184900"/>
-            <a:ext cx="2070100" cy="529560"/>
-          </a:xfrm>
-          <a:prstGeom prst="rect">
-            <a:avLst/>
-          </a:prstGeom>
-        </p:spPr>
-      </p:pic>
-      <p:pic>
-        <p:nvPicPr>
-          <p:cNvPr id="6" name="Picture 5" descr="seal_dark.png"/>
-          <p:cNvPicPr>
-            <a:picLocks noChangeAspect="1"/>
-          </p:cNvPicPr>
-          <p:nvPr/>
-        </p:nvPicPr>
-        <p:blipFill>
-          <a:blip r:embed="rId4"/>
-          <a:stretch>
-            <a:fillRect/>
-          </a:stretch>
-        </p:blipFill>
-        <p:spPr>
-          <a:xfrm>
-            <a:off x="11226800" y="5969000"/>
-            <a:ext cx="713915" cy="711200"/>
-          </a:xfrm>
-          <a:prstGeom prst="rect">
-            <a:avLst/>
-          </a:prstGeom>
-        </p:spPr>
-      </p:pic>
-    </p:spTree>
-  </p:cSld>
-  <p:clrMapOvr>
-    <a:masterClrMapping/>
-  </p:clrMapOvr>
-</p:sld>
-</file>
-
-<file path=ppt/slides/slide15.xml><?xml version="1.0" encoding="utf-8"?>
-<p:sld xmlns:a="http://schemas.openxmlformats.org/drawingml/2006/main" xmlns:p="http://schemas.openxmlformats.org/presentationml/2006/main" xmlns:r="http://schemas.openxmlformats.org/officeDocument/2006/relationships">
-  <p:cSld>
-    <p:spTree>
-      <p:nvGrpSpPr>
-        <p:cNvPr id="1" name=""/>
-        <p:cNvGrpSpPr/>
-        <p:nvPr/>
-      </p:nvGrpSpPr>
-      <p:grpSpPr/>
-      <p:sp>
-        <p:nvSpPr>
-          <p:cNvPr id="2" name="Title 1"/>
-          <p:cNvSpPr>
-            <a:spLocks noGrp="1"/>
-          </p:cNvSpPr>
-          <p:nvPr>
-            <p:ph type="title"/>
-          </p:nvPr>
-        </p:nvSpPr>
-        <p:spPr/>
-        <p:txBody>
-          <a:bodyPr/>
-          <a:lstStyle/>
-          <a:p>
-            <a:pPr marL="0" indent="0" algn="l">
-              <a:buNone/>
-            </a:pPr>
-            <a:r>
-              <a:rPr sz="3200" b="1">
-                <a:solidFill>
-                  <a:srgbClr val="000000"/>
-                </a:solidFill>
-                <a:latin typeface="Arial"/>
-              </a:rPr>
-              <a:t>SURFACE TRANSDUCER</a:t>
-            </a:r>
-          </a:p>
-        </p:txBody>
-      </p:sp>
-      <p:sp>
-        <p:nvSpPr>
-          <p:cNvPr id="3" name="Text Placeholder 2"/>
-          <p:cNvSpPr>
-            <a:spLocks noGrp="1"/>
-          </p:cNvSpPr>
-          <p:nvPr>
-            <p:ph type="body" idx="1"/>
-          </p:nvPr>
-        </p:nvSpPr>
-        <p:spPr>
-          <a:xfrm>
-            <a:off x="5461000" y="1905000"/>
-            <a:ext cx="5486400" cy="3302000"/>
-          </a:xfrm>
-        </p:spPr>
-        <p:txBody>
-          <a:bodyPr/>
-          <a:lstStyle/>
-          <a:p>
-            <a:pPr marL="0" indent="0" algn="l">
-              <a:lnSpc>
-                <a:spcPct val="130000"/>
-              </a:lnSpc>
-              <a:spcAft>
-                <a:spcPts val="1200"/>
-              </a:spcAft>
-              <a:buNone/>
-            </a:pPr>
-            <a:r>
-              <a:rPr sz="1600" b="0">
-                <a:solidFill>
-                  <a:srgbClr val="000000"/>
-                </a:solidFill>
-                <a:latin typeface="Arial"/>
-              </a:rPr>
-              <a:t>Turns any surface into a speaker. Drive it so one frequency is felt and another is heard, from the same part.</a:t>
-            </a:r>
-          </a:p>
-          <a:p>
-            <a:pPr marL="0" indent="0" algn="l">
-              <a:lnSpc>
-                <a:spcPct val="130000"/>
-              </a:lnSpc>
-              <a:spcAft>
-                <a:spcPts val="1400"/>
-              </a:spcAft>
-              <a:buNone/>
-            </a:pPr>
-            <a:r>
-              <a:rPr sz="1600" b="1">
-                <a:solidFill>
-                  <a:srgbClr val="002546"/>
-                </a:solidFill>
-                <a:latin typeface="Arial"/>
-              </a:rPr>
-              <a:t>Feels like: more certain, rather than louder.</a:t>
-            </a:r>
-          </a:p>
-          <a:p>
-            <a:pPr marL="0" indent="0" algn="l">
-              <a:lnSpc>
-                <a:spcPct val="130000"/>
-              </a:lnSpc>
-              <a:spcAft>
-                <a:spcPts val="400"/>
-              </a:spcAft>
-              <a:buNone/>
-            </a:pPr>
-            <a:r>
-              <a:rPr sz="900" b="1">
-                <a:solidFill>
-                  <a:srgbClr val="595959"/>
-                </a:solidFill>
-                <a:latin typeface="Arial"/>
-              </a:rPr>
-              <a:t>USED FOR</a:t>
-            </a:r>
-          </a:p>
-          <a:p>
-            <a:pPr marL="0" indent="0" algn="l">
-              <a:lnSpc>
-                <a:spcPct val="130000"/>
-              </a:lnSpc>
-              <a:spcAft>
-                <a:spcPts val="1400"/>
-              </a:spcAft>
-              <a:buNone/>
-            </a:pPr>
-            <a:r>
-              <a:rPr sz="1400" b="0">
-                <a:solidFill>
-                  <a:srgbClr val="000000"/>
-                </a:solidFill>
-                <a:latin typeface="Arial"/>
-              </a:rPr>
-              <a:t>Noisy or bright environments, and accessibility.</a:t>
-            </a:r>
-          </a:p>
-          <a:p>
-            <a:pPr marL="0" indent="0" algn="l">
-              <a:lnSpc>
-                <a:spcPct val="130000"/>
-              </a:lnSpc>
-              <a:spcAft>
-                <a:spcPts val="0"/>
-              </a:spcAft>
-              <a:buNone/>
-            </a:pPr>
-            <a:r>
-              <a:rPr sz="1200" b="0">
-                <a:solidFill>
-                  <a:srgbClr val="595959"/>
-                </a:solidFill>
-                <a:latin typeface="Consolas"/>
-              </a:rPr>
-              <a:t>Drawer 7F  |  12 large, 13 medium, 23 bone  |  needs an amp</a:t>
-            </a:r>
-          </a:p>
-        </p:txBody>
-      </p:sp>
-      <p:pic>
-        <p:nvPicPr>
-          <p:cNvPr id="4" name="Picture 3" descr="transducer.jpg"/>
-          <p:cNvPicPr>
-            <a:picLocks noChangeAspect="1"/>
-          </p:cNvPicPr>
-          <p:nvPr/>
-        </p:nvPicPr>
-        <p:blipFill>
-          <a:blip r:embed="rId2"/>
-          <a:stretch>
-            <a:fillRect/>
-          </a:stretch>
-        </p:blipFill>
-        <p:spPr>
-          <a:xfrm>
-            <a:off x="914400" y="1905000"/>
-            <a:ext cx="3175000" cy="3175000"/>
-          </a:xfrm>
-          <a:prstGeom prst="rect">
-            <a:avLst/>
-          </a:prstGeom>
-        </p:spPr>
-      </p:pic>
-      <p:pic>
-        <p:nvPicPr>
-          <p:cNvPr id="5" name="Picture 4" descr="wordmark_dark.png"/>
-          <p:cNvPicPr>
-            <a:picLocks noChangeAspect="1"/>
-          </p:cNvPicPr>
-          <p:nvPr/>
-        </p:nvPicPr>
-        <p:blipFill>
-          <a:blip r:embed="rId3"/>
-          <a:stretch>
-            <a:fillRect/>
-          </a:stretch>
-        </p:blipFill>
-        <p:spPr>
-          <a:xfrm>
-            <a:off x="342900" y="6184900"/>
-            <a:ext cx="2070100" cy="529560"/>
-          </a:xfrm>
-          <a:prstGeom prst="rect">
-            <a:avLst/>
-          </a:prstGeom>
-        </p:spPr>
-      </p:pic>
-      <p:pic>
-        <p:nvPicPr>
-          <p:cNvPr id="6" name="Picture 5" descr="seal_dark.png"/>
-          <p:cNvPicPr>
-            <a:picLocks noChangeAspect="1"/>
-          </p:cNvPicPr>
-          <p:nvPr/>
-        </p:nvPicPr>
-        <p:blipFill>
-          <a:blip r:embed="rId4"/>
-          <a:stretch>
-            <a:fillRect/>
-          </a:stretch>
-        </p:blipFill>
-        <p:spPr>
-          <a:xfrm>
-            <a:off x="11226800" y="5969000"/>
-            <a:ext cx="713915" cy="711200"/>
-          </a:xfrm>
-          <a:prstGeom prst="rect">
-            <a:avLst/>
-          </a:prstGeom>
-        </p:spPr>
-      </p:pic>
-    </p:spTree>
-  </p:cSld>
-  <p:clrMapOvr>
-    <a:masterClrMapping/>
-  </p:clrMapOvr>
-</p:sld>
-</file>
-
-<file path=ppt/slides/slide16.xml><?xml version="1.0" encoding="utf-8"?>
-<p:sld xmlns:a="http://schemas.openxmlformats.org/drawingml/2006/main" xmlns:p="http://schemas.openxmlformats.org/presentationml/2006/main" xmlns:r="http://schemas.openxmlformats.org/officeDocument/2006/relationships">
-  <p:cSld>
-    <p:spTree>
-      <p:nvGrpSpPr>
-        <p:cNvPr id="1" name=""/>
-        <p:cNvGrpSpPr/>
-        <p:nvPr/>
-      </p:nvGrpSpPr>
-      <p:grpSpPr/>
-      <p:sp>
-        <p:nvSpPr>
-          <p:cNvPr id="2" name="Title 1"/>
-          <p:cNvSpPr>
-            <a:spLocks noGrp="1"/>
-          </p:cNvSpPr>
-          <p:nvPr>
-            <p:ph type="title"/>
-          </p:nvPr>
-        </p:nvSpPr>
-        <p:spPr/>
-        <p:txBody>
-          <a:bodyPr/>
-          <a:lstStyle/>
-          <a:p>
-            <a:pPr marL="0" indent="0" algn="l">
-              <a:buNone/>
-            </a:pPr>
-            <a:r>
-              <a:rPr sz="3200" b="1">
-                <a:solidFill>
-                  <a:srgbClr val="000000"/>
-                </a:solidFill>
-                <a:latin typeface="Arial"/>
-              </a:rPr>
-              <a:t>SERVO</a:t>
-            </a:r>
-          </a:p>
-        </p:txBody>
-      </p:sp>
-      <p:sp>
-        <p:nvSpPr>
-          <p:cNvPr id="3" name="Text Placeholder 2"/>
-          <p:cNvSpPr>
-            <a:spLocks noGrp="1"/>
-          </p:cNvSpPr>
-          <p:nvPr>
-            <p:ph type="body" idx="1"/>
-          </p:nvPr>
-        </p:nvSpPr>
-        <p:spPr>
-          <a:xfrm>
-            <a:off x="5461000" y="1905000"/>
-            <a:ext cx="5486400" cy="3302000"/>
-          </a:xfrm>
-        </p:spPr>
-        <p:txBody>
-          <a:bodyPr/>
-          <a:lstStyle/>
-          <a:p>
-            <a:pPr marL="0" indent="0" algn="l">
-              <a:lnSpc>
-                <a:spcPct val="130000"/>
-              </a:lnSpc>
-              <a:spcAft>
-                <a:spcPts val="1200"/>
-              </a:spcAft>
-              <a:buNone/>
-            </a:pPr>
-            <a:r>
-              <a:rPr sz="1600" b="0">
-                <a:solidFill>
-                  <a:srgbClr val="000000"/>
-                </a:solidFill>
-                <a:latin typeface="Arial"/>
-              </a:rPr>
-              <a:t>A motor that holds a position instead of spinning freely. Tell it an angle and it goes there.</a:t>
-            </a:r>
-          </a:p>
-          <a:p>
-            <a:pPr marL="0" indent="0" algn="l">
-              <a:lnSpc>
-                <a:spcPct val="130000"/>
-              </a:lnSpc>
-              <a:spcAft>
-                <a:spcPts val="1400"/>
-              </a:spcAft>
-              <a:buNone/>
-            </a:pPr>
-            <a:r>
-              <a:rPr sz="1600" b="1">
-                <a:solidFill>
-                  <a:srgbClr val="002546"/>
-                </a:solidFill>
-                <a:latin typeface="Arial"/>
-              </a:rPr>
-              <a:t>Feels like: something deliberate moving, with force behind it.</a:t>
-            </a:r>
-          </a:p>
-          <a:p>
-            <a:pPr marL="0" indent="0" algn="l">
-              <a:lnSpc>
-                <a:spcPct val="130000"/>
-              </a:lnSpc>
-              <a:spcAft>
-                <a:spcPts val="400"/>
-              </a:spcAft>
-              <a:buNone/>
-            </a:pPr>
-            <a:r>
-              <a:rPr sz="900" b="1">
-                <a:solidFill>
-                  <a:srgbClr val="595959"/>
-                </a:solidFill>
-                <a:latin typeface="Arial"/>
-              </a:rPr>
-              <a:t>USED FOR</a:t>
-            </a:r>
-          </a:p>
-          <a:p>
-            <a:pPr marL="0" indent="0" algn="l">
-              <a:lnSpc>
-                <a:spcPct val="130000"/>
-              </a:lnSpc>
-              <a:spcAft>
-                <a:spcPts val="1400"/>
-              </a:spcAft>
-              <a:buNone/>
-            </a:pPr>
-            <a:r>
-              <a:rPr sz="1400" b="0">
-                <a:solidFill>
-                  <a:srgbClr val="000000"/>
-                </a:solidFill>
-                <a:latin typeface="Arial"/>
-              </a:rPr>
-              <a:t>Anything that points, pushes, opens or resists a hand.</a:t>
-            </a:r>
-          </a:p>
-          <a:p>
-            <a:pPr marL="0" indent="0" algn="l">
-              <a:lnSpc>
-                <a:spcPct val="130000"/>
-              </a:lnSpc>
-              <a:spcAft>
-                <a:spcPts val="0"/>
-              </a:spcAft>
-              <a:buNone/>
-            </a:pPr>
-            <a:r>
-              <a:rPr sz="1200" b="0">
-                <a:solidFill>
-                  <a:srgbClr val="595959"/>
-                </a:solidFill>
-                <a:latin typeface="Consolas"/>
-              </a:rPr>
-              <a:t>Drawer 2F  |  80 in stock  |  Servo.h  |  needs its own 5V</a:t>
-            </a:r>
-          </a:p>
-        </p:txBody>
-      </p:sp>
-      <p:pic>
-        <p:nvPicPr>
-          <p:cNvPr id="4" name="Picture 3" descr="servo.jpg"/>
-          <p:cNvPicPr>
-            <a:picLocks noChangeAspect="1"/>
-          </p:cNvPicPr>
-          <p:nvPr/>
-        </p:nvPicPr>
-        <p:blipFill>
-          <a:blip r:embed="rId2"/>
-          <a:stretch>
-            <a:fillRect/>
-          </a:stretch>
-        </p:blipFill>
-        <p:spPr>
-          <a:xfrm>
-            <a:off x="914400" y="1905000"/>
-            <a:ext cx="4191000" cy="3145410"/>
-          </a:xfrm>
-          <a:prstGeom prst="rect">
-            <a:avLst/>
-          </a:prstGeom>
-        </p:spPr>
-      </p:pic>
-      <p:pic>
-        <p:nvPicPr>
-          <p:cNvPr id="5" name="Picture 4" descr="wordmark_dark.png"/>
-          <p:cNvPicPr>
-            <a:picLocks noChangeAspect="1"/>
-          </p:cNvPicPr>
-          <p:nvPr/>
-        </p:nvPicPr>
-        <p:blipFill>
-          <a:blip r:embed="rId3"/>
-          <a:stretch>
-            <a:fillRect/>
-          </a:stretch>
-        </p:blipFill>
-        <p:spPr>
-          <a:xfrm>
-            <a:off x="342900" y="6184900"/>
-            <a:ext cx="2070100" cy="529560"/>
-          </a:xfrm>
-          <a:prstGeom prst="rect">
-            <a:avLst/>
-          </a:prstGeom>
-        </p:spPr>
-      </p:pic>
-      <p:pic>
-        <p:nvPicPr>
-          <p:cNvPr id="6" name="Picture 5" descr="seal_dark.png"/>
-          <p:cNvPicPr>
-            <a:picLocks noChangeAspect="1"/>
-          </p:cNvPicPr>
-          <p:nvPr/>
-        </p:nvPicPr>
-        <p:blipFill>
-          <a:blip r:embed="rId4"/>
-          <a:stretch>
-            <a:fillRect/>
-          </a:stretch>
-        </p:blipFill>
-        <p:spPr>
-          <a:xfrm>
-            <a:off x="11226800" y="5969000"/>
-            <a:ext cx="713915" cy="711200"/>
-          </a:xfrm>
-          <a:prstGeom prst="rect">
-            <a:avLst/>
-          </a:prstGeom>
-        </p:spPr>
-      </p:pic>
-    </p:spTree>
-  </p:cSld>
-  <p:clrMapOvr>
-    <a:masterClrMapping/>
-  </p:clrMapOvr>
-</p:sld>
-</file>
-
-<file path=ppt/slides/slide17.xml><?xml version="1.0" encoding="utf-8"?>
-<p:sld xmlns:a="http://schemas.openxmlformats.org/drawingml/2006/main" xmlns:p="http://schemas.openxmlformats.org/presentationml/2006/main" xmlns:r="http://schemas.openxmlformats.org/officeDocument/2006/relationships">
-  <p:cSld>
-    <p:spTree>
-      <p:nvGrpSpPr>
-        <p:cNvPr id="1" name=""/>
-        <p:cNvGrpSpPr/>
-        <p:nvPr/>
-      </p:nvGrpSpPr>
-      <p:grpSpPr/>
-      <p:sp>
-        <p:nvSpPr>
-          <p:cNvPr id="2" name="Title 1"/>
-          <p:cNvSpPr>
-            <a:spLocks noGrp="1"/>
-          </p:cNvSpPr>
-          <p:nvPr>
-            <p:ph type="title"/>
-          </p:nvPr>
-        </p:nvSpPr>
-        <p:spPr/>
-        <p:txBody>
-          <a:bodyPr/>
-          <a:lstStyle/>
-          <a:p>
-            <a:pPr marL="0" indent="0" algn="l">
-              <a:buNone/>
-            </a:pPr>
-            <a:r>
-              <a:rPr sz="3200" b="1">
-                <a:solidFill>
-                  <a:srgbClr val="000000"/>
-                </a:solidFill>
-                <a:latin typeface="Arial"/>
-              </a:rPr>
-              <a:t>STEPPER MOTOR</a:t>
-            </a:r>
-          </a:p>
-        </p:txBody>
-      </p:sp>
-      <p:sp>
-        <p:nvSpPr>
-          <p:cNvPr id="3" name="Text Placeholder 2"/>
-          <p:cNvSpPr>
-            <a:spLocks noGrp="1"/>
-          </p:cNvSpPr>
-          <p:nvPr>
-            <p:ph type="body" idx="1"/>
-          </p:nvPr>
-        </p:nvSpPr>
-        <p:spPr>
-          <a:xfrm>
-            <a:off x="5461000" y="1905000"/>
-            <a:ext cx="5486400" cy="3302000"/>
-          </a:xfrm>
-        </p:spPr>
-        <p:txBody>
-          <a:bodyPr/>
-          <a:lstStyle/>
-          <a:p>
-            <a:pPr marL="0" indent="0" algn="l">
-              <a:lnSpc>
-                <a:spcPct val="130000"/>
-              </a:lnSpc>
-              <a:spcAft>
-                <a:spcPts val="1200"/>
-              </a:spcAft>
-              <a:buNone/>
-            </a:pPr>
-            <a:r>
-              <a:rPr sz="1600" b="0">
-                <a:solidFill>
-                  <a:srgbClr val="000000"/>
-                </a:solidFill>
-                <a:latin typeface="Arial"/>
-              </a:rPr>
-              <a:t>Moves in fixed steps rather than continuously, so you always know where it is without a sensor.</a:t>
-            </a:r>
-          </a:p>
-          <a:p>
-            <a:pPr marL="0" indent="0" algn="l">
-              <a:lnSpc>
-                <a:spcPct val="130000"/>
-              </a:lnSpc>
-              <a:spcAft>
-                <a:spcPts val="1400"/>
-              </a:spcAft>
-              <a:buNone/>
-            </a:pPr>
-            <a:r>
-              <a:rPr sz="1600" b="1">
-                <a:solidFill>
-                  <a:srgbClr val="002546"/>
-                </a:solidFill>
-                <a:latin typeface="Arial"/>
-              </a:rPr>
-              <a:t>Feels like: precise, and audibly clicky.</a:t>
-            </a:r>
-          </a:p>
-          <a:p>
-            <a:pPr marL="0" indent="0" algn="l">
-              <a:lnSpc>
-                <a:spcPct val="130000"/>
-              </a:lnSpc>
-              <a:spcAft>
-                <a:spcPts val="400"/>
-              </a:spcAft>
-              <a:buNone/>
-            </a:pPr>
-            <a:r>
-              <a:rPr sz="900" b="1">
-                <a:solidFill>
-                  <a:srgbClr val="595959"/>
-                </a:solidFill>
-                <a:latin typeface="Arial"/>
-              </a:rPr>
-              <a:t>USED FOR</a:t>
-            </a:r>
-          </a:p>
-          <a:p>
-            <a:pPr marL="0" indent="0" algn="l">
-              <a:lnSpc>
-                <a:spcPct val="130000"/>
-              </a:lnSpc>
-              <a:spcAft>
-                <a:spcPts val="1400"/>
-              </a:spcAft>
-              <a:buNone/>
-            </a:pPr>
-            <a:r>
-              <a:rPr sz="1400" b="0">
-                <a:solidFill>
-                  <a:srgbClr val="000000"/>
-                </a:solidFill>
-                <a:latin typeface="Arial"/>
-              </a:rPr>
-              <a:t>Slow accurate motion. Dials, sliders, anything positioned.</a:t>
-            </a:r>
-          </a:p>
-          <a:p>
-            <a:pPr marL="0" indent="0" algn="l">
-              <a:lnSpc>
-                <a:spcPct val="130000"/>
-              </a:lnSpc>
-              <a:spcAft>
-                <a:spcPts val="0"/>
-              </a:spcAft>
-              <a:buNone/>
-            </a:pPr>
-            <a:r>
-              <a:rPr sz="1200" b="0">
-                <a:solidFill>
-                  <a:srgbClr val="595959"/>
-                </a:solidFill>
-                <a:latin typeface="Consolas"/>
-              </a:rPr>
-              <a:t>2A  |  44  |  ULN2003 driver  |  2048 steps/rev</a:t>
+              <a:t>2A  |  44  |  ULN2003  |  2048 steps/rev  |  own 5V supply</a:t>
             </a:r>
           </a:p>
         </p:txBody>
@@ -8719,7 +7205,7 @@
 </p:sld>
 </file>
 
-<file path=ppt/slides/slide18.xml><?xml version="1.0" encoding="utf-8"?>
+<file path=ppt/slides/slide13.xml><?xml version="1.0" encoding="utf-8"?>
 <p:sld xmlns:a="http://schemas.openxmlformats.org/drawingml/2006/main" xmlns:p="http://schemas.openxmlformats.org/presentationml/2006/main" xmlns:r="http://schemas.openxmlformats.org/officeDocument/2006/relationships">
   <p:cSld>
     <p:spTree>
@@ -8754,7 +7240,7 @@
                 </a:solidFill>
                 <a:latin typeface="Arial"/>
               </a:rPr>
-              <a:t>ELECTROMAGNET</a:t>
+              <a:t>WHAT ELSE THE LAB HAS</a:t>
             </a:r>
           </a:p>
         </p:txBody>
@@ -8769,19 +7255,14 @@
             <p:ph type="body" idx="1"/>
           </p:nvPr>
         </p:nvSpPr>
-        <p:spPr>
-          <a:xfrm>
-            <a:off x="5461000" y="1905000"/>
-            <a:ext cx="5486400" cy="3302000"/>
-          </a:xfrm>
-        </p:spPr>
+        <p:spPr/>
         <p:txBody>
           <a:bodyPr/>
           <a:lstStyle/>
           <a:p>
             <a:pPr marL="0" indent="0" algn="l">
               <a:lnSpc>
-                <a:spcPct val="130000"/>
+                <a:spcPct val="128000"/>
               </a:lnSpc>
               <a:spcAft>
                 <a:spcPts val="1200"/>
@@ -8789,39 +7270,19 @@
               <a:buNone/>
             </a:pPr>
             <a:r>
-              <a:rPr sz="1600" b="0">
-                <a:solidFill>
-                  <a:srgbClr val="000000"/>
-                </a:solidFill>
-                <a:latin typeface="Arial"/>
-              </a:rPr>
-              <a:t>Grabs and releases ferrous metal on command. No moving parts of its own.</a:t>
-            </a:r>
-          </a:p>
-          <a:p>
-            <a:pPr marL="0" indent="0" algn="l">
-              <a:lnSpc>
-                <a:spcPct val="130000"/>
-              </a:lnSpc>
-              <a:spcAft>
-                <a:spcPts val="1400"/>
-              </a:spcAft>
-              <a:buNone/>
-            </a:pPr>
-            <a:r>
-              <a:rPr sz="1600" b="1">
-                <a:solidFill>
-                  <a:srgbClr val="002546"/>
-                </a:solidFill>
-                <a:latin typeface="Arial"/>
-              </a:rPr>
-              <a:t>Feels like: a grip that appears and vanishes.</a:t>
-            </a:r>
-          </a:p>
-          <a:p>
-            <a:pPr marL="0" indent="0" algn="l">
-              <a:lnSpc>
-                <a:spcPct val="130000"/>
+              <a:rPr sz="1700" b="0">
+                <a:solidFill>
+                  <a:srgbClr val="595959"/>
+                </a:solidFill>
+                <a:latin typeface="Arial"/>
+              </a:rPr>
+              <a:t>You are not limited to today's three. All of this is in the drawers, and the repo has working code for the first three.</a:t>
+            </a:r>
+          </a:p>
+          <a:p>
+            <a:pPr marL="0" indent="0" algn="l">
+              <a:lnSpc>
+                <a:spcPct val="128000"/>
               </a:lnSpc>
               <a:spcAft>
                 <a:spcPts val="400"/>
@@ -8829,209 +7290,33 @@
               <a:buNone/>
             </a:pPr>
             <a:r>
-              <a:rPr sz="900" b="1">
-                <a:solidFill>
-                  <a:srgbClr val="595959"/>
-                </a:solidFill>
-                <a:latin typeface="Arial"/>
-              </a:rPr>
-              <a:t>USED FOR</a:t>
-            </a:r>
-          </a:p>
-          <a:p>
-            <a:pPr marL="0" indent="0" algn="l">
-              <a:lnSpc>
-                <a:spcPct val="130000"/>
-              </a:lnSpc>
-              <a:spcAft>
-                <a:spcPts val="1400"/>
-              </a:spcAft>
-              <a:buNone/>
-            </a:pPr>
-            <a:r>
-              <a:rPr sz="1400" b="0">
-                <a:solidFill>
-                  <a:srgbClr val="000000"/>
-                </a:solidFill>
-                <a:latin typeface="Arial"/>
-              </a:rPr>
-              <a:t>Latches, holds, and anything that should let go on cue.</a:t>
-            </a:r>
-          </a:p>
-          <a:p>
-            <a:pPr marL="0" indent="0" algn="l">
-              <a:lnSpc>
-                <a:spcPct val="130000"/>
-              </a:lnSpc>
-              <a:spcAft>
-                <a:spcPts val="0"/>
-              </a:spcAft>
-              <a:buNone/>
-            </a:pPr>
-            <a:r>
-              <a:rPr sz="1200" b="0">
-                <a:solidFill>
-                  <a:srgbClr val="595959"/>
-                </a:solidFill>
-                <a:latin typeface="Consolas"/>
-              </a:rPr>
-              <a:t>Drawer 3D  |  17 mini, 11 standard  |  needs a MOSFET</a:t>
-            </a:r>
-          </a:p>
-        </p:txBody>
-      </p:sp>
-      <p:pic>
-        <p:nvPicPr>
-          <p:cNvPr id="4" name="Picture 3" descr="electromagnet.jpg"/>
-          <p:cNvPicPr>
-            <a:picLocks noChangeAspect="1"/>
-          </p:cNvPicPr>
-          <p:nvPr/>
-        </p:nvPicPr>
-        <p:blipFill>
-          <a:blip r:embed="rId2"/>
-          <a:stretch>
-            <a:fillRect/>
-          </a:stretch>
-        </p:blipFill>
-        <p:spPr>
-          <a:xfrm>
-            <a:off x="914400" y="1905000"/>
-            <a:ext cx="1784181" cy="3175000"/>
-          </a:xfrm>
-          <a:prstGeom prst="rect">
-            <a:avLst/>
-          </a:prstGeom>
-        </p:spPr>
-      </p:pic>
-      <p:pic>
-        <p:nvPicPr>
-          <p:cNvPr id="5" name="Picture 4" descr="wordmark_dark.png"/>
-          <p:cNvPicPr>
-            <a:picLocks noChangeAspect="1"/>
-          </p:cNvPicPr>
-          <p:nvPr/>
-        </p:nvPicPr>
-        <p:blipFill>
-          <a:blip r:embed="rId3"/>
-          <a:stretch>
-            <a:fillRect/>
-          </a:stretch>
-        </p:blipFill>
-        <p:spPr>
-          <a:xfrm>
-            <a:off x="342900" y="6184900"/>
-            <a:ext cx="2070100" cy="529560"/>
-          </a:xfrm>
-          <a:prstGeom prst="rect">
-            <a:avLst/>
-          </a:prstGeom>
-        </p:spPr>
-      </p:pic>
-      <p:pic>
-        <p:nvPicPr>
-          <p:cNvPr id="6" name="Picture 5" descr="seal_dark.png"/>
-          <p:cNvPicPr>
-            <a:picLocks noChangeAspect="1"/>
-          </p:cNvPicPr>
-          <p:nvPr/>
-        </p:nvPicPr>
-        <p:blipFill>
-          <a:blip r:embed="rId4"/>
-          <a:stretch>
-            <a:fillRect/>
-          </a:stretch>
-        </p:blipFill>
-        <p:spPr>
-          <a:xfrm>
-            <a:off x="11226800" y="5969000"/>
-            <a:ext cx="713915" cy="711200"/>
-          </a:xfrm>
-          <a:prstGeom prst="rect">
-            <a:avLst/>
-          </a:prstGeom>
-        </p:spPr>
-      </p:pic>
-    </p:spTree>
-  </p:cSld>
-  <p:clrMapOvr>
-    <a:masterClrMapping/>
-  </p:clrMapOvr>
-</p:sld>
-</file>
-
-<file path=ppt/slides/slide19.xml><?xml version="1.0" encoding="utf-8"?>
-<p:sld xmlns:a="http://schemas.openxmlformats.org/drawingml/2006/main" xmlns:p="http://schemas.openxmlformats.org/presentationml/2006/main" xmlns:r="http://schemas.openxmlformats.org/officeDocument/2006/relationships">
-  <p:cSld>
-    <p:spTree>
-      <p:nvGrpSpPr>
-        <p:cNvPr id="1" name=""/>
-        <p:cNvGrpSpPr/>
-        <p:nvPr/>
-      </p:nvGrpSpPr>
-      <p:grpSpPr/>
-      <p:sp>
-        <p:nvSpPr>
-          <p:cNvPr id="2" name="Title 1"/>
-          <p:cNvSpPr>
-            <a:spLocks noGrp="1"/>
-          </p:cNvSpPr>
-          <p:nvPr>
-            <p:ph type="title"/>
-          </p:nvPr>
-        </p:nvSpPr>
-        <p:spPr/>
-        <p:txBody>
-          <a:bodyPr/>
-          <a:lstStyle/>
-          <a:p>
-            <a:pPr marL="0" indent="0" algn="l">
-              <a:buNone/>
-            </a:pPr>
-            <a:r>
-              <a:rPr sz="3200" b="1">
-                <a:solidFill>
-                  <a:srgbClr val="000000"/>
-                </a:solidFill>
-                <a:latin typeface="Arial"/>
-              </a:rPr>
-              <a:t>FREESTYLE, WITHIN THREE LIMITS</a:t>
-            </a:r>
-          </a:p>
-        </p:txBody>
-      </p:sp>
-      <p:sp>
-        <p:nvSpPr>
-          <p:cNvPr id="3" name="Text Placeholder 2"/>
-          <p:cNvSpPr>
-            <a:spLocks noGrp="1"/>
-          </p:cNvSpPr>
-          <p:nvPr>
-            <p:ph type="body" idx="1"/>
-          </p:nvPr>
-        </p:nvSpPr>
-        <p:spPr/>
-        <p:txBody>
-          <a:bodyPr/>
-          <a:lstStyle/>
+              <a:rPr sz="1700" b="1">
+                <a:solidFill>
+                  <a:srgbClr val="000000"/>
+                </a:solidFill>
+                <a:latin typeface="Arial"/>
+              </a:rPr>
+              <a:t>Coin motor         a buzz you cannot make gentle and fast</a:t>
+            </a:r>
+          </a:p>
           <a:p>
             <a:pPr marL="0" indent="0" algn="l">
               <a:lnSpc>
                 <a:spcPct val="128000"/>
               </a:lnSpc>
               <a:spcAft>
-                <a:spcPts val="1200"/>
-              </a:spcAft>
-              <a:buNone/>
-            </a:pPr>
-            <a:r>
-              <a:rPr sz="1700" b="0">
-                <a:solidFill>
-                  <a:srgbClr val="595959"/>
-                </a:solidFill>
-                <a:latin typeface="Arial"/>
-              </a:rPr>
-              <a:t>You do not have to do the tasks in order, or finish them. Playing properly with two beats rushing all five.</a:t>
+                <a:spcPts val="400"/>
+              </a:spcAft>
+              <a:buNone/>
+            </a:pPr>
+            <a:r>
+              <a:rPr sz="1500" b="0">
+                <a:solidFill>
+                  <a:srgbClr val="000000"/>
+                </a:solidFill>
+                <a:latin typeface="Arial"/>
+              </a:rPr>
+              <a:t>• 1E  |  117 in stock  |  needs a transistor</a:t>
             </a:r>
           </a:p>
           <a:p>
@@ -9045,13 +7330,13 @@
               <a:buNone/>
             </a:pPr>
             <a:r>
-              <a:rPr sz="1700" b="0">
-                <a:solidFill>
-                  <a:srgbClr val="000000"/>
-                </a:solidFill>
-                <a:latin typeface="Arial"/>
-              </a:rPr>
-              <a:t>If you want to drive something not in front of you, go get it.</a:t>
+              <a:rPr sz="1700" b="1">
+                <a:solidFill>
+                  <a:srgbClr val="000000"/>
+                </a:solidFill>
+                <a:latin typeface="Arial"/>
+              </a:rPr>
+              <a:t>Solenoid           a person tapping you, not a signal</a:t>
             </a:r>
           </a:p>
           <a:p>
@@ -9065,13 +7350,33 @@
               <a:buNone/>
             </a:pPr>
             <a:r>
+              <a:rPr sz="1500" b="0">
+                <a:solidFill>
+                  <a:srgbClr val="000000"/>
+                </a:solidFill>
+                <a:latin typeface="Arial"/>
+              </a:rPr>
+              <a:t>• 3E  |  24  |  1.1 A, needs its own supply</a:t>
+            </a:r>
+          </a:p>
+          <a:p>
+            <a:pPr marL="0" indent="0" algn="l">
+              <a:lnSpc>
+                <a:spcPct val="128000"/>
+              </a:lnSpc>
+              <a:spcAft>
+                <a:spcPts val="400"/>
+              </a:spcAft>
+              <a:buNone/>
+            </a:pPr>
+            <a:r>
               <a:rPr sz="1700" b="1">
                 <a:solidFill>
                   <a:srgbClr val="000000"/>
                 </a:solidFill>
                 <a:latin typeface="Arial"/>
               </a:rPr>
-              <a:t>The three things that are not negotiable</a:t>
+              <a:t>Peltier tile       heat and cold, several seconds to be sure</a:t>
             </a:r>
           </a:p>
           <a:p>
@@ -9091,7 +7396,7 @@
                 </a:solidFill>
                 <a:latin typeface="Arial"/>
               </a:rPr>
-              <a:t>• Solenoid and Peltier get their own supply, never USB</a:t>
+              <a:t>• 4C  |  60  |  needs an H bridge</a:t>
             </a:r>
           </a:p>
           <a:p>
@@ -9105,13 +7410,33 @@
               <a:buNone/>
             </a:pPr>
             <a:r>
+              <a:rPr sz="1700" b="1">
+                <a:solidFill>
+                  <a:srgbClr val="000000"/>
+                </a:solidFill>
+                <a:latin typeface="Arial"/>
+              </a:rPr>
+              <a:t>Surface transducer turns any surface into a speaker</a:t>
+            </a:r>
+          </a:p>
+          <a:p>
+            <a:pPr marL="0" indent="0" algn="l">
+              <a:lnSpc>
+                <a:spcPct val="128000"/>
+              </a:lnSpc>
+              <a:spcAft>
+                <a:spcPts val="400"/>
+              </a:spcAft>
+              <a:buNone/>
+            </a:pPr>
+            <a:r>
               <a:rPr sz="1500" b="0">
                 <a:solidFill>
                   <a:srgbClr val="000000"/>
                 </a:solidFill>
                 <a:latin typeface="Arial"/>
               </a:rPr>
-              <a:t>• The Peltier heatsink goes on before it is switched on</a:t>
+              <a:t>• 7F  |  48  |  needs an amplifier</a:t>
             </a:r>
           </a:p>
           <a:p>
@@ -9125,13 +7450,73 @@
               <a:buNone/>
             </a:pPr>
             <a:r>
+              <a:rPr sz="1700" b="1">
+                <a:solidFill>
+                  <a:srgbClr val="000000"/>
+                </a:solidFill>
+                <a:latin typeface="Arial"/>
+              </a:rPr>
+              <a:t>Servo              holds an angle, with force behind it</a:t>
+            </a:r>
+          </a:p>
+          <a:p>
+            <a:pPr marL="0" indent="0" algn="l">
+              <a:lnSpc>
+                <a:spcPct val="128000"/>
+              </a:lnSpc>
+              <a:spcAft>
+                <a:spcPts val="400"/>
+              </a:spcAft>
+              <a:buNone/>
+            </a:pPr>
+            <a:r>
               <a:rPr sz="1500" b="0">
                 <a:solidFill>
                   <a:srgbClr val="000000"/>
                 </a:solidFill>
                 <a:latin typeface="Arial"/>
               </a:rPr>
-              <a:t>• No motor straight from a pin. 40 mA limit, it wants 75</a:t>
+              <a:t>• 2F  |  80  |  Servo.h, own 5V</a:t>
+            </a:r>
+          </a:p>
+          <a:p>
+            <a:pPr marL="0" indent="0" algn="l">
+              <a:lnSpc>
+                <a:spcPct val="128000"/>
+              </a:lnSpc>
+              <a:spcAft>
+                <a:spcPts val="400"/>
+              </a:spcAft>
+              <a:buNone/>
+            </a:pPr>
+            <a:r>
+              <a:rPr sz="1700" b="1">
+                <a:solidFill>
+                  <a:srgbClr val="000000"/>
+                </a:solidFill>
+                <a:latin typeface="Arial"/>
+              </a:rPr>
+              <a:t>Electromagnet      a grip that appears and vanishes</a:t>
+            </a:r>
+          </a:p>
+          <a:p>
+            <a:pPr marL="0" indent="0" algn="l">
+              <a:lnSpc>
+                <a:spcPct val="128000"/>
+              </a:lnSpc>
+              <a:spcAft>
+                <a:spcPts val="400"/>
+              </a:spcAft>
+              <a:buNone/>
+            </a:pPr>
+            <a:r>
+              <a:rPr sz="1500" b="0">
+                <a:solidFill>
+                  <a:srgbClr val="000000"/>
+                </a:solidFill>
+                <a:latin typeface="Arial"/>
+              </a:rPr>
+              <a:t>• 3D  |  28  |  needs a MOSFET</a:t>
             </a:r>
           </a:p>
         </p:txBody>
@@ -9192,7 +7577,7 @@
 </p:sld>
 </file>
 
-<file path=ppt/slides/slide2.xml><?xml version="1.0" encoding="utf-8"?>
+<file path=ppt/slides/slide14.xml><?xml version="1.0" encoding="utf-8"?>
 <p:sld xmlns:a="http://schemas.openxmlformats.org/drawingml/2006/main" xmlns:p="http://schemas.openxmlformats.org/presentationml/2006/main" xmlns:r="http://schemas.openxmlformats.org/officeDocument/2006/relationships">
   <p:cSld>
     <p:spTree>
@@ -9227,7 +7612,7 @@
                 </a:solidFill>
                 <a:latin typeface="Arial"/>
               </a:rPr>
-              <a:t>TLDR</a:t>
+              <a:t>FREESTYLE, WITHIN THREE LIMITS</a:t>
             </a:r>
           </a:p>
         </p:txBody>
@@ -9263,7 +7648,7 @@
                 </a:solidFill>
                 <a:latin typeface="Arial"/>
               </a:rPr>
-              <a:t>Two hours finding out what actuators feel like, and leaving able to drive one from your own code.</a:t>
+              <a:t>You do not have to do the tasks in order, or finish them. Playing properly with two beats rushing all five.</a:t>
             </a:r>
           </a:p>
           <a:p>
@@ -9283,7 +7668,7 @@
                 </a:solidFill>
                 <a:latin typeface="Arial"/>
               </a:rPr>
-              <a:t>Get a board and run task 01. Something spins.</a:t>
+              <a:t>If you want to drive something not in front of you, go get it.</a:t>
             </a:r>
           </a:p>
           <a:p>
@@ -9297,13 +7682,13 @@
               <a:buNone/>
             </a:pPr>
             <a:r>
-              <a:rPr sz="1700" b="0">
-                <a:solidFill>
-                  <a:srgbClr val="000000"/>
-                </a:solidFill>
-                <a:latin typeface="Arial"/>
-              </a:rPr>
-              <a:t>Change two numbers, upload again. That loop is the workshop.</a:t>
+              <a:rPr sz="1700" b="1">
+                <a:solidFill>
+                  <a:srgbClr val="000000"/>
+                </a:solidFill>
+                <a:latin typeface="Arial"/>
+              </a:rPr>
+              <a:t>The three things that are not negotiable</a:t>
             </a:r>
           </a:p>
           <a:p>
@@ -9317,13 +7702,13 @@
               <a:buNone/>
             </a:pPr>
             <a:r>
-              <a:rPr sz="1700" b="0">
-                <a:solidFill>
-                  <a:srgbClr val="000000"/>
-                </a:solidFill>
-                <a:latin typeface="Arial"/>
-              </a:rPr>
-              <a:t>Pick up the actuators you are not driving.</a:t>
+              <a:rPr sz="1500" b="0">
+                <a:solidFill>
+                  <a:srgbClr val="000000"/>
+                </a:solidFill>
+                <a:latin typeface="Arial"/>
+              </a:rPr>
+              <a:t>• Solenoid and Peltier get their own supply, never USB</a:t>
             </a:r>
           </a:p>
           <a:p>
@@ -9337,13 +7722,13 @@
               <a:buNone/>
             </a:pPr>
             <a:r>
-              <a:rPr sz="1700" b="0">
-                <a:solidFill>
-                  <a:srgbClr val="000000"/>
-                </a:solidFill>
-                <a:latin typeface="Arial"/>
-              </a:rPr>
-              <a:t>Work through as many of the five tasks as you get to.</a:t>
+              <a:rPr sz="1500" b="0">
+                <a:solidFill>
+                  <a:srgbClr val="000000"/>
+                </a:solidFill>
+                <a:latin typeface="Arial"/>
+              </a:rPr>
+              <a:t>• The Peltier heatsink goes on before it is switched on</a:t>
             </a:r>
           </a:p>
           <a:p>
@@ -9357,13 +7742,13 @@
               <a:buNone/>
             </a:pPr>
             <a:r>
-              <a:rPr sz="1700" b="0">
-                <a:solidFill>
-                  <a:srgbClr val="000000"/>
-                </a:solidFill>
-                <a:latin typeface="Arial"/>
-              </a:rPr>
-              <a:t>Build one signal someone else can read without looking.</a:t>
+              <a:rPr sz="1500" b="0">
+                <a:solidFill>
+                  <a:srgbClr val="000000"/>
+                </a:solidFill>
+                <a:latin typeface="Arial"/>
+              </a:rPr>
+              <a:t>• No motor straight from a pin. 40 mA limit, it wants 75</a:t>
             </a:r>
           </a:p>
         </p:txBody>
@@ -9424,7 +7809,7 @@
 </p:sld>
 </file>
 
-<file path=ppt/slides/slide20.xml><?xml version="1.0" encoding="utf-8"?>
+<file path=ppt/slides/slide15.xml><?xml version="1.0" encoding="utf-8"?>
 <p:sld xmlns:a="http://schemas.openxmlformats.org/drawingml/2006/main" xmlns:p="http://schemas.openxmlformats.org/presentationml/2006/main" xmlns:r="http://schemas.openxmlformats.org/officeDocument/2006/relationships">
   <p:cSld>
     <p:spTree>
@@ -9656,7 +8041,7 @@
 </p:sld>
 </file>
 
-<file path=ppt/slides/slide21.xml><?xml version="1.0" encoding="utf-8"?>
+<file path=ppt/slides/slide16.xml><?xml version="1.0" encoding="utf-8"?>
 <p:sld xmlns:a="http://schemas.openxmlformats.org/drawingml/2006/main" xmlns:p="http://schemas.openxmlformats.org/presentationml/2006/main" xmlns:r="http://schemas.openxmlformats.org/officeDocument/2006/relationships">
   <p:cSld>
     <p:spTree>
@@ -9752,7 +8137,7 @@
 </p:sld>
 </file>
 
-<file path=ppt/slides/slide22.xml><?xml version="1.0" encoding="utf-8"?>
+<file path=ppt/slides/slide17.xml><?xml version="1.0" encoding="utf-8"?>
 <p:sld xmlns:a="http://schemas.openxmlformats.org/drawingml/2006/main" xmlns:p="http://schemas.openxmlformats.org/presentationml/2006/main" xmlns:r="http://schemas.openxmlformats.org/officeDocument/2006/relationships">
   <p:cSld>
     <p:spTree>
@@ -10136,7 +8521,7 @@
 </p:sld>
 </file>
 
-<file path=ppt/slides/slide23.xml><?xml version="1.0" encoding="utf-8"?>
+<file path=ppt/slides/slide18.xml><?xml version="1.0" encoding="utf-8"?>
 <p:sld xmlns:a="http://schemas.openxmlformats.org/drawingml/2006/main" xmlns:p="http://schemas.openxmlformats.org/presentationml/2006/main" xmlns:r="http://schemas.openxmlformats.org/officeDocument/2006/relationships">
   <p:cSld>
     <p:spTree>
@@ -10388,7 +8773,7 @@
 </p:sld>
 </file>
 
-<file path=ppt/slides/slide24.xml><?xml version="1.0" encoding="utf-8"?>
+<file path=ppt/slides/slide19.xml><?xml version="1.0" encoding="utf-8"?>
 <p:sld xmlns:a="http://schemas.openxmlformats.org/drawingml/2006/main" xmlns:p="http://schemas.openxmlformats.org/presentationml/2006/main" xmlns:r="http://schemas.openxmlformats.org/officeDocument/2006/relationships">
   <p:cSld>
     <p:spTree>
@@ -10680,7 +9065,239 @@
 </p:sld>
 </file>
 
-<file path=ppt/slides/slide25.xml><?xml version="1.0" encoding="utf-8"?>
+<file path=ppt/slides/slide2.xml><?xml version="1.0" encoding="utf-8"?>
+<p:sld xmlns:a="http://schemas.openxmlformats.org/drawingml/2006/main" xmlns:p="http://schemas.openxmlformats.org/presentationml/2006/main" xmlns:r="http://schemas.openxmlformats.org/officeDocument/2006/relationships">
+  <p:cSld>
+    <p:spTree>
+      <p:nvGrpSpPr>
+        <p:cNvPr id="1" name=""/>
+        <p:cNvGrpSpPr/>
+        <p:nvPr/>
+      </p:nvGrpSpPr>
+      <p:grpSpPr/>
+      <p:sp>
+        <p:nvSpPr>
+          <p:cNvPr id="2" name="Title 1"/>
+          <p:cNvSpPr>
+            <a:spLocks noGrp="1"/>
+          </p:cNvSpPr>
+          <p:nvPr>
+            <p:ph type="title"/>
+          </p:nvPr>
+        </p:nvSpPr>
+        <p:spPr/>
+        <p:txBody>
+          <a:bodyPr/>
+          <a:lstStyle/>
+          <a:p>
+            <a:pPr marL="0" indent="0" algn="l">
+              <a:buNone/>
+            </a:pPr>
+            <a:r>
+              <a:rPr sz="3200" b="1">
+                <a:solidFill>
+                  <a:srgbClr val="000000"/>
+                </a:solidFill>
+                <a:latin typeface="Arial"/>
+              </a:rPr>
+              <a:t>TLDR</a:t>
+            </a:r>
+          </a:p>
+        </p:txBody>
+      </p:sp>
+      <p:sp>
+        <p:nvSpPr>
+          <p:cNvPr id="3" name="Text Placeholder 2"/>
+          <p:cNvSpPr>
+            <a:spLocks noGrp="1"/>
+          </p:cNvSpPr>
+          <p:nvPr>
+            <p:ph type="body" idx="1"/>
+          </p:nvPr>
+        </p:nvSpPr>
+        <p:spPr/>
+        <p:txBody>
+          <a:bodyPr/>
+          <a:lstStyle/>
+          <a:p>
+            <a:pPr marL="0" indent="0" algn="l">
+              <a:lnSpc>
+                <a:spcPct val="128000"/>
+              </a:lnSpc>
+              <a:spcAft>
+                <a:spcPts val="1200"/>
+              </a:spcAft>
+              <a:buNone/>
+            </a:pPr>
+            <a:r>
+              <a:rPr sz="1700" b="0">
+                <a:solidFill>
+                  <a:srgbClr val="595959"/>
+                </a:solidFill>
+                <a:latin typeface="Arial"/>
+              </a:rPr>
+              <a:t>Two hours finding out what actuators feel like, and leaving able to drive one from your own code.</a:t>
+            </a:r>
+          </a:p>
+          <a:p>
+            <a:pPr marL="0" indent="0" algn="l">
+              <a:lnSpc>
+                <a:spcPct val="128000"/>
+              </a:lnSpc>
+              <a:spcAft>
+                <a:spcPts val="400"/>
+              </a:spcAft>
+              <a:buNone/>
+            </a:pPr>
+            <a:r>
+              <a:rPr sz="1700" b="0">
+                <a:solidFill>
+                  <a:srgbClr val="000000"/>
+                </a:solidFill>
+                <a:latin typeface="Arial"/>
+              </a:rPr>
+              <a:t>Get a board and run task 01. Something spins.</a:t>
+            </a:r>
+          </a:p>
+          <a:p>
+            <a:pPr marL="0" indent="0" algn="l">
+              <a:lnSpc>
+                <a:spcPct val="128000"/>
+              </a:lnSpc>
+              <a:spcAft>
+                <a:spcPts val="400"/>
+              </a:spcAft>
+              <a:buNone/>
+            </a:pPr>
+            <a:r>
+              <a:rPr sz="1700" b="0">
+                <a:solidFill>
+                  <a:srgbClr val="000000"/>
+                </a:solidFill>
+                <a:latin typeface="Arial"/>
+              </a:rPr>
+              <a:t>Change two numbers, upload again. That loop is the workshop.</a:t>
+            </a:r>
+          </a:p>
+          <a:p>
+            <a:pPr marL="0" indent="0" algn="l">
+              <a:lnSpc>
+                <a:spcPct val="128000"/>
+              </a:lnSpc>
+              <a:spcAft>
+                <a:spcPts val="400"/>
+              </a:spcAft>
+              <a:buNone/>
+            </a:pPr>
+            <a:r>
+              <a:rPr sz="1700" b="0">
+                <a:solidFill>
+                  <a:srgbClr val="000000"/>
+                </a:solidFill>
+                <a:latin typeface="Arial"/>
+              </a:rPr>
+              <a:t>Pick up the actuators you are not driving.</a:t>
+            </a:r>
+          </a:p>
+          <a:p>
+            <a:pPr marL="0" indent="0" algn="l">
+              <a:lnSpc>
+                <a:spcPct val="128000"/>
+              </a:lnSpc>
+              <a:spcAft>
+                <a:spcPts val="400"/>
+              </a:spcAft>
+              <a:buNone/>
+            </a:pPr>
+            <a:r>
+              <a:rPr sz="1700" b="0">
+                <a:solidFill>
+                  <a:srgbClr val="000000"/>
+                </a:solidFill>
+                <a:latin typeface="Arial"/>
+              </a:rPr>
+              <a:t>Work through as many of the five tasks as you get to.</a:t>
+            </a:r>
+          </a:p>
+          <a:p>
+            <a:pPr marL="0" indent="0" algn="l">
+              <a:lnSpc>
+                <a:spcPct val="128000"/>
+              </a:lnSpc>
+              <a:spcAft>
+                <a:spcPts val="400"/>
+              </a:spcAft>
+              <a:buNone/>
+            </a:pPr>
+            <a:r>
+              <a:rPr sz="1700" b="0">
+                <a:solidFill>
+                  <a:srgbClr val="000000"/>
+                </a:solidFill>
+                <a:latin typeface="Arial"/>
+              </a:rPr>
+              <a:t>Build one signal someone else can read without looking.</a:t>
+            </a:r>
+          </a:p>
+        </p:txBody>
+      </p:sp>
+      <p:pic>
+        <p:nvPicPr>
+          <p:cNvPr id="4" name="Picture 3" descr="wordmark_dark.png"/>
+          <p:cNvPicPr>
+            <a:picLocks noChangeAspect="1"/>
+          </p:cNvPicPr>
+          <p:nvPr/>
+        </p:nvPicPr>
+        <p:blipFill>
+          <a:blip r:embed="rId2"/>
+          <a:stretch>
+            <a:fillRect/>
+          </a:stretch>
+        </p:blipFill>
+        <p:spPr>
+          <a:xfrm>
+            <a:off x="342900" y="6184900"/>
+            <a:ext cx="2070100" cy="529560"/>
+          </a:xfrm>
+          <a:prstGeom prst="rect">
+            <a:avLst/>
+          </a:prstGeom>
+        </p:spPr>
+      </p:pic>
+      <p:pic>
+        <p:nvPicPr>
+          <p:cNvPr id="5" name="Picture 4" descr="seal_dark.png"/>
+          <p:cNvPicPr>
+            <a:picLocks noChangeAspect="1"/>
+          </p:cNvPicPr>
+          <p:nvPr/>
+        </p:nvPicPr>
+        <p:blipFill>
+          <a:blip r:embed="rId3"/>
+          <a:stretch>
+            <a:fillRect/>
+          </a:stretch>
+        </p:blipFill>
+        <p:spPr>
+          <a:xfrm>
+            <a:off x="11226800" y="5969000"/>
+            <a:ext cx="713915" cy="711200"/>
+          </a:xfrm>
+          <a:prstGeom prst="rect">
+            <a:avLst/>
+          </a:prstGeom>
+        </p:spPr>
+      </p:pic>
+    </p:spTree>
+  </p:cSld>
+  <p:clrMapOvr>
+    <a:masterClrMapping/>
+  </p:clrMapOvr>
+</p:sld>
+</file>
+
+<file path=ppt/slides/slide20.xml><?xml version="1.0" encoding="utf-8"?>
 <p:sld xmlns:a="http://schemas.openxmlformats.org/drawingml/2006/main" xmlns:p="http://schemas.openxmlformats.org/presentationml/2006/main" xmlns:r="http://schemas.openxmlformats.org/officeDocument/2006/relationships">
   <p:cSld>
     <p:spTree>
@@ -11024,7 +9641,7 @@
 </p:sld>
 </file>
 
-<file path=ppt/slides/slide26.xml><?xml version="1.0" encoding="utf-8"?>
+<file path=ppt/slides/slide21.xml><?xml version="1.0" encoding="utf-8"?>
 <p:sld xmlns:a="http://schemas.openxmlformats.org/drawingml/2006/main" xmlns:p="http://schemas.openxmlformats.org/presentationml/2006/main" xmlns:r="http://schemas.openxmlformats.org/officeDocument/2006/relationships">
   <p:cSld>
     <p:spTree>
@@ -11276,7 +9893,7 @@
 </p:sld>
 </file>
 
-<file path=ppt/slides/slide27.xml><?xml version="1.0" encoding="utf-8"?>
+<file path=ppt/slides/slide22.xml><?xml version="1.0" encoding="utf-8"?>
 <p:sld xmlns:a="http://schemas.openxmlformats.org/drawingml/2006/main" xmlns:p="http://schemas.openxmlformats.org/presentationml/2006/main" xmlns:r="http://schemas.openxmlformats.org/officeDocument/2006/relationships">
   <p:cSld>
     <p:spTree>
@@ -11372,7 +9989,7 @@
 </p:sld>
 </file>
 
-<file path=ppt/slides/slide28.xml><?xml version="1.0" encoding="utf-8"?>
+<file path=ppt/slides/slide23.xml><?xml version="1.0" encoding="utf-8"?>
 <p:sld xmlns:a="http://schemas.openxmlformats.org/drawingml/2006/main" xmlns:p="http://schemas.openxmlformats.org/presentationml/2006/main" xmlns:r="http://schemas.openxmlformats.org/officeDocument/2006/relationships">
   <p:cSld>
     <p:spTree>
@@ -11624,7 +10241,7 @@
 </p:sld>
 </file>
 
-<file path=ppt/slides/slide29.xml><?xml version="1.0" encoding="utf-8"?>
+<file path=ppt/slides/slide24.xml><?xml version="1.0" encoding="utf-8"?>
 <p:sld xmlns:a="http://schemas.openxmlformats.org/drawingml/2006/main" xmlns:p="http://schemas.openxmlformats.org/presentationml/2006/main" xmlns:r="http://schemas.openxmlformats.org/officeDocument/2006/relationships">
   <p:cSld>
     <p:spTree>
@@ -11807,7 +10424,7 @@
 </p:sld>
 </file>
 
-<file path=ppt/slides/slide3.xml><?xml version="1.0" encoding="utf-8"?>
+<file path=ppt/slides/slide25.xml><?xml version="1.0" encoding="utf-8"?>
 <p:sld xmlns:a="http://schemas.openxmlformats.org/drawingml/2006/main" xmlns:p="http://schemas.openxmlformats.org/presentationml/2006/main" xmlns:r="http://schemas.openxmlformats.org/officeDocument/2006/relationships">
   <p:cSld>
     <p:spTree>
@@ -11842,7 +10459,7 @@
                 </a:solidFill>
                 <a:latin typeface="Arial"/>
               </a:rPr>
-              <a:t>WHY WE ARE HERE</a:t>
+              <a:t>BEFORE YOU CALL IT DONE</a:t>
             </a:r>
           </a:p>
         </p:txBody>
@@ -11878,7 +10495,7 @@
                 </a:solidFill>
                 <a:latin typeface="Arial"/>
               </a:rPr>
-              <a:t>You can read a datasheet. You have never held one of these.</a:t>
+              <a:t>Hand your device to another group with the screen turned away.</a:t>
             </a:r>
           </a:p>
           <a:p>
@@ -11892,13 +10509,13 @@
               <a:buNone/>
             </a:pPr>
             <a:r>
-              <a:rPr sz="1700" b="0">
-                <a:solidFill>
-                  <a:srgbClr val="000000"/>
-                </a:solidFill>
-                <a:latin typeface="Arial"/>
-              </a:rPr>
-              <a:t>Most projects end up on the screen and the speaker</a:t>
+              <a:rPr sz="1500" b="0">
+                <a:solidFill>
+                  <a:srgbClr val="000000"/>
+                </a:solidFill>
+                <a:latin typeface="Arial"/>
+              </a:rPr>
+              <a:t>• They can tell all three messages apart</a:t>
             </a:r>
           </a:p>
           <a:p>
@@ -11918,7 +10535,7 @@
                 </a:solidFill>
                 <a:latin typeface="Arial"/>
               </a:rPr>
-              <a:t>• Not because touch was wrong</a:t>
+              <a:t>• It does not fire continuously when held</a:t>
             </a:r>
           </a:p>
           <a:p>
@@ -11938,7 +10555,7 @@
                 </a:solidFill>
                 <a:latin typeface="Arial"/>
               </a:rPr>
-              <a:t>• Because nobody knew the lab has 117 coin motors</a:t>
+              <a:t>• You know which two got confused, and why</a:t>
             </a:r>
           </a:p>
           <a:p>
@@ -11969,7 +10586,7 @@
                 </a:solidFill>
                 <a:latin typeface="Arial"/>
               </a:rPr>
-              <a:t>Today: decide it feels cheap, pick something else</a:t>
+              <a:t>What you actually leave with</a:t>
             </a:r>
           </a:p>
           <a:p>
@@ -11989,7 +10606,27 @@
                 </a:solidFill>
                 <a:latin typeface="Arial"/>
               </a:rPr>
-              <a:t>• Better now than in week 46</a:t>
+              <a:t>• What things feel like, how to drive one, and which to pick</a:t>
+            </a:r>
+          </a:p>
+          <a:p>
+            <a:pPr marL="0" indent="0" algn="l">
+              <a:lnSpc>
+                <a:spcPct val="128000"/>
+              </a:lnSpc>
+              <a:spcAft>
+                <a:spcPts val="400"/>
+              </a:spcAft>
+              <a:buNone/>
+            </a:pPr>
+            <a:r>
+              <a:rPr sz="1500" b="0">
+                <a:solidFill>
+                  <a:srgbClr val="000000"/>
+                </a:solidFill>
+                <a:latin typeface="Arial"/>
+              </a:rPr>
+              <a:t>• That last one is the expensive mistake this prevents</a:t>
             </a:r>
           </a:p>
         </p:txBody>
@@ -12050,270 +10687,7 @@
 </p:sld>
 </file>
 
-<file path=ppt/slides/slide30.xml><?xml version="1.0" encoding="utf-8"?>
-<p:sld xmlns:a="http://schemas.openxmlformats.org/drawingml/2006/main" xmlns:p="http://schemas.openxmlformats.org/presentationml/2006/main" xmlns:r="http://schemas.openxmlformats.org/officeDocument/2006/relationships">
-  <p:cSld>
-    <p:spTree>
-      <p:nvGrpSpPr>
-        <p:cNvPr id="1" name=""/>
-        <p:cNvGrpSpPr/>
-        <p:nvPr/>
-      </p:nvGrpSpPr>
-      <p:grpSpPr/>
-      <p:sp>
-        <p:nvSpPr>
-          <p:cNvPr id="2" name="Title 1"/>
-          <p:cNvSpPr>
-            <a:spLocks noGrp="1"/>
-          </p:cNvSpPr>
-          <p:nvPr>
-            <p:ph type="title"/>
-          </p:nvPr>
-        </p:nvSpPr>
-        <p:spPr/>
-        <p:txBody>
-          <a:bodyPr/>
-          <a:lstStyle/>
-          <a:p>
-            <a:pPr marL="0" indent="0" algn="l">
-              <a:buNone/>
-            </a:pPr>
-            <a:r>
-              <a:rPr sz="3200" b="1">
-                <a:solidFill>
-                  <a:srgbClr val="000000"/>
-                </a:solidFill>
-                <a:latin typeface="Arial"/>
-              </a:rPr>
-              <a:t>BEFORE YOU CALL IT DONE</a:t>
-            </a:r>
-          </a:p>
-        </p:txBody>
-      </p:sp>
-      <p:sp>
-        <p:nvSpPr>
-          <p:cNvPr id="3" name="Text Placeholder 2"/>
-          <p:cNvSpPr>
-            <a:spLocks noGrp="1"/>
-          </p:cNvSpPr>
-          <p:nvPr>
-            <p:ph type="body" idx="1"/>
-          </p:nvPr>
-        </p:nvSpPr>
-        <p:spPr/>
-        <p:txBody>
-          <a:bodyPr/>
-          <a:lstStyle/>
-          <a:p>
-            <a:pPr marL="0" indent="0" algn="l">
-              <a:lnSpc>
-                <a:spcPct val="128000"/>
-              </a:lnSpc>
-              <a:spcAft>
-                <a:spcPts val="1200"/>
-              </a:spcAft>
-              <a:buNone/>
-            </a:pPr>
-            <a:r>
-              <a:rPr sz="1700" b="0">
-                <a:solidFill>
-                  <a:srgbClr val="595959"/>
-                </a:solidFill>
-                <a:latin typeface="Arial"/>
-              </a:rPr>
-              <a:t>Hand your device to another group with the screen turned away.</a:t>
-            </a:r>
-          </a:p>
-          <a:p>
-            <a:pPr marL="0" indent="0" algn="l">
-              <a:lnSpc>
-                <a:spcPct val="128000"/>
-              </a:lnSpc>
-              <a:spcAft>
-                <a:spcPts val="400"/>
-              </a:spcAft>
-              <a:buNone/>
-            </a:pPr>
-            <a:r>
-              <a:rPr sz="1500" b="0">
-                <a:solidFill>
-                  <a:srgbClr val="000000"/>
-                </a:solidFill>
-                <a:latin typeface="Arial"/>
-              </a:rPr>
-              <a:t>• They can tell all three messages apart</a:t>
-            </a:r>
-          </a:p>
-          <a:p>
-            <a:pPr marL="0" indent="0" algn="l">
-              <a:lnSpc>
-                <a:spcPct val="128000"/>
-              </a:lnSpc>
-              <a:spcAft>
-                <a:spcPts val="400"/>
-              </a:spcAft>
-              <a:buNone/>
-            </a:pPr>
-            <a:r>
-              <a:rPr sz="1500" b="0">
-                <a:solidFill>
-                  <a:srgbClr val="000000"/>
-                </a:solidFill>
-                <a:latin typeface="Arial"/>
-              </a:rPr>
-              <a:t>• It does not fire continuously when held</a:t>
-            </a:r>
-          </a:p>
-          <a:p>
-            <a:pPr marL="0" indent="0" algn="l">
-              <a:lnSpc>
-                <a:spcPct val="128000"/>
-              </a:lnSpc>
-              <a:spcAft>
-                <a:spcPts val="400"/>
-              </a:spcAft>
-              <a:buNone/>
-            </a:pPr>
-            <a:r>
-              <a:rPr sz="1500" b="0">
-                <a:solidFill>
-                  <a:srgbClr val="000000"/>
-                </a:solidFill>
-                <a:latin typeface="Arial"/>
-              </a:rPr>
-              <a:t>• You know which two got confused, and why</a:t>
-            </a:r>
-          </a:p>
-          <a:p>
-            <a:pPr marL="0" indent="0" algn="l">
-              <a:lnSpc>
-                <a:spcPct val="128000"/>
-              </a:lnSpc>
-              <a:spcAft>
-                <a:spcPts val="0"/>
-              </a:spcAft>
-              <a:buNone/>
-            </a:pPr>
-          </a:p>
-          <a:p>
-            <a:pPr marL="0" indent="0" algn="l">
-              <a:lnSpc>
-                <a:spcPct val="128000"/>
-              </a:lnSpc>
-              <a:spcAft>
-                <a:spcPts val="400"/>
-              </a:spcAft>
-              <a:buNone/>
-            </a:pPr>
-            <a:r>
-              <a:rPr sz="1700" b="1">
-                <a:solidFill>
-                  <a:srgbClr val="000000"/>
-                </a:solidFill>
-                <a:latin typeface="Arial"/>
-              </a:rPr>
-              <a:t>What you actually leave with</a:t>
-            </a:r>
-          </a:p>
-          <a:p>
-            <a:pPr marL="0" indent="0" algn="l">
-              <a:lnSpc>
-                <a:spcPct val="128000"/>
-              </a:lnSpc>
-              <a:spcAft>
-                <a:spcPts val="400"/>
-              </a:spcAft>
-              <a:buNone/>
-            </a:pPr>
-            <a:r>
-              <a:rPr sz="1500" b="0">
-                <a:solidFill>
-                  <a:srgbClr val="000000"/>
-                </a:solidFill>
-                <a:latin typeface="Arial"/>
-              </a:rPr>
-              <a:t>• What things feel like, how to drive one, and which to pick</a:t>
-            </a:r>
-          </a:p>
-          <a:p>
-            <a:pPr marL="0" indent="0" algn="l">
-              <a:lnSpc>
-                <a:spcPct val="128000"/>
-              </a:lnSpc>
-              <a:spcAft>
-                <a:spcPts val="400"/>
-              </a:spcAft>
-              <a:buNone/>
-            </a:pPr>
-            <a:r>
-              <a:rPr sz="1500" b="0">
-                <a:solidFill>
-                  <a:srgbClr val="000000"/>
-                </a:solidFill>
-                <a:latin typeface="Arial"/>
-              </a:rPr>
-              <a:t>• That last one is the expensive mistake this prevents</a:t>
-            </a:r>
-          </a:p>
-        </p:txBody>
-      </p:sp>
-      <p:pic>
-        <p:nvPicPr>
-          <p:cNvPr id="4" name="Picture 3" descr="wordmark_dark.png"/>
-          <p:cNvPicPr>
-            <a:picLocks noChangeAspect="1"/>
-          </p:cNvPicPr>
-          <p:nvPr/>
-        </p:nvPicPr>
-        <p:blipFill>
-          <a:blip r:embed="rId2"/>
-          <a:stretch>
-            <a:fillRect/>
-          </a:stretch>
-        </p:blipFill>
-        <p:spPr>
-          <a:xfrm>
-            <a:off x="342900" y="6184900"/>
-            <a:ext cx="2070100" cy="529560"/>
-          </a:xfrm>
-          <a:prstGeom prst="rect">
-            <a:avLst/>
-          </a:prstGeom>
-        </p:spPr>
-      </p:pic>
-      <p:pic>
-        <p:nvPicPr>
-          <p:cNvPr id="5" name="Picture 4" descr="seal_dark.png"/>
-          <p:cNvPicPr>
-            <a:picLocks noChangeAspect="1"/>
-          </p:cNvPicPr>
-          <p:nvPr/>
-        </p:nvPicPr>
-        <p:blipFill>
-          <a:blip r:embed="rId3"/>
-          <a:stretch>
-            <a:fillRect/>
-          </a:stretch>
-        </p:blipFill>
-        <p:spPr>
-          <a:xfrm>
-            <a:off x="11226800" y="5969000"/>
-            <a:ext cx="713915" cy="711200"/>
-          </a:xfrm>
-          <a:prstGeom prst="rect">
-            <a:avLst/>
-          </a:prstGeom>
-        </p:spPr>
-      </p:pic>
-    </p:spTree>
-  </p:cSld>
-  <p:clrMapOvr>
-    <a:masterClrMapping/>
-  </p:clrMapOvr>
-</p:sld>
-</file>
-
-<file path=ppt/slides/slide31.xml><?xml version="1.0" encoding="utf-8"?>
+<file path=ppt/slides/slide26.xml><?xml version="1.0" encoding="utf-8"?>
 <p:sld xmlns:a="http://schemas.openxmlformats.org/drawingml/2006/main" xmlns:p="http://schemas.openxmlformats.org/presentationml/2006/main" xmlns:r="http://schemas.openxmlformats.org/officeDocument/2006/relationships">
   <p:cSld>
     <p:spTree>
@@ -12510,6 +10884,249 @@
 </p:sld>
 </file>
 
+<file path=ppt/slides/slide3.xml><?xml version="1.0" encoding="utf-8"?>
+<p:sld xmlns:a="http://schemas.openxmlformats.org/drawingml/2006/main" xmlns:p="http://schemas.openxmlformats.org/presentationml/2006/main" xmlns:r="http://schemas.openxmlformats.org/officeDocument/2006/relationships">
+  <p:cSld>
+    <p:spTree>
+      <p:nvGrpSpPr>
+        <p:cNvPr id="1" name=""/>
+        <p:cNvGrpSpPr/>
+        <p:nvPr/>
+      </p:nvGrpSpPr>
+      <p:grpSpPr/>
+      <p:sp>
+        <p:nvSpPr>
+          <p:cNvPr id="2" name="Title 1"/>
+          <p:cNvSpPr>
+            <a:spLocks noGrp="1"/>
+          </p:cNvSpPr>
+          <p:nvPr>
+            <p:ph type="title"/>
+          </p:nvPr>
+        </p:nvSpPr>
+        <p:spPr/>
+        <p:txBody>
+          <a:bodyPr/>
+          <a:lstStyle/>
+          <a:p>
+            <a:pPr marL="0" indent="0" algn="l">
+              <a:buNone/>
+            </a:pPr>
+            <a:r>
+              <a:rPr sz="3200" b="1">
+                <a:solidFill>
+                  <a:srgbClr val="000000"/>
+                </a:solidFill>
+                <a:latin typeface="Arial"/>
+              </a:rPr>
+              <a:t>WHY WE ARE HERE</a:t>
+            </a:r>
+          </a:p>
+        </p:txBody>
+      </p:sp>
+      <p:sp>
+        <p:nvSpPr>
+          <p:cNvPr id="3" name="Text Placeholder 2"/>
+          <p:cNvSpPr>
+            <a:spLocks noGrp="1"/>
+          </p:cNvSpPr>
+          <p:nvPr>
+            <p:ph type="body" idx="1"/>
+          </p:nvPr>
+        </p:nvSpPr>
+        <p:spPr/>
+        <p:txBody>
+          <a:bodyPr/>
+          <a:lstStyle/>
+          <a:p>
+            <a:pPr marL="0" indent="0" algn="l">
+              <a:lnSpc>
+                <a:spcPct val="128000"/>
+              </a:lnSpc>
+              <a:spcAft>
+                <a:spcPts val="1200"/>
+              </a:spcAft>
+              <a:buNone/>
+            </a:pPr>
+            <a:r>
+              <a:rPr sz="1700" b="0">
+                <a:solidFill>
+                  <a:srgbClr val="595959"/>
+                </a:solidFill>
+                <a:latin typeface="Arial"/>
+              </a:rPr>
+              <a:t>You can read a datasheet. You have never held one of these.</a:t>
+            </a:r>
+          </a:p>
+          <a:p>
+            <a:pPr marL="0" indent="0" algn="l">
+              <a:lnSpc>
+                <a:spcPct val="128000"/>
+              </a:lnSpc>
+              <a:spcAft>
+                <a:spcPts val="400"/>
+              </a:spcAft>
+              <a:buNone/>
+            </a:pPr>
+            <a:r>
+              <a:rPr sz="1700" b="0">
+                <a:solidFill>
+                  <a:srgbClr val="000000"/>
+                </a:solidFill>
+                <a:latin typeface="Arial"/>
+              </a:rPr>
+              <a:t>Most projects end up on the screen and the speaker</a:t>
+            </a:r>
+          </a:p>
+          <a:p>
+            <a:pPr marL="0" indent="0" algn="l">
+              <a:lnSpc>
+                <a:spcPct val="128000"/>
+              </a:lnSpc>
+              <a:spcAft>
+                <a:spcPts val="400"/>
+              </a:spcAft>
+              <a:buNone/>
+            </a:pPr>
+            <a:r>
+              <a:rPr sz="1500" b="0">
+                <a:solidFill>
+                  <a:srgbClr val="000000"/>
+                </a:solidFill>
+                <a:latin typeface="Arial"/>
+              </a:rPr>
+              <a:t>• Not because touch was wrong</a:t>
+            </a:r>
+          </a:p>
+          <a:p>
+            <a:pPr marL="0" indent="0" algn="l">
+              <a:lnSpc>
+                <a:spcPct val="128000"/>
+              </a:lnSpc>
+              <a:spcAft>
+                <a:spcPts val="400"/>
+              </a:spcAft>
+              <a:buNone/>
+            </a:pPr>
+            <a:r>
+              <a:rPr sz="1500" b="0">
+                <a:solidFill>
+                  <a:srgbClr val="000000"/>
+                </a:solidFill>
+                <a:latin typeface="Arial"/>
+              </a:rPr>
+              <a:t>• Because nobody knew the lab has 117 coin motors</a:t>
+            </a:r>
+          </a:p>
+          <a:p>
+            <a:pPr marL="0" indent="0" algn="l">
+              <a:lnSpc>
+                <a:spcPct val="128000"/>
+              </a:lnSpc>
+              <a:spcAft>
+                <a:spcPts val="0"/>
+              </a:spcAft>
+              <a:buNone/>
+            </a:pPr>
+          </a:p>
+          <a:p>
+            <a:pPr marL="0" indent="0" algn="l">
+              <a:lnSpc>
+                <a:spcPct val="128000"/>
+              </a:lnSpc>
+              <a:spcAft>
+                <a:spcPts val="400"/>
+              </a:spcAft>
+              <a:buNone/>
+            </a:pPr>
+            <a:r>
+              <a:rPr sz="1700" b="1">
+                <a:solidFill>
+                  <a:srgbClr val="000000"/>
+                </a:solidFill>
+                <a:latin typeface="Arial"/>
+              </a:rPr>
+              <a:t>Today: decide it feels cheap, pick something else</a:t>
+            </a:r>
+          </a:p>
+          <a:p>
+            <a:pPr marL="0" indent="0" algn="l">
+              <a:lnSpc>
+                <a:spcPct val="128000"/>
+              </a:lnSpc>
+              <a:spcAft>
+                <a:spcPts val="400"/>
+              </a:spcAft>
+              <a:buNone/>
+            </a:pPr>
+            <a:r>
+              <a:rPr sz="1500" b="0">
+                <a:solidFill>
+                  <a:srgbClr val="000000"/>
+                </a:solidFill>
+                <a:latin typeface="Arial"/>
+              </a:rPr>
+              <a:t>• Better now than in week 46</a:t>
+            </a:r>
+          </a:p>
+        </p:txBody>
+      </p:sp>
+      <p:pic>
+        <p:nvPicPr>
+          <p:cNvPr id="4" name="Picture 3" descr="wordmark_dark.png"/>
+          <p:cNvPicPr>
+            <a:picLocks noChangeAspect="1"/>
+          </p:cNvPicPr>
+          <p:nvPr/>
+        </p:nvPicPr>
+        <p:blipFill>
+          <a:blip r:embed="rId2"/>
+          <a:stretch>
+            <a:fillRect/>
+          </a:stretch>
+        </p:blipFill>
+        <p:spPr>
+          <a:xfrm>
+            <a:off x="342900" y="6184900"/>
+            <a:ext cx="2070100" cy="529560"/>
+          </a:xfrm>
+          <a:prstGeom prst="rect">
+            <a:avLst/>
+          </a:prstGeom>
+        </p:spPr>
+      </p:pic>
+      <p:pic>
+        <p:nvPicPr>
+          <p:cNvPr id="5" name="Picture 4" descr="seal_dark.png"/>
+          <p:cNvPicPr>
+            <a:picLocks noChangeAspect="1"/>
+          </p:cNvPicPr>
+          <p:nvPr/>
+        </p:nvPicPr>
+        <p:blipFill>
+          <a:blip r:embed="rId3"/>
+          <a:stretch>
+            <a:fillRect/>
+          </a:stretch>
+        </p:blipFill>
+        <p:spPr>
+          <a:xfrm>
+            <a:off x="11226800" y="5969000"/>
+            <a:ext cx="713915" cy="711200"/>
+          </a:xfrm>
+          <a:prstGeom prst="rect">
+            <a:avLst/>
+          </a:prstGeom>
+        </p:spPr>
+      </p:pic>
+    </p:spTree>
+  </p:cSld>
+  <p:clrMapOvr>
+    <a:masterClrMapping/>
+  </p:clrMapOvr>
+</p:sld>
+</file>
+
 <file path=ppt/slides/slide4.xml><?xml version="1.0" encoding="utf-8"?>
 <p:sld xmlns:a="http://schemas.openxmlformats.org/drawingml/2006/main" xmlns:p="http://schemas.openxmlformats.org/presentationml/2006/main" xmlns:r="http://schemas.openxmlformats.org/officeDocument/2006/relationships">
   <p:cSld>
@@ -12621,7 +11238,7 @@
                 </a:solidFill>
                 <a:latin typeface="Arial"/>
               </a:rPr>
-              <a:t>Two or three stations each, getting harder</a:t>
+              <a:t>Four tasks, each one wire more than the last</a:t>
             </a:r>
           </a:p>
           <a:p>
@@ -12641,7 +11258,7 @@
                 </a:solidFill>
                 <a:latin typeface="Arial"/>
               </a:rPr>
-              <a:t>• Start with two wires. End with a transistor</a:t>
+              <a:t>• Piezo, then a touch pad, then both, then a stepper</a:t>
             </a:r>
           </a:p>
           <a:p>
@@ -12873,7 +11490,7 @@
                 </a:solidFill>
                 <a:latin typeface="Consolas"/>
               </a:rPr>
-              <a:t>0:10     10 min    Breadboards out. Piezo: two wires, everyone</a:t>
+              <a:t>0:10     15 min    Task 00: piezo. Two wires, everyone</a:t>
             </a:r>
           </a:p>
           <a:p>
@@ -12893,7 +11510,7 @@
                 </a:solidFill>
                 <a:latin typeface="Consolas"/>
               </a:rPr>
-              <a:t>0:20     20 min    Task 01: your first driver circuit, together</a:t>
+              <a:t>0:25     20 min    Task 04: one wire and foil. Watch the drift</a:t>
             </a:r>
           </a:p>
           <a:p>
@@ -12913,7 +11530,27 @@
                 </a:solidFill>
                 <a:latin typeface="Consolas"/>
               </a:rPr>
-              <a:t>0:40     45 min    Build on, at your own pace</a:t>
+              <a:t>0:45     20 min    Task 05: join them. Touch in, tick out</a:t>
+            </a:r>
+          </a:p>
+          <a:p>
+            <a:pPr marL="0" indent="0" algn="l">
+              <a:lnSpc>
+                <a:spcPct val="128000"/>
+              </a:lnSpc>
+              <a:spcAft>
+                <a:spcPts val="1200"/>
+              </a:spcAft>
+              <a:buNone/>
+            </a:pPr>
+            <a:r>
+              <a:rPr sz="1400" b="0">
+                <a:solidFill>
+                  <a:srgbClr val="000000"/>
+                </a:solidFill>
+                <a:latin typeface="Consolas"/>
+              </a:rPr>
+              <a:t>1:05     20 min    Task 07: stepper, if you want it</a:t>
             </a:r>
           </a:p>
           <a:p>
@@ -13125,7 +11762,7 @@
                 </a:solidFill>
                 <a:latin typeface="Arial"/>
               </a:rPr>
-              <a:t>00   Make it tick        piezo             2 wires</a:t>
+              <a:t>00   Make it tick        piezo              2 wires</a:t>
             </a:r>
           </a:p>
           <a:p>
@@ -13145,7 +11782,7 @@
                 </a:solidFill>
                 <a:latin typeface="Arial"/>
               </a:rPr>
-              <a:t>04   Make it notice you  wire and foil     1 wire</a:t>
+              <a:t>04   Make it notice you  a wire and foil    1 wire</a:t>
             </a:r>
           </a:p>
           <a:p>
@@ -13165,7 +11802,7 @@
                 </a:solidFill>
                 <a:latin typeface="Arial"/>
               </a:rPr>
-              <a:t>05   Make it answer      both of the above 3 wires</a:t>
+              <a:t>05   Make it answer      both of the above  3 wires</a:t>
             </a:r>
           </a:p>
           <a:p>
@@ -13174,6 +11811,26 @@
                 <a:spcPct val="128000"/>
               </a:lnSpc>
               <a:spcAft>
+                <a:spcPts val="400"/>
+              </a:spcAft>
+              <a:buNone/>
+            </a:pPr>
+            <a:r>
+              <a:rPr sz="1700" b="1">
+                <a:solidFill>
+                  <a:srgbClr val="000000"/>
+                </a:solidFill>
+                <a:latin typeface="Arial"/>
+              </a:rPr>
+              <a:t>07   Make it turn        stepper            6 wires</a:t>
+            </a:r>
+          </a:p>
+          <a:p>
+            <a:pPr marL="0" indent="0" algn="l">
+              <a:lnSpc>
+                <a:spcPct val="128000"/>
+              </a:lnSpc>
+              <a:spcAft>
                 <a:spcPts val="0"/>
               </a:spcAft>
               <a:buNone/>
@@ -13190,13 +11847,13 @@
               <a:buNone/>
             </a:pPr>
             <a:r>
-              <a:rPr sz="1700" b="1">
-                <a:solidFill>
-                  <a:srgbClr val="000000"/>
-                </a:solidFill>
-                <a:latin typeface="Arial"/>
-              </a:rPr>
-              <a:t>07   Make it turn       stepper           6 wires, a trap</a:t>
+              <a:rPr sz="1700" b="0">
+                <a:solidFill>
+                  <a:srgbClr val="000000"/>
+                </a:solidFill>
+                <a:latin typeface="Arial"/>
+              </a:rPr>
+              <a:t>Four tasks, and the first three need no driver at all.</a:t>
             </a:r>
           </a:p>
           <a:p>
@@ -13210,13 +11867,13 @@
               <a:buNone/>
             </a:pPr>
             <a:r>
-              <a:rPr sz="1700" b="1">
-                <a:solidFill>
-                  <a:srgbClr val="000000"/>
-                </a:solidFill>
-                <a:latin typeface="Arial"/>
-              </a:rPr>
-              <a:t>01   Make something spin coin motor        + transistor</a:t>
+              <a:rPr sz="1700" b="0">
+                <a:solidFill>
+                  <a:srgbClr val="000000"/>
+                </a:solidFill>
+                <a:latin typeface="Arial"/>
+              </a:rPr>
+              <a:t>Tasks 01 to 03 are in the repo if you want the motor,</a:t>
             </a:r>
           </a:p>
           <a:p>
@@ -13230,64 +11887,13 @@
               <a:buNone/>
             </a:pPr>
             <a:r>
-              <a:rPr sz="1700" b="1">
-                <a:solidFill>
-                  <a:srgbClr val="000000"/>
-                </a:solidFill>
-                <a:latin typeface="Arial"/>
-              </a:rPr>
-              <a:t>02   Make something tap  solenoid          + own supply</a:t>
-            </a:r>
-          </a:p>
-          <a:p>
-            <a:pPr marL="0" indent="0" algn="l">
-              <a:lnSpc>
-                <a:spcPct val="128000"/>
-              </a:lnSpc>
-              <a:spcAft>
-                <a:spcPts val="400"/>
-              </a:spcAft>
-              <a:buNone/>
-            </a:pPr>
-            <a:r>
-              <a:rPr sz="1700" b="1">
-                <a:solidFill>
-                  <a:srgbClr val="000000"/>
-                </a:solidFill>
-                <a:latin typeface="Arial"/>
-              </a:rPr>
-              <a:t>03   Make something warm Peltier tile      + H-bridge</a:t>
-            </a:r>
-          </a:p>
-          <a:p>
-            <a:pPr marL="0" indent="0" algn="l">
-              <a:lnSpc>
-                <a:spcPct val="128000"/>
-              </a:lnSpc>
-              <a:spcAft>
-                <a:spcPts val="0"/>
-              </a:spcAft>
-              <a:buNone/>
-            </a:pPr>
-          </a:p>
-          <a:p>
-            <a:pPr marL="0" indent="0" algn="l">
-              <a:lnSpc>
-                <a:spcPct val="128000"/>
-              </a:lnSpc>
-              <a:spcAft>
-                <a:spcPts val="400"/>
-              </a:spcAft>
-              <a:buNone/>
-            </a:pPr>
-            <a:r>
               <a:rPr sz="1700" b="0">
                 <a:solidFill>
                   <a:srgbClr val="000000"/>
                 </a:solidFill>
                 <a:latin typeface="Arial"/>
               </a:rPr>
-              <a:t>Two or three each. Nobody does all of them.</a:t>
+              <a:t>the solenoid or the Peltier tile. We will not do them today.</a:t>
             </a:r>
           </a:p>
         </p:txBody>

</xml_diff>